<commit_message>
Flatten project structure and add .gitignore
Add a .gitignore to exclude virtualenvs, caches, pyc, logs and notebook checkpoints; remove a nested Musbahu_Tijjani_P25EGCP8009_COEN807_Project folder by deleting duplicate/large artifacts (raw data, trained models, report PDF, results, some figures and data files). Several resources were relocated/renamed into top-level directories (assets, figures, notebooks, slides, src) and src/build_report.py was updated. This cleans up the repository layout, removes tracked build artifacts and datasets, and prevents env/cache files from being committed going forward.
</commit_message>
<xml_diff>
--- a/slides/COEN807_Project_Presentation.pptx
+++ b/slides/COEN807_Project_Presentation.pptx
@@ -2,26 +2,26 @@
 <file path=ppt/presentation.xml><?xml version="1.0" encoding="utf-8"?>
 <p:presentation xmlns:p="http://schemas.openxmlformats.org/presentationml/2006/main">
   <p:sldMasterIdLst>
-    <p:sldMasterId xmlns:r="http://schemas.openxmlformats.org/officeDocument/2006/relationships" id="2147483648" r:id="Rb6cb8cb7b4454730"/>
+    <p:sldMasterId xmlns:r="http://schemas.openxmlformats.org/officeDocument/2006/relationships" id="2147483648" r:id="Re14bfda8393e4f72"/>
   </p:sldMasterIdLst>
   <p:notesMasterIdLst>
-    <p:notesMasterId xmlns:r="http://schemas.openxmlformats.org/officeDocument/2006/relationships" r:id="R0c60d1b5a95e48f8"/>
+    <p:notesMasterId xmlns:r="http://schemas.openxmlformats.org/officeDocument/2006/relationships" r:id="R22ea6642113e4d2a"/>
   </p:notesMasterIdLst>
   <p:sldIdLst>
-    <p:sldId xmlns:r="http://schemas.openxmlformats.org/officeDocument/2006/relationships" id="256" r:id="Rb88b213b31124e87"/>
-    <p:sldId xmlns:r="http://schemas.openxmlformats.org/officeDocument/2006/relationships" id="257" r:id="R0177d9ec92de46ed"/>
-    <p:sldId xmlns:r="http://schemas.openxmlformats.org/officeDocument/2006/relationships" id="258" r:id="Ra049801a2fd542d6"/>
-    <p:sldId xmlns:r="http://schemas.openxmlformats.org/officeDocument/2006/relationships" id="259" r:id="R2e8d953928cc4323"/>
-    <p:sldId xmlns:r="http://schemas.openxmlformats.org/officeDocument/2006/relationships" id="260" r:id="R82b3912f68f94a40"/>
-    <p:sldId xmlns:r="http://schemas.openxmlformats.org/officeDocument/2006/relationships" id="261" r:id="R4dd6bb120c114681"/>
-    <p:sldId xmlns:r="http://schemas.openxmlformats.org/officeDocument/2006/relationships" id="262" r:id="R492866176c7b4d20"/>
-    <p:sldId xmlns:r="http://schemas.openxmlformats.org/officeDocument/2006/relationships" id="263" r:id="Rb76deea7ea1a40f6"/>
-    <p:sldId xmlns:r="http://schemas.openxmlformats.org/officeDocument/2006/relationships" id="264" r:id="R4f7b4f1fb6e84049"/>
-    <p:sldId xmlns:r="http://schemas.openxmlformats.org/officeDocument/2006/relationships" id="265" r:id="R73b4a79cb50c4dc2"/>
-    <p:sldId xmlns:r="http://schemas.openxmlformats.org/officeDocument/2006/relationships" id="266" r:id="R021b5ae8ade44903"/>
-    <p:sldId xmlns:r="http://schemas.openxmlformats.org/officeDocument/2006/relationships" id="267" r:id="Re45c3b2b0dac4cae"/>
-    <p:sldId xmlns:r="http://schemas.openxmlformats.org/officeDocument/2006/relationships" id="268" r:id="R3068cf46add5497a"/>
-    <p:sldId xmlns:r="http://schemas.openxmlformats.org/officeDocument/2006/relationships" id="269" r:id="Rac7c7578d8344710"/>
+    <p:sldId xmlns:r="http://schemas.openxmlformats.org/officeDocument/2006/relationships" id="256" r:id="R796196f210874976"/>
+    <p:sldId xmlns:r="http://schemas.openxmlformats.org/officeDocument/2006/relationships" id="257" r:id="Rc3992183b74b4d57"/>
+    <p:sldId xmlns:r="http://schemas.openxmlformats.org/officeDocument/2006/relationships" id="258" r:id="Re621e8cf76b548d2"/>
+    <p:sldId xmlns:r="http://schemas.openxmlformats.org/officeDocument/2006/relationships" id="259" r:id="R8ab43807005f4323"/>
+    <p:sldId xmlns:r="http://schemas.openxmlformats.org/officeDocument/2006/relationships" id="260" r:id="R94eef48e18da4a05"/>
+    <p:sldId xmlns:r="http://schemas.openxmlformats.org/officeDocument/2006/relationships" id="261" r:id="R6032a24ad2724e7f"/>
+    <p:sldId xmlns:r="http://schemas.openxmlformats.org/officeDocument/2006/relationships" id="262" r:id="R0bb0b1a5a0cd4363"/>
+    <p:sldId xmlns:r="http://schemas.openxmlformats.org/officeDocument/2006/relationships" id="263" r:id="R2de2420104bd4a2c"/>
+    <p:sldId xmlns:r="http://schemas.openxmlformats.org/officeDocument/2006/relationships" id="264" r:id="R395fc84c4ea143b1"/>
+    <p:sldId xmlns:r="http://schemas.openxmlformats.org/officeDocument/2006/relationships" id="265" r:id="Recce778acd124541"/>
+    <p:sldId xmlns:r="http://schemas.openxmlformats.org/officeDocument/2006/relationships" id="266" r:id="Rf31c950a03c44207"/>
+    <p:sldId xmlns:r="http://schemas.openxmlformats.org/officeDocument/2006/relationships" id="267" r:id="R846f3bc5aa974a89"/>
+    <p:sldId xmlns:r="http://schemas.openxmlformats.org/officeDocument/2006/relationships" id="268" r:id="R557b41b9e04040b1"/>
+    <p:sldId xmlns:r="http://schemas.openxmlformats.org/officeDocument/2006/relationships" id="269" r:id="R8ae558ccc253448c"/>
   </p:sldIdLst>
   <p:sldSz cx="12192000" cy="6858000"/>
   <p:notesSz cx="6858000" cy="9144000"/>
@@ -1472,7 +1472,7 @@
   </p:cSld>
   <p:clrMap bg1="lt1" tx1="dk1" bg2="lt2" tx2="dk2" accent1="accent1" accent2="accent2" accent3="accent3" accent4="accent4" accent5="accent5" accent6="accent6" hlink="hlink" folHlink="folHlink"/>
   <p:sldLayoutIdLst>
-    <p:sldLayoutId xmlns:r="http://schemas.openxmlformats.org/officeDocument/2006/relationships" id="2147483649" r:id="R344476445dac4df6"/>
+    <p:sldLayoutId xmlns:r="http://schemas.openxmlformats.org/officeDocument/2006/relationships" id="2147483649" r:id="Re7cc0923b5c04625"/>
   </p:sldLayoutIdLst>
   <p:txStyles>
     <p:titleStyle>
@@ -2023,7 +2023,7 @@
           <p:cNvPr id="1" name="">
             <a:extLst xmlns:a="http://schemas.openxmlformats.org/drawingml/2006/main">
               <a:ext uri="{FF2B5EF4-FFF2-40B4-BE49-F238E27FC236}">
-                <a16:creationId xmlns:a16="http://schemas.microsoft.com/office/drawing/2014/main" id="{DE1BC31A-253B-4F59-A91B-6ED66436D190}"/>
+                <a16:creationId xmlns:a16="http://schemas.microsoft.com/office/drawing/2014/main" id="{03235B3D-8D8E-42AC-B741-987F843A8C68}"/>
               </a:ext>
             </a:extLst>
           </p:cNvPr>
@@ -2054,7 +2054,7 @@
           <p:cNvPr id="2" name="">
             <a:extLst xmlns:a="http://schemas.openxmlformats.org/drawingml/2006/main">
               <a:ext uri="{FF2B5EF4-FFF2-40B4-BE49-F238E27FC236}">
-                <a16:creationId xmlns:a16="http://schemas.microsoft.com/office/drawing/2014/main" id="{FBF316AD-34F5-40AD-9788-8CF464596FC6}"/>
+                <a16:creationId xmlns:a16="http://schemas.microsoft.com/office/drawing/2014/main" id="{2CE507A9-3FE4-4AEF-BD05-6FBE187D0F1E}"/>
               </a:ext>
             </a:extLst>
           </p:cNvPr>
@@ -2085,7 +2085,7 @@
           <p:cNvPr id="3" name="">
             <a:extLst xmlns:a="http://schemas.openxmlformats.org/drawingml/2006/main">
               <a:ext uri="{FF2B5EF4-FFF2-40B4-BE49-F238E27FC236}">
-                <a16:creationId xmlns:a16="http://schemas.microsoft.com/office/drawing/2014/main" id="{D175DFAC-F905-45D9-8E72-D2EC55085F3A}"/>
+                <a16:creationId xmlns:a16="http://schemas.microsoft.com/office/drawing/2014/main" id="{E8E39BAC-D086-4076-8C7E-E3DABD328A38}"/>
               </a:ext>
             </a:extLst>
           </p:cNvPr>
@@ -2120,7 +2120,7 @@
           <p:nvPr/>
         </p:nvPicPr>
         <p:blipFill>
-          <a:blip xmlns:r="http://schemas.openxmlformats.org/officeDocument/2006/relationships" xmlns:a="http://schemas.openxmlformats.org/drawingml/2006/main" r:embed="R35538af013114371"/>
+          <a:blip xmlns:r="http://schemas.openxmlformats.org/officeDocument/2006/relationships" xmlns:a="http://schemas.openxmlformats.org/drawingml/2006/main" r:embed="R8cc5aeccdee54232"/>
           <a:stretch xmlns:a="http://schemas.openxmlformats.org/drawingml/2006/main"/>
         </p:blipFill>
         <p:spPr>
@@ -2142,7 +2142,7 @@
           <p:nvPr/>
         </p:nvPicPr>
         <p:blipFill>
-          <a:blip xmlns:r="http://schemas.openxmlformats.org/officeDocument/2006/relationships" xmlns:a="http://schemas.openxmlformats.org/drawingml/2006/main" r:embed="R97c4c3d49e954705"/>
+          <a:blip xmlns:r="http://schemas.openxmlformats.org/officeDocument/2006/relationships" xmlns:a="http://schemas.openxmlformats.org/drawingml/2006/main" r:embed="R8477c96c0b0b4dbe"/>
           <a:stretch xmlns:a="http://schemas.openxmlformats.org/drawingml/2006/main"/>
         </p:blipFill>
         <p:spPr>
@@ -2160,7 +2160,7 @@
           <p:cNvPr id="6" name="">
             <a:extLst xmlns:a="http://schemas.openxmlformats.org/drawingml/2006/main">
               <a:ext uri="{FF2B5EF4-FFF2-40B4-BE49-F238E27FC236}">
-                <a16:creationId xmlns:a16="http://schemas.microsoft.com/office/drawing/2014/main" id="{B23C6AE4-42AD-4ABD-815F-FBA7F3C9862C}"/>
+                <a16:creationId xmlns:a16="http://schemas.microsoft.com/office/drawing/2014/main" id="{CAB06CC6-29B8-4EE9-8544-13925509CBF3}"/>
               </a:ext>
             </a:extLst>
           </p:cNvPr>
@@ -2216,7 +2216,7 @@
           <p:cNvPr id="7" name="">
             <a:extLst xmlns:a="http://schemas.openxmlformats.org/drawingml/2006/main">
               <a:ext uri="{FF2B5EF4-FFF2-40B4-BE49-F238E27FC236}">
-                <a16:creationId xmlns:a16="http://schemas.microsoft.com/office/drawing/2014/main" id="{8CD7A7F2-285E-42C8-9563-82D15F5D670C}"/>
+                <a16:creationId xmlns:a16="http://schemas.microsoft.com/office/drawing/2014/main" id="{6D6C1440-87B5-4541-9E3D-001A28AF8AF5}"/>
               </a:ext>
             </a:extLst>
           </p:cNvPr>
@@ -2272,7 +2272,7 @@
           <p:cNvPr id="8" name="">
             <a:extLst xmlns:a="http://schemas.openxmlformats.org/drawingml/2006/main">
               <a:ext uri="{FF2B5EF4-FFF2-40B4-BE49-F238E27FC236}">
-                <a16:creationId xmlns:a16="http://schemas.microsoft.com/office/drawing/2014/main" id="{52ED75DB-5BC7-4B64-8AD4-5F256B647218}"/>
+                <a16:creationId xmlns:a16="http://schemas.microsoft.com/office/drawing/2014/main" id="{06963F8F-AA55-4406-88BD-0002EDB6B6A6}"/>
               </a:ext>
             </a:extLst>
           </p:cNvPr>
@@ -2328,7 +2328,7 @@
           <p:cNvPr id="9" name="">
             <a:extLst xmlns:a="http://schemas.openxmlformats.org/drawingml/2006/main">
               <a:ext uri="{FF2B5EF4-FFF2-40B4-BE49-F238E27FC236}">
-                <a16:creationId xmlns:a16="http://schemas.microsoft.com/office/drawing/2014/main" id="{62355AEA-6323-490E-A1DA-1DEDC697E930}"/>
+                <a16:creationId xmlns:a16="http://schemas.microsoft.com/office/drawing/2014/main" id="{8FF59F49-BFCF-4E2F-BB8B-D6D2EB69D8F1}"/>
               </a:ext>
             </a:extLst>
           </p:cNvPr>
@@ -2384,7 +2384,7 @@
           <p:cNvPr id="10" name="">
             <a:extLst xmlns:a="http://schemas.openxmlformats.org/drawingml/2006/main">
               <a:ext uri="{FF2B5EF4-FFF2-40B4-BE49-F238E27FC236}">
-                <a16:creationId xmlns:a16="http://schemas.microsoft.com/office/drawing/2014/main" id="{34A58E95-1A80-46C2-9EB1-154ADAC6FDFC}"/>
+                <a16:creationId xmlns:a16="http://schemas.microsoft.com/office/drawing/2014/main" id="{D9739926-8B4F-4334-A181-7F281B57D11F}"/>
               </a:ext>
             </a:extLst>
           </p:cNvPr>
@@ -2440,7 +2440,7 @@
           <p:cNvPr id="11" name="">
             <a:extLst xmlns:a="http://schemas.openxmlformats.org/drawingml/2006/main">
               <a:ext uri="{FF2B5EF4-FFF2-40B4-BE49-F238E27FC236}">
-                <a16:creationId xmlns:a16="http://schemas.microsoft.com/office/drawing/2014/main" id="{AF306742-A459-467B-BD77-A596781AB183}"/>
+                <a16:creationId xmlns:a16="http://schemas.microsoft.com/office/drawing/2014/main" id="{8D3F9794-E26F-48D1-9ED9-49B5330BD45A}"/>
               </a:ext>
             </a:extLst>
           </p:cNvPr>
@@ -2496,7 +2496,7 @@
           <p:cNvPr id="12" name="">
             <a:extLst xmlns:a="http://schemas.openxmlformats.org/drawingml/2006/main">
               <a:ext uri="{FF2B5EF4-FFF2-40B4-BE49-F238E27FC236}">
-                <a16:creationId xmlns:a16="http://schemas.microsoft.com/office/drawing/2014/main" id="{97FF4B1F-B173-4A78-B687-8C9F5678521B}"/>
+                <a16:creationId xmlns:a16="http://schemas.microsoft.com/office/drawing/2014/main" id="{D8B642F8-633E-434C-B0BC-05942D0EE6C3}"/>
               </a:ext>
             </a:extLst>
           </p:cNvPr>
@@ -2552,7 +2552,7 @@
           <p:cNvPr id="13" name="">
             <a:extLst xmlns:a="http://schemas.openxmlformats.org/drawingml/2006/main">
               <a:ext uri="{FF2B5EF4-FFF2-40B4-BE49-F238E27FC236}">
-                <a16:creationId xmlns:a16="http://schemas.microsoft.com/office/drawing/2014/main" id="{A004A846-9292-4CCD-9493-F8871426CA76}"/>
+                <a16:creationId xmlns:a16="http://schemas.microsoft.com/office/drawing/2014/main" id="{EB1EEEFC-5410-4AA8-8B57-F19B9FFA1C62}"/>
               </a:ext>
             </a:extLst>
           </p:cNvPr>
@@ -2631,7 +2631,7 @@
           <p:cNvPr id="14" name="">
             <a:extLst xmlns:a="http://schemas.openxmlformats.org/drawingml/2006/main">
               <a:ext uri="{FF2B5EF4-FFF2-40B4-BE49-F238E27FC236}">
-                <a16:creationId xmlns:a16="http://schemas.microsoft.com/office/drawing/2014/main" id="{0DD9EB05-71C5-4234-A3C8-EFBBE8BF5966}"/>
+                <a16:creationId xmlns:a16="http://schemas.microsoft.com/office/drawing/2014/main" id="{229B8E5D-B2B2-4D1D-B7BD-4657FA495D3D}"/>
               </a:ext>
             </a:extLst>
           </p:cNvPr>
@@ -2687,7 +2687,7 @@
           <p:cNvPr id="15" name="">
             <a:extLst xmlns:a="http://schemas.openxmlformats.org/drawingml/2006/main">
               <a:ext uri="{FF2B5EF4-FFF2-40B4-BE49-F238E27FC236}">
-                <a16:creationId xmlns:a16="http://schemas.microsoft.com/office/drawing/2014/main" id="{F6454053-E9D2-453D-89D9-6F6D7BFE31E3}"/>
+                <a16:creationId xmlns:a16="http://schemas.microsoft.com/office/drawing/2014/main" id="{F5C816C9-6AD9-4A95-85FA-E1171C1EF157}"/>
               </a:ext>
             </a:extLst>
           </p:cNvPr>
@@ -2720,7 +2720,7 @@
           <p:cNvPr id="16" name="">
             <a:extLst xmlns:a="http://schemas.openxmlformats.org/drawingml/2006/main">
               <a:ext uri="{FF2B5EF4-FFF2-40B4-BE49-F238E27FC236}">
-                <a16:creationId xmlns:a16="http://schemas.microsoft.com/office/drawing/2014/main" id="{D18D4C78-A336-46C9-B073-39BA827B26A7}"/>
+                <a16:creationId xmlns:a16="http://schemas.microsoft.com/office/drawing/2014/main" id="{6C7E501D-4F2B-4CD8-AF18-802D192D7EA6}"/>
               </a:ext>
             </a:extLst>
           </p:cNvPr>
@@ -2776,7 +2776,7 @@
           <p:cNvPr id="17" name="">
             <a:extLst xmlns:a="http://schemas.openxmlformats.org/drawingml/2006/main">
               <a:ext uri="{FF2B5EF4-FFF2-40B4-BE49-F238E27FC236}">
-                <a16:creationId xmlns:a16="http://schemas.microsoft.com/office/drawing/2014/main" id="{3D75830C-89D2-4230-9300-0B90F6B23CE2}"/>
+                <a16:creationId xmlns:a16="http://schemas.microsoft.com/office/drawing/2014/main" id="{6869B488-ED84-46BF-B1DF-00689B57A364}"/>
               </a:ext>
             </a:extLst>
           </p:cNvPr>
@@ -2832,7 +2832,7 @@
           <p:cNvPr id="18" name="">
             <a:extLst xmlns:a="http://schemas.openxmlformats.org/drawingml/2006/main">
               <a:ext uri="{FF2B5EF4-FFF2-40B4-BE49-F238E27FC236}">
-                <a16:creationId xmlns:a16="http://schemas.microsoft.com/office/drawing/2014/main" id="{356DDC3A-AA6C-47BD-AE61-341EAE39482F}"/>
+                <a16:creationId xmlns:a16="http://schemas.microsoft.com/office/drawing/2014/main" id="{61D59901-9462-4B76-A029-0C47D95F6987}"/>
               </a:ext>
             </a:extLst>
           </p:cNvPr>
@@ -2886,7 +2886,7 @@
     </p:spTree>
     <p:extLst>
       <p:ext uri="{BB962C8B-B14F-4D97-AF65-F5344CB8AC3E}">
-        <p14:creationId xmlns:p14="http://schemas.microsoft.com/office/powerpoint/2010/main" val="752697997"/>
+        <p14:creationId xmlns:p14="http://schemas.microsoft.com/office/powerpoint/2010/main" val="757541669"/>
       </p:ext>
     </p:extLst>
   </p:cSld>
@@ -2917,7 +2917,7 @@
           <p:cNvPr id="1" name="">
             <a:extLst xmlns:a="http://schemas.openxmlformats.org/drawingml/2006/main">
               <a:ext uri="{FF2B5EF4-FFF2-40B4-BE49-F238E27FC236}">
-                <a16:creationId xmlns:a16="http://schemas.microsoft.com/office/drawing/2014/main" id="{0BEC6B20-B4ED-41D0-96DF-3B003AB80D3F}"/>
+                <a16:creationId xmlns:a16="http://schemas.microsoft.com/office/drawing/2014/main" id="{E845041E-BFAD-4677-94B6-AFACB32BF5F6}"/>
               </a:ext>
             </a:extLst>
           </p:cNvPr>
@@ -2950,7 +2950,7 @@
           <p:cNvPr id="2" name="">
             <a:extLst xmlns:a="http://schemas.openxmlformats.org/drawingml/2006/main">
               <a:ext uri="{FF2B5EF4-FFF2-40B4-BE49-F238E27FC236}">
-                <a16:creationId xmlns:a16="http://schemas.microsoft.com/office/drawing/2014/main" id="{B964A747-2204-4C9F-B79E-AD6694375D4B}"/>
+                <a16:creationId xmlns:a16="http://schemas.microsoft.com/office/drawing/2014/main" id="{20B74ADD-A05D-4694-874F-BFCE4D2514A4}"/>
               </a:ext>
             </a:extLst>
           </p:cNvPr>
@@ -2983,7 +2983,7 @@
           <p:cNvPr id="3" name="">
             <a:extLst xmlns:a="http://schemas.openxmlformats.org/drawingml/2006/main">
               <a:ext uri="{FF2B5EF4-FFF2-40B4-BE49-F238E27FC236}">
-                <a16:creationId xmlns:a16="http://schemas.microsoft.com/office/drawing/2014/main" id="{2E45EA63-7E4E-4B9F-BAC7-872FC4D40B2E}"/>
+                <a16:creationId xmlns:a16="http://schemas.microsoft.com/office/drawing/2014/main" id="{A7C05D06-ED1E-449D-886B-B1DF5A798CA6}"/>
               </a:ext>
             </a:extLst>
           </p:cNvPr>
@@ -3039,7 +3039,7 @@
           <p:cNvPr id="4" name="">
             <a:extLst xmlns:a="http://schemas.openxmlformats.org/drawingml/2006/main">
               <a:ext uri="{FF2B5EF4-FFF2-40B4-BE49-F238E27FC236}">
-                <a16:creationId xmlns:a16="http://schemas.microsoft.com/office/drawing/2014/main" id="{63F0B5F0-C17D-4826-83F2-1982473F26C2}"/>
+                <a16:creationId xmlns:a16="http://schemas.microsoft.com/office/drawing/2014/main" id="{5F4468C2-F1CF-4475-A958-9218F0A8BFB6}"/>
               </a:ext>
             </a:extLst>
           </p:cNvPr>
@@ -3095,7 +3095,7 @@
           <p:cNvPr id="5" name="">
             <a:extLst xmlns:a="http://schemas.openxmlformats.org/drawingml/2006/main">
               <a:ext uri="{FF2B5EF4-FFF2-40B4-BE49-F238E27FC236}">
-                <a16:creationId xmlns:a16="http://schemas.microsoft.com/office/drawing/2014/main" id="{0BD0A62A-89A8-4799-947A-7CA486E5934E}"/>
+                <a16:creationId xmlns:a16="http://schemas.microsoft.com/office/drawing/2014/main" id="{1D436F8A-31BC-4D04-8A4D-488FA15FFD80}"/>
               </a:ext>
             </a:extLst>
           </p:cNvPr>
@@ -3151,7 +3151,7 @@
           <p:cNvPr id="6" name="">
             <a:extLst xmlns:a="http://schemas.openxmlformats.org/drawingml/2006/main">
               <a:ext uri="{FF2B5EF4-FFF2-40B4-BE49-F238E27FC236}">
-                <a16:creationId xmlns:a16="http://schemas.microsoft.com/office/drawing/2014/main" id="{51D1DCE7-2F5D-406B-90AE-176B37C95FAB}"/>
+                <a16:creationId xmlns:a16="http://schemas.microsoft.com/office/drawing/2014/main" id="{BD5B24ED-F7F4-41FA-B594-21C672B8FB27}"/>
               </a:ext>
             </a:extLst>
           </p:cNvPr>
@@ -3207,7 +3207,7 @@
           <p:cNvPr id="7" name="">
             <a:extLst xmlns:a="http://schemas.openxmlformats.org/drawingml/2006/main">
               <a:ext uri="{FF2B5EF4-FFF2-40B4-BE49-F238E27FC236}">
-                <a16:creationId xmlns:a16="http://schemas.microsoft.com/office/drawing/2014/main" id="{9C1C8C80-42AD-4015-A886-5EB1AA025592}"/>
+                <a16:creationId xmlns:a16="http://schemas.microsoft.com/office/drawing/2014/main" id="{02CA1E06-E4C5-4181-B45A-A713CCADFA9E}"/>
               </a:ext>
             </a:extLst>
           </p:cNvPr>
@@ -3240,7 +3240,7 @@
           <p:cNvPr id="8" name="">
             <a:extLst xmlns:a="http://schemas.openxmlformats.org/drawingml/2006/main">
               <a:ext uri="{FF2B5EF4-FFF2-40B4-BE49-F238E27FC236}">
-                <a16:creationId xmlns:a16="http://schemas.microsoft.com/office/drawing/2014/main" id="{3F3E3843-07CF-4A16-BDA4-EEE9C91A8CCF}"/>
+                <a16:creationId xmlns:a16="http://schemas.microsoft.com/office/drawing/2014/main" id="{291790E3-32AF-43F8-BA3B-A77F20047B5A}"/>
               </a:ext>
             </a:extLst>
           </p:cNvPr>
@@ -3277,7 +3277,7 @@
           <p:nvPr/>
         </p:nvPicPr>
         <p:blipFill>
-          <a:blip xmlns:r="http://schemas.openxmlformats.org/officeDocument/2006/relationships" xmlns:a="http://schemas.openxmlformats.org/drawingml/2006/main" r:embed="Rb612c137bd624a3b"/>
+          <a:blip xmlns:r="http://schemas.openxmlformats.org/officeDocument/2006/relationships" xmlns:a="http://schemas.openxmlformats.org/drawingml/2006/main" r:embed="Rd8c459d084ce4a47"/>
           <a:stretch xmlns:a="http://schemas.openxmlformats.org/drawingml/2006/main"/>
         </p:blipFill>
         <p:spPr>
@@ -3295,7 +3295,7 @@
           <p:cNvPr id="10" name="">
             <a:extLst xmlns:a="http://schemas.openxmlformats.org/drawingml/2006/main">
               <a:ext uri="{FF2B5EF4-FFF2-40B4-BE49-F238E27FC236}">
-                <a16:creationId xmlns:a16="http://schemas.microsoft.com/office/drawing/2014/main" id="{12FF5E85-EBD3-4172-BAD7-206FC983FD11}"/>
+                <a16:creationId xmlns:a16="http://schemas.microsoft.com/office/drawing/2014/main" id="{46CEAB77-A487-4CF0-9055-D7EC14C4EF25}"/>
               </a:ext>
             </a:extLst>
           </p:cNvPr>
@@ -3332,7 +3332,7 @@
           <p:nvPr/>
         </p:nvPicPr>
         <p:blipFill>
-          <a:blip xmlns:r="http://schemas.openxmlformats.org/officeDocument/2006/relationships" xmlns:a="http://schemas.openxmlformats.org/drawingml/2006/main" r:embed="Rc65dd2f41b2f42e6"/>
+          <a:blip xmlns:r="http://schemas.openxmlformats.org/officeDocument/2006/relationships" xmlns:a="http://schemas.openxmlformats.org/drawingml/2006/main" r:embed="R1de5bccca84f430a"/>
           <a:stretch xmlns:a="http://schemas.openxmlformats.org/drawingml/2006/main"/>
         </p:blipFill>
         <p:spPr>
@@ -3350,7 +3350,7 @@
           <p:cNvPr id="12" name="">
             <a:extLst xmlns:a="http://schemas.openxmlformats.org/drawingml/2006/main">
               <a:ext uri="{FF2B5EF4-FFF2-40B4-BE49-F238E27FC236}">
-                <a16:creationId xmlns:a16="http://schemas.microsoft.com/office/drawing/2014/main" id="{C72206B0-6487-4D01-BD14-4F103547CFF2}"/>
+                <a16:creationId xmlns:a16="http://schemas.microsoft.com/office/drawing/2014/main" id="{0A1CEFEC-FC2D-4E36-87C2-EA9C31630824}"/>
               </a:ext>
             </a:extLst>
           </p:cNvPr>
@@ -3383,7 +3383,7 @@
           <p:cNvPr id="13" name="">
             <a:extLst xmlns:a="http://schemas.openxmlformats.org/drawingml/2006/main">
               <a:ext uri="{FF2B5EF4-FFF2-40B4-BE49-F238E27FC236}">
-                <a16:creationId xmlns:a16="http://schemas.microsoft.com/office/drawing/2014/main" id="{FB9F003E-0642-4E48-BDB2-D51D264D4E42}"/>
+                <a16:creationId xmlns:a16="http://schemas.microsoft.com/office/drawing/2014/main" id="{D2E4E288-996E-4906-9A98-3C141C223175}"/>
               </a:ext>
             </a:extLst>
           </p:cNvPr>
@@ -3416,7 +3416,7 @@
           <p:cNvPr id="14" name="">
             <a:extLst xmlns:a="http://schemas.openxmlformats.org/drawingml/2006/main">
               <a:ext uri="{FF2B5EF4-FFF2-40B4-BE49-F238E27FC236}">
-                <a16:creationId xmlns:a16="http://schemas.microsoft.com/office/drawing/2014/main" id="{FE3421F4-A6FF-4DEC-A8EF-217FAA122DF6}"/>
+                <a16:creationId xmlns:a16="http://schemas.microsoft.com/office/drawing/2014/main" id="{FAEA6B39-1216-4117-8747-EBFB63965D0E}"/>
               </a:ext>
             </a:extLst>
           </p:cNvPr>
@@ -3472,7 +3472,7 @@
           <p:cNvPr id="15" name="">
             <a:extLst xmlns:a="http://schemas.openxmlformats.org/drawingml/2006/main">
               <a:ext uri="{FF2B5EF4-FFF2-40B4-BE49-F238E27FC236}">
-                <a16:creationId xmlns:a16="http://schemas.microsoft.com/office/drawing/2014/main" id="{A9BA8052-CEE8-4B78-9C27-DDFE987DC191}"/>
+                <a16:creationId xmlns:a16="http://schemas.microsoft.com/office/drawing/2014/main" id="{9F5F93A3-5490-406D-A82F-DDAD745B88BD}"/>
               </a:ext>
             </a:extLst>
           </p:cNvPr>
@@ -3528,7 +3528,7 @@
           <p:cNvPr id="16" name="">
             <a:extLst xmlns:a="http://schemas.openxmlformats.org/drawingml/2006/main">
               <a:ext uri="{FF2B5EF4-FFF2-40B4-BE49-F238E27FC236}">
-                <a16:creationId xmlns:a16="http://schemas.microsoft.com/office/drawing/2014/main" id="{C36DDA5F-54E5-4A81-9E09-27B07D7F85D0}"/>
+                <a16:creationId xmlns:a16="http://schemas.microsoft.com/office/drawing/2014/main" id="{FFA0B34A-81FD-49EF-A863-F647E85CB0A4}"/>
               </a:ext>
             </a:extLst>
           </p:cNvPr>
@@ -3582,7 +3582,7 @@
     </p:spTree>
     <p:extLst>
       <p:ext uri="{BB962C8B-B14F-4D97-AF65-F5344CB8AC3E}">
-        <p14:creationId xmlns:p14="http://schemas.microsoft.com/office/powerpoint/2010/main" val="439160612"/>
+        <p14:creationId xmlns:p14="http://schemas.microsoft.com/office/powerpoint/2010/main" val="260641000"/>
       </p:ext>
     </p:extLst>
   </p:cSld>
@@ -3613,7 +3613,7 @@
           <p:cNvPr id="1" name="">
             <a:extLst xmlns:a="http://schemas.openxmlformats.org/drawingml/2006/main">
               <a:ext uri="{FF2B5EF4-FFF2-40B4-BE49-F238E27FC236}">
-                <a16:creationId xmlns:a16="http://schemas.microsoft.com/office/drawing/2014/main" id="{AE131FFA-76E4-45A2-8BE2-5F7F9BA79D38}"/>
+                <a16:creationId xmlns:a16="http://schemas.microsoft.com/office/drawing/2014/main" id="{A80F3169-953C-46A5-932D-455CCDCB5E82}"/>
               </a:ext>
             </a:extLst>
           </p:cNvPr>
@@ -3646,7 +3646,7 @@
           <p:cNvPr id="2" name="">
             <a:extLst xmlns:a="http://schemas.openxmlformats.org/drawingml/2006/main">
               <a:ext uri="{FF2B5EF4-FFF2-40B4-BE49-F238E27FC236}">
-                <a16:creationId xmlns:a16="http://schemas.microsoft.com/office/drawing/2014/main" id="{8A11608D-A152-4882-931B-A663BD3BBF0A}"/>
+                <a16:creationId xmlns:a16="http://schemas.microsoft.com/office/drawing/2014/main" id="{EC1FAC93-8328-444E-9FFA-CE14D767D7EB}"/>
               </a:ext>
             </a:extLst>
           </p:cNvPr>
@@ -3679,7 +3679,7 @@
           <p:cNvPr id="3" name="">
             <a:extLst xmlns:a="http://schemas.openxmlformats.org/drawingml/2006/main">
               <a:ext uri="{FF2B5EF4-FFF2-40B4-BE49-F238E27FC236}">
-                <a16:creationId xmlns:a16="http://schemas.microsoft.com/office/drawing/2014/main" id="{D109C6AD-AD81-4B5F-BBC8-919FEE96F22D}"/>
+                <a16:creationId xmlns:a16="http://schemas.microsoft.com/office/drawing/2014/main" id="{68739FFA-9F03-44AA-9E39-61968EFE83A3}"/>
               </a:ext>
             </a:extLst>
           </p:cNvPr>
@@ -3735,7 +3735,7 @@
           <p:cNvPr id="4" name="">
             <a:extLst xmlns:a="http://schemas.openxmlformats.org/drawingml/2006/main">
               <a:ext uri="{FF2B5EF4-FFF2-40B4-BE49-F238E27FC236}">
-                <a16:creationId xmlns:a16="http://schemas.microsoft.com/office/drawing/2014/main" id="{AC972B4B-A1DC-4064-B797-51BF1348F69D}"/>
+                <a16:creationId xmlns:a16="http://schemas.microsoft.com/office/drawing/2014/main" id="{A38D35CA-6532-43CF-BC2B-A06A8B899202}"/>
               </a:ext>
             </a:extLst>
           </p:cNvPr>
@@ -3791,7 +3791,7 @@
           <p:cNvPr id="5" name="">
             <a:extLst xmlns:a="http://schemas.openxmlformats.org/drawingml/2006/main">
               <a:ext uri="{FF2B5EF4-FFF2-40B4-BE49-F238E27FC236}">
-                <a16:creationId xmlns:a16="http://schemas.microsoft.com/office/drawing/2014/main" id="{765C4329-FC46-4095-A5F7-32F3F7F89644}"/>
+                <a16:creationId xmlns:a16="http://schemas.microsoft.com/office/drawing/2014/main" id="{8D05AFBC-AED2-4432-8DB0-6CB9E819B9D8}"/>
               </a:ext>
             </a:extLst>
           </p:cNvPr>
@@ -3847,7 +3847,7 @@
           <p:cNvPr id="6" name="">
             <a:extLst xmlns:a="http://schemas.openxmlformats.org/drawingml/2006/main">
               <a:ext uri="{FF2B5EF4-FFF2-40B4-BE49-F238E27FC236}">
-                <a16:creationId xmlns:a16="http://schemas.microsoft.com/office/drawing/2014/main" id="{C7AE1664-F418-4159-BA22-C4D8693D42F2}"/>
+                <a16:creationId xmlns:a16="http://schemas.microsoft.com/office/drawing/2014/main" id="{8078FE32-65E1-4319-B334-43CF3C5FEF44}"/>
               </a:ext>
             </a:extLst>
           </p:cNvPr>
@@ -3903,7 +3903,7 @@
           <p:cNvPr id="7" name="">
             <a:extLst xmlns:a="http://schemas.openxmlformats.org/drawingml/2006/main">
               <a:ext uri="{FF2B5EF4-FFF2-40B4-BE49-F238E27FC236}">
-                <a16:creationId xmlns:a16="http://schemas.microsoft.com/office/drawing/2014/main" id="{750A28A4-75E2-4F35-A3B9-4C8316E82639}"/>
+                <a16:creationId xmlns:a16="http://schemas.microsoft.com/office/drawing/2014/main" id="{577BE0BD-47DA-42CD-A88A-8411D16E946D}"/>
               </a:ext>
             </a:extLst>
           </p:cNvPr>
@@ -3936,7 +3936,7 @@
           <p:cNvPr id="8" name="">
             <a:extLst xmlns:a="http://schemas.openxmlformats.org/drawingml/2006/main">
               <a:ext uri="{FF2B5EF4-FFF2-40B4-BE49-F238E27FC236}">
-                <a16:creationId xmlns:a16="http://schemas.microsoft.com/office/drawing/2014/main" id="{53136DCE-5A6E-49AA-BC4A-65B4E4E3AC39}"/>
+                <a16:creationId xmlns:a16="http://schemas.microsoft.com/office/drawing/2014/main" id="{7BEA9812-3E96-4FE5-A9F5-23652A7F72C0}"/>
               </a:ext>
             </a:extLst>
           </p:cNvPr>
@@ -3969,7 +3969,7 @@
           <p:cNvPr id="9" name="">
             <a:extLst xmlns:a="http://schemas.openxmlformats.org/drawingml/2006/main">
               <a:ext uri="{FF2B5EF4-FFF2-40B4-BE49-F238E27FC236}">
-                <a16:creationId xmlns:a16="http://schemas.microsoft.com/office/drawing/2014/main" id="{D626DE32-5540-4B53-8A1F-4D69E0E49CBE}"/>
+                <a16:creationId xmlns:a16="http://schemas.microsoft.com/office/drawing/2014/main" id="{FB58CFBA-FB23-42B7-B91B-2C91E920DB02}"/>
               </a:ext>
             </a:extLst>
           </p:cNvPr>
@@ -4025,7 +4025,7 @@
           <p:cNvPr id="10" name="">
             <a:extLst xmlns:a="http://schemas.openxmlformats.org/drawingml/2006/main">
               <a:ext uri="{FF2B5EF4-FFF2-40B4-BE49-F238E27FC236}">
-                <a16:creationId xmlns:a16="http://schemas.microsoft.com/office/drawing/2014/main" id="{44DCFB5C-720E-4C9D-A26E-B098EDDF1E85}"/>
+                <a16:creationId xmlns:a16="http://schemas.microsoft.com/office/drawing/2014/main" id="{4B3ACBF8-329C-4C14-A33D-F3A99B779D20}"/>
               </a:ext>
             </a:extLst>
           </p:cNvPr>
@@ -4081,7 +4081,7 @@
           <p:cNvPr id="11" name="">
             <a:extLst xmlns:a="http://schemas.openxmlformats.org/drawingml/2006/main">
               <a:ext uri="{FF2B5EF4-FFF2-40B4-BE49-F238E27FC236}">
-                <a16:creationId xmlns:a16="http://schemas.microsoft.com/office/drawing/2014/main" id="{84B5C8C7-0E1A-49D8-B517-311FA545B553}"/>
+                <a16:creationId xmlns:a16="http://schemas.microsoft.com/office/drawing/2014/main" id="{23D7FBA7-F1BE-4DE1-8ABC-2056D5952A07}"/>
               </a:ext>
             </a:extLst>
           </p:cNvPr>
@@ -4114,7 +4114,7 @@
           <p:cNvPr id="12" name="">
             <a:extLst xmlns:a="http://schemas.openxmlformats.org/drawingml/2006/main">
               <a:ext uri="{FF2B5EF4-FFF2-40B4-BE49-F238E27FC236}">
-                <a16:creationId xmlns:a16="http://schemas.microsoft.com/office/drawing/2014/main" id="{FE42E1E3-E4FF-4A8E-9D6C-BA1A73BBAA7F}"/>
+                <a16:creationId xmlns:a16="http://schemas.microsoft.com/office/drawing/2014/main" id="{7201CBBC-187C-4DAF-80BD-B2D63872D17D}"/>
               </a:ext>
             </a:extLst>
           </p:cNvPr>
@@ -4170,7 +4170,7 @@
           <p:cNvPr id="13" name="">
             <a:extLst xmlns:a="http://schemas.openxmlformats.org/drawingml/2006/main">
               <a:ext uri="{FF2B5EF4-FFF2-40B4-BE49-F238E27FC236}">
-                <a16:creationId xmlns:a16="http://schemas.microsoft.com/office/drawing/2014/main" id="{D503FFD2-63E8-4E22-BBE9-7CF237A8ABF3}"/>
+                <a16:creationId xmlns:a16="http://schemas.microsoft.com/office/drawing/2014/main" id="{54517E34-77C9-4D09-ADF0-C2A28A7973A0}"/>
               </a:ext>
             </a:extLst>
           </p:cNvPr>
@@ -4226,7 +4226,7 @@
           <p:cNvPr id="14" name="">
             <a:extLst xmlns:a="http://schemas.openxmlformats.org/drawingml/2006/main">
               <a:ext uri="{FF2B5EF4-FFF2-40B4-BE49-F238E27FC236}">
-                <a16:creationId xmlns:a16="http://schemas.microsoft.com/office/drawing/2014/main" id="{D5A39402-2ADE-4329-B2CF-0DCF62F7F57B}"/>
+                <a16:creationId xmlns:a16="http://schemas.microsoft.com/office/drawing/2014/main" id="{5E35D33B-7F40-4043-9615-57EF60AD6BB4}"/>
               </a:ext>
             </a:extLst>
           </p:cNvPr>
@@ -4259,7 +4259,7 @@
           <p:cNvPr id="15" name="">
             <a:extLst xmlns:a="http://schemas.openxmlformats.org/drawingml/2006/main">
               <a:ext uri="{FF2B5EF4-FFF2-40B4-BE49-F238E27FC236}">
-                <a16:creationId xmlns:a16="http://schemas.microsoft.com/office/drawing/2014/main" id="{E9327BE4-0248-47B4-B5C2-FF60B691365D}"/>
+                <a16:creationId xmlns:a16="http://schemas.microsoft.com/office/drawing/2014/main" id="{F8814501-90A2-46ED-98B0-0AF54F627739}"/>
               </a:ext>
             </a:extLst>
           </p:cNvPr>
@@ -4315,7 +4315,7 @@
           <p:cNvPr id="16" name="">
             <a:extLst xmlns:a="http://schemas.openxmlformats.org/drawingml/2006/main">
               <a:ext uri="{FF2B5EF4-FFF2-40B4-BE49-F238E27FC236}">
-                <a16:creationId xmlns:a16="http://schemas.microsoft.com/office/drawing/2014/main" id="{F3D6BC4D-0E27-430E-8CC8-B8027C8A6FBA}"/>
+                <a16:creationId xmlns:a16="http://schemas.microsoft.com/office/drawing/2014/main" id="{D8C6F00A-A83C-4BF1-8E0D-30F72A230556}"/>
               </a:ext>
             </a:extLst>
           </p:cNvPr>
@@ -4371,7 +4371,7 @@
           <p:cNvPr id="17" name="">
             <a:extLst xmlns:a="http://schemas.openxmlformats.org/drawingml/2006/main">
               <a:ext uri="{FF2B5EF4-FFF2-40B4-BE49-F238E27FC236}">
-                <a16:creationId xmlns:a16="http://schemas.microsoft.com/office/drawing/2014/main" id="{9BEB291A-E7BF-47D0-A6C5-8FCF0C329F04}"/>
+                <a16:creationId xmlns:a16="http://schemas.microsoft.com/office/drawing/2014/main" id="{11D0ABE0-37B1-48DE-A183-CFE32179DBD6}"/>
               </a:ext>
             </a:extLst>
           </p:cNvPr>
@@ -4425,7 +4425,7 @@
     </p:spTree>
     <p:extLst>
       <p:ext uri="{BB962C8B-B14F-4D97-AF65-F5344CB8AC3E}">
-        <p14:creationId xmlns:p14="http://schemas.microsoft.com/office/powerpoint/2010/main" val="1366739504"/>
+        <p14:creationId xmlns:p14="http://schemas.microsoft.com/office/powerpoint/2010/main" val="1351170263"/>
       </p:ext>
     </p:extLst>
   </p:cSld>
@@ -4456,7 +4456,7 @@
           <p:cNvPr id="1" name="">
             <a:extLst xmlns:a="http://schemas.openxmlformats.org/drawingml/2006/main">
               <a:ext uri="{FF2B5EF4-FFF2-40B4-BE49-F238E27FC236}">
-                <a16:creationId xmlns:a16="http://schemas.microsoft.com/office/drawing/2014/main" id="{FA9A6C87-E986-4D4D-A310-30BD1D95CE27}"/>
+                <a16:creationId xmlns:a16="http://schemas.microsoft.com/office/drawing/2014/main" id="{56F1E23D-94DA-4A95-B277-D2818F204204}"/>
               </a:ext>
             </a:extLst>
           </p:cNvPr>
@@ -4489,7 +4489,7 @@
           <p:cNvPr id="2" name="">
             <a:extLst xmlns:a="http://schemas.openxmlformats.org/drawingml/2006/main">
               <a:ext uri="{FF2B5EF4-FFF2-40B4-BE49-F238E27FC236}">
-                <a16:creationId xmlns:a16="http://schemas.microsoft.com/office/drawing/2014/main" id="{C78453E3-2CC8-4E8A-8894-23262806A334}"/>
+                <a16:creationId xmlns:a16="http://schemas.microsoft.com/office/drawing/2014/main" id="{9C26C0E7-C1F5-44F8-B5E5-35686CE8A831}"/>
               </a:ext>
             </a:extLst>
           </p:cNvPr>
@@ -4522,7 +4522,7 @@
           <p:cNvPr id="3" name="">
             <a:extLst xmlns:a="http://schemas.openxmlformats.org/drawingml/2006/main">
               <a:ext uri="{FF2B5EF4-FFF2-40B4-BE49-F238E27FC236}">
-                <a16:creationId xmlns:a16="http://schemas.microsoft.com/office/drawing/2014/main" id="{6D26D526-6B42-4816-B3DA-561BD584CED8}"/>
+                <a16:creationId xmlns:a16="http://schemas.microsoft.com/office/drawing/2014/main" id="{82BEA435-D587-43E6-A95C-FF9F27D15B6E}"/>
               </a:ext>
             </a:extLst>
           </p:cNvPr>
@@ -4578,7 +4578,7 @@
           <p:cNvPr id="4" name="">
             <a:extLst xmlns:a="http://schemas.openxmlformats.org/drawingml/2006/main">
               <a:ext uri="{FF2B5EF4-FFF2-40B4-BE49-F238E27FC236}">
-                <a16:creationId xmlns:a16="http://schemas.microsoft.com/office/drawing/2014/main" id="{E9044B47-A9A9-446E-82A7-B2E55BBF8086}"/>
+                <a16:creationId xmlns:a16="http://schemas.microsoft.com/office/drawing/2014/main" id="{BF5FAEBC-CC73-42A9-A345-876BE94E6FB2}"/>
               </a:ext>
             </a:extLst>
           </p:cNvPr>
@@ -4634,7 +4634,7 @@
           <p:cNvPr id="5" name="">
             <a:extLst xmlns:a="http://schemas.openxmlformats.org/drawingml/2006/main">
               <a:ext uri="{FF2B5EF4-FFF2-40B4-BE49-F238E27FC236}">
-                <a16:creationId xmlns:a16="http://schemas.microsoft.com/office/drawing/2014/main" id="{EC1E96B7-A716-4406-A587-B3FAC21A7FBA}"/>
+                <a16:creationId xmlns:a16="http://schemas.microsoft.com/office/drawing/2014/main" id="{927F79E4-6BC5-4208-A925-BDB3E0B98AD7}"/>
               </a:ext>
             </a:extLst>
           </p:cNvPr>
@@ -4690,7 +4690,7 @@
           <p:cNvPr id="6" name="">
             <a:extLst xmlns:a="http://schemas.openxmlformats.org/drawingml/2006/main">
               <a:ext uri="{FF2B5EF4-FFF2-40B4-BE49-F238E27FC236}">
-                <a16:creationId xmlns:a16="http://schemas.microsoft.com/office/drawing/2014/main" id="{E31B6593-935C-41E7-A5D3-508D81C3AAE1}"/>
+                <a16:creationId xmlns:a16="http://schemas.microsoft.com/office/drawing/2014/main" id="{A6AB2AAF-7457-4620-862B-FEFB273A85B3}"/>
               </a:ext>
             </a:extLst>
           </p:cNvPr>
@@ -4746,7 +4746,7 @@
           <p:cNvPr id="7" name="">
             <a:extLst xmlns:a="http://schemas.openxmlformats.org/drawingml/2006/main">
               <a:ext uri="{FF2B5EF4-FFF2-40B4-BE49-F238E27FC236}">
-                <a16:creationId xmlns:a16="http://schemas.microsoft.com/office/drawing/2014/main" id="{01704E0E-FCD3-47DB-8EDE-16695CC88839}"/>
+                <a16:creationId xmlns:a16="http://schemas.microsoft.com/office/drawing/2014/main" id="{83F3A603-1BF9-42ED-AB0D-BAEBAD434DE7}"/>
               </a:ext>
             </a:extLst>
           </p:cNvPr>
@@ -4779,7 +4779,7 @@
           <p:cNvPr id="8" name="">
             <a:extLst xmlns:a="http://schemas.openxmlformats.org/drawingml/2006/main">
               <a:ext uri="{FF2B5EF4-FFF2-40B4-BE49-F238E27FC236}">
-                <a16:creationId xmlns:a16="http://schemas.microsoft.com/office/drawing/2014/main" id="{B04644FA-5CF6-414B-B456-158B437A64CD}"/>
+                <a16:creationId xmlns:a16="http://schemas.microsoft.com/office/drawing/2014/main" id="{26AB956F-AE35-42F5-BABA-63A139D95EA9}"/>
               </a:ext>
             </a:extLst>
           </p:cNvPr>
@@ -4812,7 +4812,7 @@
           <p:cNvPr id="9" name="">
             <a:extLst xmlns:a="http://schemas.openxmlformats.org/drawingml/2006/main">
               <a:ext uri="{FF2B5EF4-FFF2-40B4-BE49-F238E27FC236}">
-                <a16:creationId xmlns:a16="http://schemas.microsoft.com/office/drawing/2014/main" id="{8ED2D673-530A-4AC3-9C66-1B8C53581A67}"/>
+                <a16:creationId xmlns:a16="http://schemas.microsoft.com/office/drawing/2014/main" id="{F517E9B4-4B42-48C4-8CB8-1EC2854974D5}"/>
               </a:ext>
             </a:extLst>
           </p:cNvPr>
@@ -4845,7 +4845,7 @@
           <p:cNvPr id="10" name="">
             <a:extLst xmlns:a="http://schemas.openxmlformats.org/drawingml/2006/main">
               <a:ext uri="{FF2B5EF4-FFF2-40B4-BE49-F238E27FC236}">
-                <a16:creationId xmlns:a16="http://schemas.microsoft.com/office/drawing/2014/main" id="{55E4D8EC-5D52-4D4A-8B5A-D32C7A5AD697}"/>
+                <a16:creationId xmlns:a16="http://schemas.microsoft.com/office/drawing/2014/main" id="{D62490C4-4935-49F5-A5AD-665BB9A10315}"/>
               </a:ext>
             </a:extLst>
           </p:cNvPr>
@@ -4901,7 +4901,7 @@
           <p:cNvPr id="11" name="">
             <a:extLst xmlns:a="http://schemas.openxmlformats.org/drawingml/2006/main">
               <a:ext uri="{FF2B5EF4-FFF2-40B4-BE49-F238E27FC236}">
-                <a16:creationId xmlns:a16="http://schemas.microsoft.com/office/drawing/2014/main" id="{D1FCA171-EB67-4BFB-B3E6-EC90DD184997}"/>
+                <a16:creationId xmlns:a16="http://schemas.microsoft.com/office/drawing/2014/main" id="{53F4DB25-4032-4993-A617-CCCB1AE854EE}"/>
               </a:ext>
             </a:extLst>
           </p:cNvPr>
@@ -4957,7 +4957,7 @@
           <p:cNvPr id="12" name="">
             <a:extLst xmlns:a="http://schemas.openxmlformats.org/drawingml/2006/main">
               <a:ext uri="{FF2B5EF4-FFF2-40B4-BE49-F238E27FC236}">
-                <a16:creationId xmlns:a16="http://schemas.microsoft.com/office/drawing/2014/main" id="{30F46263-89ED-4289-9350-3E027DCCECEE}"/>
+                <a16:creationId xmlns:a16="http://schemas.microsoft.com/office/drawing/2014/main" id="{DCADB163-0404-47FE-A037-4EF942216A73}"/>
               </a:ext>
             </a:extLst>
           </p:cNvPr>
@@ -4990,7 +4990,7 @@
           <p:cNvPr id="13" name="">
             <a:extLst xmlns:a="http://schemas.openxmlformats.org/drawingml/2006/main">
               <a:ext uri="{FF2B5EF4-FFF2-40B4-BE49-F238E27FC236}">
-                <a16:creationId xmlns:a16="http://schemas.microsoft.com/office/drawing/2014/main" id="{9A19D460-E41B-4220-8A2D-510CEC6FCDF7}"/>
+                <a16:creationId xmlns:a16="http://schemas.microsoft.com/office/drawing/2014/main" id="{B2F51EBE-2987-444A-948D-60246298E778}"/>
               </a:ext>
             </a:extLst>
           </p:cNvPr>
@@ -5023,7 +5023,7 @@
           <p:cNvPr id="14" name="">
             <a:extLst xmlns:a="http://schemas.openxmlformats.org/drawingml/2006/main">
               <a:ext uri="{FF2B5EF4-FFF2-40B4-BE49-F238E27FC236}">
-                <a16:creationId xmlns:a16="http://schemas.microsoft.com/office/drawing/2014/main" id="{18AB7F23-1647-4BCF-9286-01C795B4ADE3}"/>
+                <a16:creationId xmlns:a16="http://schemas.microsoft.com/office/drawing/2014/main" id="{1BD34C6A-4E16-41F0-BF81-FA0C5FCAAF4F}"/>
               </a:ext>
             </a:extLst>
           </p:cNvPr>
@@ -5079,7 +5079,7 @@
           <p:cNvPr id="15" name="">
             <a:extLst xmlns:a="http://schemas.openxmlformats.org/drawingml/2006/main">
               <a:ext uri="{FF2B5EF4-FFF2-40B4-BE49-F238E27FC236}">
-                <a16:creationId xmlns:a16="http://schemas.microsoft.com/office/drawing/2014/main" id="{6AD0F687-8D4D-4A15-AD36-1EA76FB45AE3}"/>
+                <a16:creationId xmlns:a16="http://schemas.microsoft.com/office/drawing/2014/main" id="{357BCB14-C1F5-44FB-AC2B-56C896466B12}"/>
               </a:ext>
             </a:extLst>
           </p:cNvPr>
@@ -5135,7 +5135,7 @@
           <p:cNvPr id="16" name="">
             <a:extLst xmlns:a="http://schemas.openxmlformats.org/drawingml/2006/main">
               <a:ext uri="{FF2B5EF4-FFF2-40B4-BE49-F238E27FC236}">
-                <a16:creationId xmlns:a16="http://schemas.microsoft.com/office/drawing/2014/main" id="{5A16BFCF-A82E-499F-882C-8B4C2714ACBA}"/>
+                <a16:creationId xmlns:a16="http://schemas.microsoft.com/office/drawing/2014/main" id="{C1FC181B-00AB-4D94-ABA8-CBC37AE3BC8A}"/>
               </a:ext>
             </a:extLst>
           </p:cNvPr>
@@ -5168,7 +5168,7 @@
           <p:cNvPr id="17" name="">
             <a:extLst xmlns:a="http://schemas.openxmlformats.org/drawingml/2006/main">
               <a:ext uri="{FF2B5EF4-FFF2-40B4-BE49-F238E27FC236}">
-                <a16:creationId xmlns:a16="http://schemas.microsoft.com/office/drawing/2014/main" id="{AA0A4644-F32E-4EE1-BC87-A7F713914363}"/>
+                <a16:creationId xmlns:a16="http://schemas.microsoft.com/office/drawing/2014/main" id="{11113E6A-4DAC-409D-8698-E1B13EBA5DF8}"/>
               </a:ext>
             </a:extLst>
           </p:cNvPr>
@@ -5201,7 +5201,7 @@
           <p:cNvPr id="18" name="">
             <a:extLst xmlns:a="http://schemas.openxmlformats.org/drawingml/2006/main">
               <a:ext uri="{FF2B5EF4-FFF2-40B4-BE49-F238E27FC236}">
-                <a16:creationId xmlns:a16="http://schemas.microsoft.com/office/drawing/2014/main" id="{B1E9A7F4-A59B-45BE-BE7B-4265642A2578}"/>
+                <a16:creationId xmlns:a16="http://schemas.microsoft.com/office/drawing/2014/main" id="{ECAF040D-1A0B-425B-A4CE-C30D0F790F21}"/>
               </a:ext>
             </a:extLst>
           </p:cNvPr>
@@ -5257,7 +5257,7 @@
           <p:cNvPr id="19" name="">
             <a:extLst xmlns:a="http://schemas.openxmlformats.org/drawingml/2006/main">
               <a:ext uri="{FF2B5EF4-FFF2-40B4-BE49-F238E27FC236}">
-                <a16:creationId xmlns:a16="http://schemas.microsoft.com/office/drawing/2014/main" id="{8D331EEF-1D43-435A-9A41-CFE02549DC94}"/>
+                <a16:creationId xmlns:a16="http://schemas.microsoft.com/office/drawing/2014/main" id="{3D5AF77A-6793-4E3F-90E0-4201978B3E63}"/>
               </a:ext>
             </a:extLst>
           </p:cNvPr>
@@ -5313,7 +5313,7 @@
           <p:cNvPr id="20" name="">
             <a:extLst xmlns:a="http://schemas.openxmlformats.org/drawingml/2006/main">
               <a:ext uri="{FF2B5EF4-FFF2-40B4-BE49-F238E27FC236}">
-                <a16:creationId xmlns:a16="http://schemas.microsoft.com/office/drawing/2014/main" id="{214AB2D2-D47E-450E-A3DD-77E7038F9F1A}"/>
+                <a16:creationId xmlns:a16="http://schemas.microsoft.com/office/drawing/2014/main" id="{03227985-1B2E-402B-B449-0B70F6086D77}"/>
               </a:ext>
             </a:extLst>
           </p:cNvPr>
@@ -5359,7 +5359,7 @@
                 <a:ea typeface="Aptos"/>
                 <a:cs typeface="Aptos"/>
               </a:rPr>
-              <a:t>Before deployment, validate the approach using local Nigerian educational data.</a:t>
+              <a:t>External validation should use independent Nigerian data and report confidence intervals.</a:t>
             </a:r>
           </a:p>
         </p:txBody>
@@ -5367,7 +5367,7 @@
     </p:spTree>
     <p:extLst>
       <p:ext uri="{BB962C8B-B14F-4D97-AF65-F5344CB8AC3E}">
-        <p14:creationId xmlns:p14="http://schemas.microsoft.com/office/powerpoint/2010/main" val="1462741560"/>
+        <p14:creationId xmlns:p14="http://schemas.microsoft.com/office/powerpoint/2010/main" val="488315267"/>
       </p:ext>
     </p:extLst>
   </p:cSld>
@@ -5398,7 +5398,7 @@
           <p:cNvPr id="1" name="">
             <a:extLst xmlns:a="http://schemas.openxmlformats.org/drawingml/2006/main">
               <a:ext uri="{FF2B5EF4-FFF2-40B4-BE49-F238E27FC236}">
-                <a16:creationId xmlns:a16="http://schemas.microsoft.com/office/drawing/2014/main" id="{04AB97C1-4CF2-448A-8841-D5F491FA22CB}"/>
+                <a16:creationId xmlns:a16="http://schemas.microsoft.com/office/drawing/2014/main" id="{2FC96414-C93B-4EE1-8860-7E5E70EE7A01}"/>
               </a:ext>
             </a:extLst>
           </p:cNvPr>
@@ -5431,7 +5431,7 @@
           <p:cNvPr id="2" name="">
             <a:extLst xmlns:a="http://schemas.openxmlformats.org/drawingml/2006/main">
               <a:ext uri="{FF2B5EF4-FFF2-40B4-BE49-F238E27FC236}">
-                <a16:creationId xmlns:a16="http://schemas.microsoft.com/office/drawing/2014/main" id="{FB7F8309-AA60-425E-916C-D28EE07E15C3}"/>
+                <a16:creationId xmlns:a16="http://schemas.microsoft.com/office/drawing/2014/main" id="{6AECA418-D7B4-4BF3-A731-244ABD2CA2FE}"/>
               </a:ext>
             </a:extLst>
           </p:cNvPr>
@@ -5464,7 +5464,7 @@
           <p:cNvPr id="3" name="">
             <a:extLst xmlns:a="http://schemas.openxmlformats.org/drawingml/2006/main">
               <a:ext uri="{FF2B5EF4-FFF2-40B4-BE49-F238E27FC236}">
-                <a16:creationId xmlns:a16="http://schemas.microsoft.com/office/drawing/2014/main" id="{C5DB8C08-FF98-4EFE-9DDB-A4D5B128938C}"/>
+                <a16:creationId xmlns:a16="http://schemas.microsoft.com/office/drawing/2014/main" id="{3BFAAF5B-A243-46E2-9D5A-24511E98DBD4}"/>
               </a:ext>
             </a:extLst>
           </p:cNvPr>
@@ -5520,7 +5520,7 @@
           <p:cNvPr id="4" name="">
             <a:extLst xmlns:a="http://schemas.openxmlformats.org/drawingml/2006/main">
               <a:ext uri="{FF2B5EF4-FFF2-40B4-BE49-F238E27FC236}">
-                <a16:creationId xmlns:a16="http://schemas.microsoft.com/office/drawing/2014/main" id="{C0AEF1A7-F184-4476-B273-93F79F9CBE88}"/>
+                <a16:creationId xmlns:a16="http://schemas.microsoft.com/office/drawing/2014/main" id="{A7A72BCF-8BC0-4B91-9766-D5C8E2D65709}"/>
               </a:ext>
             </a:extLst>
           </p:cNvPr>
@@ -5576,7 +5576,7 @@
           <p:cNvPr id="5" name="">
             <a:extLst xmlns:a="http://schemas.openxmlformats.org/drawingml/2006/main">
               <a:ext uri="{FF2B5EF4-FFF2-40B4-BE49-F238E27FC236}">
-                <a16:creationId xmlns:a16="http://schemas.microsoft.com/office/drawing/2014/main" id="{C6257828-97D9-4503-9EDA-88A334B3A0AE}"/>
+                <a16:creationId xmlns:a16="http://schemas.microsoft.com/office/drawing/2014/main" id="{FBCA8F36-677C-4C52-8F54-D57F0D0F1477}"/>
               </a:ext>
             </a:extLst>
           </p:cNvPr>
@@ -5632,7 +5632,7 @@
           <p:cNvPr id="6" name="">
             <a:extLst xmlns:a="http://schemas.openxmlformats.org/drawingml/2006/main">
               <a:ext uri="{FF2B5EF4-FFF2-40B4-BE49-F238E27FC236}">
-                <a16:creationId xmlns:a16="http://schemas.microsoft.com/office/drawing/2014/main" id="{CD600EE2-3D18-4C95-99F7-B234EC9EC93B}"/>
+                <a16:creationId xmlns:a16="http://schemas.microsoft.com/office/drawing/2014/main" id="{B44E7AF9-D79F-464C-BA85-324A0CAA8DBE}"/>
               </a:ext>
             </a:extLst>
           </p:cNvPr>
@@ -5688,7 +5688,7 @@
           <p:cNvPr id="7" name="">
             <a:extLst xmlns:a="http://schemas.openxmlformats.org/drawingml/2006/main">
               <a:ext uri="{FF2B5EF4-FFF2-40B4-BE49-F238E27FC236}">
-                <a16:creationId xmlns:a16="http://schemas.microsoft.com/office/drawing/2014/main" id="{600FBFED-ACE2-4964-AC45-D7022C257FD8}"/>
+                <a16:creationId xmlns:a16="http://schemas.microsoft.com/office/drawing/2014/main" id="{3B71DB29-946D-4AF2-9C14-3FC3CF8C5FDB}"/>
               </a:ext>
             </a:extLst>
           </p:cNvPr>
@@ -5721,7 +5721,7 @@
           <p:cNvPr id="8" name="">
             <a:extLst xmlns:a="http://schemas.openxmlformats.org/drawingml/2006/main">
               <a:ext uri="{FF2B5EF4-FFF2-40B4-BE49-F238E27FC236}">
-                <a16:creationId xmlns:a16="http://schemas.microsoft.com/office/drawing/2014/main" id="{8A871F8D-F59A-44F1-83AA-2FB5972DF684}"/>
+                <a16:creationId xmlns:a16="http://schemas.microsoft.com/office/drawing/2014/main" id="{9C219728-9057-4611-876D-6F384EC5C668}"/>
               </a:ext>
             </a:extLst>
           </p:cNvPr>
@@ -5754,7 +5754,7 @@
           <p:cNvPr id="9" name="">
             <a:extLst xmlns:a="http://schemas.openxmlformats.org/drawingml/2006/main">
               <a:ext uri="{FF2B5EF4-FFF2-40B4-BE49-F238E27FC236}">
-                <a16:creationId xmlns:a16="http://schemas.microsoft.com/office/drawing/2014/main" id="{D2F98C31-7C99-4037-9195-EDE1C69821AC}"/>
+                <a16:creationId xmlns:a16="http://schemas.microsoft.com/office/drawing/2014/main" id="{E5322E62-955C-4077-81DC-4706F676E74A}"/>
               </a:ext>
             </a:extLst>
           </p:cNvPr>
@@ -5810,7 +5810,7 @@
           <p:cNvPr id="10" name="">
             <a:extLst xmlns:a="http://schemas.openxmlformats.org/drawingml/2006/main">
               <a:ext uri="{FF2B5EF4-FFF2-40B4-BE49-F238E27FC236}">
-                <a16:creationId xmlns:a16="http://schemas.microsoft.com/office/drawing/2014/main" id="{AEC24EBE-9794-455D-A21A-568581035DD5}"/>
+                <a16:creationId xmlns:a16="http://schemas.microsoft.com/office/drawing/2014/main" id="{E2EAB14C-7944-4093-A99D-964D1357B976}"/>
               </a:ext>
             </a:extLst>
           </p:cNvPr>
@@ -5894,7 +5894,7 @@
           <p:cNvPr id="11" name="">
             <a:extLst xmlns:a="http://schemas.openxmlformats.org/drawingml/2006/main">
               <a:ext uri="{FF2B5EF4-FFF2-40B4-BE49-F238E27FC236}">
-                <a16:creationId xmlns:a16="http://schemas.microsoft.com/office/drawing/2014/main" id="{5BB0FE77-2A0D-489E-B842-91F250103D08}"/>
+                <a16:creationId xmlns:a16="http://schemas.microsoft.com/office/drawing/2014/main" id="{AF8E34AE-9027-499B-A67E-A79355FF3634}"/>
               </a:ext>
             </a:extLst>
           </p:cNvPr>
@@ -5927,7 +5927,7 @@
           <p:cNvPr id="12" name="">
             <a:extLst xmlns:a="http://schemas.openxmlformats.org/drawingml/2006/main">
               <a:ext uri="{FF2B5EF4-FFF2-40B4-BE49-F238E27FC236}">
-                <a16:creationId xmlns:a16="http://schemas.microsoft.com/office/drawing/2014/main" id="{5051A8CA-22A7-4D1D-A09E-0371F87458F6}"/>
+                <a16:creationId xmlns:a16="http://schemas.microsoft.com/office/drawing/2014/main" id="{8F482A03-F9B8-478C-8410-206FD47C7C83}"/>
               </a:ext>
             </a:extLst>
           </p:cNvPr>
@@ -5983,7 +5983,7 @@
           <p:cNvPr id="13" name="">
             <a:extLst xmlns:a="http://schemas.openxmlformats.org/drawingml/2006/main">
               <a:ext uri="{FF2B5EF4-FFF2-40B4-BE49-F238E27FC236}">
-                <a16:creationId xmlns:a16="http://schemas.microsoft.com/office/drawing/2014/main" id="{58DAAB50-5930-44C7-89D3-3D7F10D363B1}"/>
+                <a16:creationId xmlns:a16="http://schemas.microsoft.com/office/drawing/2014/main" id="{5F7C2685-36EB-4551-927D-B5A5A5D9968D}"/>
               </a:ext>
             </a:extLst>
           </p:cNvPr>
@@ -6108,7 +6108,7 @@
           <p:cNvPr id="14" name="">
             <a:extLst xmlns:a="http://schemas.openxmlformats.org/drawingml/2006/main">
               <a:ext uri="{FF2B5EF4-FFF2-40B4-BE49-F238E27FC236}">
-                <a16:creationId xmlns:a16="http://schemas.microsoft.com/office/drawing/2014/main" id="{1A9FB8CE-F29B-4878-B79B-D57CB10D32F8}"/>
+                <a16:creationId xmlns:a16="http://schemas.microsoft.com/office/drawing/2014/main" id="{C13202AF-8A92-43D5-BFDD-B1511F94E7EC}"/>
               </a:ext>
             </a:extLst>
           </p:cNvPr>
@@ -6141,7 +6141,7 @@
           <p:cNvPr id="15" name="">
             <a:extLst xmlns:a="http://schemas.openxmlformats.org/drawingml/2006/main">
               <a:ext uri="{FF2B5EF4-FFF2-40B4-BE49-F238E27FC236}">
-                <a16:creationId xmlns:a16="http://schemas.microsoft.com/office/drawing/2014/main" id="{F7B8F24E-49C5-47FB-A3EB-A87961F3132B}"/>
+                <a16:creationId xmlns:a16="http://schemas.microsoft.com/office/drawing/2014/main" id="{807D55F5-73A2-4C3F-8551-BFBF5FEAE343}"/>
               </a:ext>
             </a:extLst>
           </p:cNvPr>
@@ -6197,7 +6197,7 @@
           <p:cNvPr id="16" name="">
             <a:extLst xmlns:a="http://schemas.openxmlformats.org/drawingml/2006/main">
               <a:ext uri="{FF2B5EF4-FFF2-40B4-BE49-F238E27FC236}">
-                <a16:creationId xmlns:a16="http://schemas.microsoft.com/office/drawing/2014/main" id="{FB6A3034-F44D-43E9-B27D-C29D9D32C975}"/>
+                <a16:creationId xmlns:a16="http://schemas.microsoft.com/office/drawing/2014/main" id="{A8F486B8-EF88-43A1-8428-81D926BF0501}"/>
               </a:ext>
             </a:extLst>
           </p:cNvPr>
@@ -6345,7 +6345,7 @@
           <p:cNvPr id="17" name="">
             <a:extLst xmlns:a="http://schemas.openxmlformats.org/drawingml/2006/main">
               <a:ext uri="{FF2B5EF4-FFF2-40B4-BE49-F238E27FC236}">
-                <a16:creationId xmlns:a16="http://schemas.microsoft.com/office/drawing/2014/main" id="{AD5DA854-177B-4251-944C-C8E645269D28}"/>
+                <a16:creationId xmlns:a16="http://schemas.microsoft.com/office/drawing/2014/main" id="{2797D999-037D-4B55-A3F4-A78F87400E41}"/>
               </a:ext>
             </a:extLst>
           </p:cNvPr>
@@ -6399,7 +6399,7 @@
     </p:spTree>
     <p:extLst>
       <p:ext uri="{BB962C8B-B14F-4D97-AF65-F5344CB8AC3E}">
-        <p14:creationId xmlns:p14="http://schemas.microsoft.com/office/powerpoint/2010/main" val="2075948026"/>
+        <p14:creationId xmlns:p14="http://schemas.microsoft.com/office/powerpoint/2010/main" val="1206154516"/>
       </p:ext>
     </p:extLst>
   </p:cSld>
@@ -6430,7 +6430,7 @@
           <p:cNvPr id="1" name="">
             <a:extLst xmlns:a="http://schemas.openxmlformats.org/drawingml/2006/main">
               <a:ext uri="{FF2B5EF4-FFF2-40B4-BE49-F238E27FC236}">
-                <a16:creationId xmlns:a16="http://schemas.microsoft.com/office/drawing/2014/main" id="{C61DE4A7-6F8D-4C58-BA31-CBBDF6AD92E0}"/>
+                <a16:creationId xmlns:a16="http://schemas.microsoft.com/office/drawing/2014/main" id="{FE7E18E5-B2B9-46CD-8314-CDB670E6E50C}"/>
               </a:ext>
             </a:extLst>
           </p:cNvPr>
@@ -6486,7 +6486,7 @@
           <p:cNvPr id="2" name="">
             <a:extLst xmlns:a="http://schemas.openxmlformats.org/drawingml/2006/main">
               <a:ext uri="{FF2B5EF4-FFF2-40B4-BE49-F238E27FC236}">
-                <a16:creationId xmlns:a16="http://schemas.microsoft.com/office/drawing/2014/main" id="{A81B22A1-F4C7-4CE7-B42B-47569062ED99}"/>
+                <a16:creationId xmlns:a16="http://schemas.microsoft.com/office/drawing/2014/main" id="{24F47686-DD48-4179-AD1F-6F2191EE31FA}"/>
               </a:ext>
             </a:extLst>
           </p:cNvPr>
@@ -6542,7 +6542,7 @@
           <p:cNvPr id="3" name="">
             <a:extLst xmlns:a="http://schemas.openxmlformats.org/drawingml/2006/main">
               <a:ext uri="{FF2B5EF4-FFF2-40B4-BE49-F238E27FC236}">
-                <a16:creationId xmlns:a16="http://schemas.microsoft.com/office/drawing/2014/main" id="{3FFF7322-B911-4CED-A693-842731C54650}"/>
+                <a16:creationId xmlns:a16="http://schemas.microsoft.com/office/drawing/2014/main" id="{213C7D4D-CB46-4412-AB14-3B51D1E5C75B}"/>
               </a:ext>
             </a:extLst>
           </p:cNvPr>
@@ -6575,7 +6575,7 @@
           <p:cNvPr id="4" name="">
             <a:extLst xmlns:a="http://schemas.openxmlformats.org/drawingml/2006/main">
               <a:ext uri="{FF2B5EF4-FFF2-40B4-BE49-F238E27FC236}">
-                <a16:creationId xmlns:a16="http://schemas.microsoft.com/office/drawing/2014/main" id="{B96E3402-D332-4AA7-810D-E69AD7653269}"/>
+                <a16:creationId xmlns:a16="http://schemas.microsoft.com/office/drawing/2014/main" id="{ED940ECB-43F7-480E-A4B6-8CB1285DFAA0}"/>
               </a:ext>
             </a:extLst>
           </p:cNvPr>
@@ -6631,7 +6631,7 @@
           <p:cNvPr id="5" name="">
             <a:extLst xmlns:a="http://schemas.openxmlformats.org/drawingml/2006/main">
               <a:ext uri="{FF2B5EF4-FFF2-40B4-BE49-F238E27FC236}">
-                <a16:creationId xmlns:a16="http://schemas.microsoft.com/office/drawing/2014/main" id="{E2028508-EB29-4C9D-9471-375018574E69}"/>
+                <a16:creationId xmlns:a16="http://schemas.microsoft.com/office/drawing/2014/main" id="{E5A14A8D-247B-47F5-9EEB-B12CF52988CF}"/>
               </a:ext>
             </a:extLst>
           </p:cNvPr>
@@ -6687,7 +6687,7 @@
           <p:cNvPr id="6" name="">
             <a:extLst xmlns:a="http://schemas.openxmlformats.org/drawingml/2006/main">
               <a:ext uri="{FF2B5EF4-FFF2-40B4-BE49-F238E27FC236}">
-                <a16:creationId xmlns:a16="http://schemas.microsoft.com/office/drawing/2014/main" id="{513B28D0-B308-4D42-A910-9673788B59B9}"/>
+                <a16:creationId xmlns:a16="http://schemas.microsoft.com/office/drawing/2014/main" id="{FE4AE27B-7F9D-49DF-89A0-CAF261729917}"/>
               </a:ext>
             </a:extLst>
           </p:cNvPr>
@@ -6720,7 +6720,7 @@
           <p:cNvPr id="7" name="">
             <a:extLst xmlns:a="http://schemas.openxmlformats.org/drawingml/2006/main">
               <a:ext uri="{FF2B5EF4-FFF2-40B4-BE49-F238E27FC236}">
-                <a16:creationId xmlns:a16="http://schemas.microsoft.com/office/drawing/2014/main" id="{8D2524C5-B656-41F0-90A6-BD5FE5B80963}"/>
+                <a16:creationId xmlns:a16="http://schemas.microsoft.com/office/drawing/2014/main" id="{BEB036AB-71D0-43AC-8A56-875E3AD7D7E4}"/>
               </a:ext>
             </a:extLst>
           </p:cNvPr>
@@ -6776,7 +6776,7 @@
           <p:cNvPr id="8" name="">
             <a:extLst xmlns:a="http://schemas.openxmlformats.org/drawingml/2006/main">
               <a:ext uri="{FF2B5EF4-FFF2-40B4-BE49-F238E27FC236}">
-                <a16:creationId xmlns:a16="http://schemas.microsoft.com/office/drawing/2014/main" id="{CA811147-9C7A-4AD4-A05B-A24CF829BE93}"/>
+                <a16:creationId xmlns:a16="http://schemas.microsoft.com/office/drawing/2014/main" id="{CCB8E1B0-D3DF-44A7-A133-346687F525E5}"/>
               </a:ext>
             </a:extLst>
           </p:cNvPr>
@@ -6832,7 +6832,7 @@
           <p:cNvPr id="9" name="">
             <a:extLst xmlns:a="http://schemas.openxmlformats.org/drawingml/2006/main">
               <a:ext uri="{FF2B5EF4-FFF2-40B4-BE49-F238E27FC236}">
-                <a16:creationId xmlns:a16="http://schemas.microsoft.com/office/drawing/2014/main" id="{CEB5FFDD-5781-4903-B7CB-35EC3EAF8BA6}"/>
+                <a16:creationId xmlns:a16="http://schemas.microsoft.com/office/drawing/2014/main" id="{D8B92150-EE79-4A0E-A4C3-9460DD2A6045}"/>
               </a:ext>
             </a:extLst>
           </p:cNvPr>
@@ -6865,7 +6865,7 @@
           <p:cNvPr id="10" name="">
             <a:extLst xmlns:a="http://schemas.openxmlformats.org/drawingml/2006/main">
               <a:ext uri="{FF2B5EF4-FFF2-40B4-BE49-F238E27FC236}">
-                <a16:creationId xmlns:a16="http://schemas.microsoft.com/office/drawing/2014/main" id="{D1586C6C-82D1-439D-A348-B18342BAA99B}"/>
+                <a16:creationId xmlns:a16="http://schemas.microsoft.com/office/drawing/2014/main" id="{2E36FD30-6E3C-46FE-9B2B-3994C69741A6}"/>
               </a:ext>
             </a:extLst>
           </p:cNvPr>
@@ -6921,7 +6921,7 @@
           <p:cNvPr id="11" name="">
             <a:extLst xmlns:a="http://schemas.openxmlformats.org/drawingml/2006/main">
               <a:ext uri="{FF2B5EF4-FFF2-40B4-BE49-F238E27FC236}">
-                <a16:creationId xmlns:a16="http://schemas.microsoft.com/office/drawing/2014/main" id="{71629907-463F-4A53-9020-4B59D49C76EE}"/>
+                <a16:creationId xmlns:a16="http://schemas.microsoft.com/office/drawing/2014/main" id="{43330E4D-0435-4D59-98B6-E7E4A5723987}"/>
               </a:ext>
             </a:extLst>
           </p:cNvPr>
@@ -6967,7 +6967,7 @@
                 <a:ea typeface="Aptos"/>
                 <a:cs typeface="Aptos"/>
               </a:rPr>
-              <a:t>Validate locally, tune thresholds, audit fairness, and improve calibration.</a:t>
+              <a:t>Test external validation, nested CV, calibration, threshold optimization, and SHAP/fairness metrics.</a:t>
             </a:r>
           </a:p>
         </p:txBody>
@@ -6977,7 +6977,7 @@
           <p:cNvPr id="12" name="">
             <a:extLst xmlns:a="http://schemas.openxmlformats.org/drawingml/2006/main">
               <a:ext uri="{FF2B5EF4-FFF2-40B4-BE49-F238E27FC236}">
-                <a16:creationId xmlns:a16="http://schemas.microsoft.com/office/drawing/2014/main" id="{13F400AA-B53F-477D-88F6-602FFDCAD5F4}"/>
+                <a16:creationId xmlns:a16="http://schemas.microsoft.com/office/drawing/2014/main" id="{6CEC291E-43E3-4D17-9039-223BF0157906}"/>
               </a:ext>
             </a:extLst>
           </p:cNvPr>
@@ -7033,7 +7033,7 @@
           <p:cNvPr id="13" name="">
             <a:extLst xmlns:a="http://schemas.openxmlformats.org/drawingml/2006/main">
               <a:ext uri="{FF2B5EF4-FFF2-40B4-BE49-F238E27FC236}">
-                <a16:creationId xmlns:a16="http://schemas.microsoft.com/office/drawing/2014/main" id="{1E95B77E-D599-43B0-A9DD-3ABB864F0DE4}"/>
+                <a16:creationId xmlns:a16="http://schemas.microsoft.com/office/drawing/2014/main" id="{1753FC66-711A-4C85-AF03-1E20EBEB5FBB}"/>
               </a:ext>
             </a:extLst>
           </p:cNvPr>
@@ -7089,7 +7089,7 @@
           <p:cNvPr id="14" name="">
             <a:extLst xmlns:a="http://schemas.openxmlformats.org/drawingml/2006/main">
               <a:ext uri="{FF2B5EF4-FFF2-40B4-BE49-F238E27FC236}">
-                <a16:creationId xmlns:a16="http://schemas.microsoft.com/office/drawing/2014/main" id="{8D2940A6-9D86-4FA0-B224-6660E470F9D6}"/>
+                <a16:creationId xmlns:a16="http://schemas.microsoft.com/office/drawing/2014/main" id="{E3BB70B3-5668-484D-8A39-FC05BBAF54F4}"/>
               </a:ext>
             </a:extLst>
           </p:cNvPr>
@@ -7143,7 +7143,7 @@
     </p:spTree>
     <p:extLst>
       <p:ext uri="{BB962C8B-B14F-4D97-AF65-F5344CB8AC3E}">
-        <p14:creationId xmlns:p14="http://schemas.microsoft.com/office/powerpoint/2010/main" val="1941487293"/>
+        <p14:creationId xmlns:p14="http://schemas.microsoft.com/office/powerpoint/2010/main" val="2011634777"/>
       </p:ext>
     </p:extLst>
   </p:cSld>
@@ -7174,7 +7174,7 @@
           <p:cNvPr id="1" name="">
             <a:extLst xmlns:a="http://schemas.openxmlformats.org/drawingml/2006/main">
               <a:ext uri="{FF2B5EF4-FFF2-40B4-BE49-F238E27FC236}">
-                <a16:creationId xmlns:a16="http://schemas.microsoft.com/office/drawing/2014/main" id="{B623DD42-F49F-4F15-B3AF-C9BD160BBFE0}"/>
+                <a16:creationId xmlns:a16="http://schemas.microsoft.com/office/drawing/2014/main" id="{A54CD531-5CA7-4D4D-8BB1-C8772E72C1DA}"/>
               </a:ext>
             </a:extLst>
           </p:cNvPr>
@@ -7207,7 +7207,7 @@
           <p:cNvPr id="2" name="">
             <a:extLst xmlns:a="http://schemas.openxmlformats.org/drawingml/2006/main">
               <a:ext uri="{FF2B5EF4-FFF2-40B4-BE49-F238E27FC236}">
-                <a16:creationId xmlns:a16="http://schemas.microsoft.com/office/drawing/2014/main" id="{75B06133-2949-42BB-89AC-C89782851831}"/>
+                <a16:creationId xmlns:a16="http://schemas.microsoft.com/office/drawing/2014/main" id="{88F8A92B-7795-41CB-8C3B-99AD8D0EF454}"/>
               </a:ext>
             </a:extLst>
           </p:cNvPr>
@@ -7240,7 +7240,7 @@
           <p:cNvPr id="3" name="">
             <a:extLst xmlns:a="http://schemas.openxmlformats.org/drawingml/2006/main">
               <a:ext uri="{FF2B5EF4-FFF2-40B4-BE49-F238E27FC236}">
-                <a16:creationId xmlns:a16="http://schemas.microsoft.com/office/drawing/2014/main" id="{0CEE0B9D-53B5-49D7-9D68-1D58C7AEFDCA}"/>
+                <a16:creationId xmlns:a16="http://schemas.microsoft.com/office/drawing/2014/main" id="{5260ACCF-4CDE-4D32-80B4-1CD3B36EF12C}"/>
               </a:ext>
             </a:extLst>
           </p:cNvPr>
@@ -7296,7 +7296,7 @@
           <p:cNvPr id="4" name="">
             <a:extLst xmlns:a="http://schemas.openxmlformats.org/drawingml/2006/main">
               <a:ext uri="{FF2B5EF4-FFF2-40B4-BE49-F238E27FC236}">
-                <a16:creationId xmlns:a16="http://schemas.microsoft.com/office/drawing/2014/main" id="{07B31911-B709-47EC-9DD1-8F17EBE7EE81}"/>
+                <a16:creationId xmlns:a16="http://schemas.microsoft.com/office/drawing/2014/main" id="{97139F6D-2E35-4DED-B4B4-F4EBD08B991D}"/>
               </a:ext>
             </a:extLst>
           </p:cNvPr>
@@ -7352,7 +7352,7 @@
           <p:cNvPr id="5" name="">
             <a:extLst xmlns:a="http://schemas.openxmlformats.org/drawingml/2006/main">
               <a:ext uri="{FF2B5EF4-FFF2-40B4-BE49-F238E27FC236}">
-                <a16:creationId xmlns:a16="http://schemas.microsoft.com/office/drawing/2014/main" id="{E63C2264-25CB-4287-908D-4429D92A9D94}"/>
+                <a16:creationId xmlns:a16="http://schemas.microsoft.com/office/drawing/2014/main" id="{615C4FED-00FB-4C04-A00B-D64D632465E6}"/>
               </a:ext>
             </a:extLst>
           </p:cNvPr>
@@ -7408,7 +7408,7 @@
           <p:cNvPr id="6" name="">
             <a:extLst xmlns:a="http://schemas.openxmlformats.org/drawingml/2006/main">
               <a:ext uri="{FF2B5EF4-FFF2-40B4-BE49-F238E27FC236}">
-                <a16:creationId xmlns:a16="http://schemas.microsoft.com/office/drawing/2014/main" id="{80CB35D3-DB57-464B-B431-25E9353F27D4}"/>
+                <a16:creationId xmlns:a16="http://schemas.microsoft.com/office/drawing/2014/main" id="{16613C4A-3572-4AC2-8A09-08EF8E5DB9CC}"/>
               </a:ext>
             </a:extLst>
           </p:cNvPr>
@@ -7464,7 +7464,7 @@
           <p:cNvPr id="7" name="">
             <a:extLst xmlns:a="http://schemas.openxmlformats.org/drawingml/2006/main">
               <a:ext uri="{FF2B5EF4-FFF2-40B4-BE49-F238E27FC236}">
-                <a16:creationId xmlns:a16="http://schemas.microsoft.com/office/drawing/2014/main" id="{766D3DC5-9DC3-4F85-A593-E42C0A1571C6}"/>
+                <a16:creationId xmlns:a16="http://schemas.microsoft.com/office/drawing/2014/main" id="{8E26D975-4768-40AB-846C-BD1FA544C3BC}"/>
               </a:ext>
             </a:extLst>
           </p:cNvPr>
@@ -7497,7 +7497,7 @@
           <p:cNvPr id="8" name="">
             <a:extLst xmlns:a="http://schemas.openxmlformats.org/drawingml/2006/main">
               <a:ext uri="{FF2B5EF4-FFF2-40B4-BE49-F238E27FC236}">
-                <a16:creationId xmlns:a16="http://schemas.microsoft.com/office/drawing/2014/main" id="{47F149DB-29CB-4BEF-ACD1-2034BFC2351A}"/>
+                <a16:creationId xmlns:a16="http://schemas.microsoft.com/office/drawing/2014/main" id="{6CFBDB19-B5C2-4257-BCB1-F686329A0AE7}"/>
               </a:ext>
             </a:extLst>
           </p:cNvPr>
@@ -7530,7 +7530,7 @@
           <p:cNvPr id="9" name="">
             <a:extLst xmlns:a="http://schemas.openxmlformats.org/drawingml/2006/main">
               <a:ext uri="{FF2B5EF4-FFF2-40B4-BE49-F238E27FC236}">
-                <a16:creationId xmlns:a16="http://schemas.microsoft.com/office/drawing/2014/main" id="{441CF7A2-FC2F-4A2F-8741-4D50662C29F6}"/>
+                <a16:creationId xmlns:a16="http://schemas.microsoft.com/office/drawing/2014/main" id="{6D8BB023-9590-48B3-881E-12F765422D06}"/>
               </a:ext>
             </a:extLst>
           </p:cNvPr>
@@ -7563,7 +7563,7 @@
           <p:cNvPr id="10" name="">
             <a:extLst xmlns:a="http://schemas.openxmlformats.org/drawingml/2006/main">
               <a:ext uri="{FF2B5EF4-FFF2-40B4-BE49-F238E27FC236}">
-                <a16:creationId xmlns:a16="http://schemas.microsoft.com/office/drawing/2014/main" id="{11E7B74E-3B7A-4DB0-A108-FCEAFE7AB00F}"/>
+                <a16:creationId xmlns:a16="http://schemas.microsoft.com/office/drawing/2014/main" id="{1E31BBC4-8CAE-4903-A010-411772D15ADD}"/>
               </a:ext>
             </a:extLst>
           </p:cNvPr>
@@ -7619,7 +7619,7 @@
           <p:cNvPr id="11" name="">
             <a:extLst xmlns:a="http://schemas.openxmlformats.org/drawingml/2006/main">
               <a:ext uri="{FF2B5EF4-FFF2-40B4-BE49-F238E27FC236}">
-                <a16:creationId xmlns:a16="http://schemas.microsoft.com/office/drawing/2014/main" id="{781351F3-C5B6-4763-BCB4-669E9566386C}"/>
+                <a16:creationId xmlns:a16="http://schemas.microsoft.com/office/drawing/2014/main" id="{9AFC3488-B66B-4CFF-BD15-47DB1EE0C4DE}"/>
               </a:ext>
             </a:extLst>
           </p:cNvPr>
@@ -7675,7 +7675,7 @@
           <p:cNvPr id="12" name="">
             <a:extLst xmlns:a="http://schemas.openxmlformats.org/drawingml/2006/main">
               <a:ext uri="{FF2B5EF4-FFF2-40B4-BE49-F238E27FC236}">
-                <a16:creationId xmlns:a16="http://schemas.microsoft.com/office/drawing/2014/main" id="{85A9FD78-D963-4301-85F3-8B9117B724E6}"/>
+                <a16:creationId xmlns:a16="http://schemas.microsoft.com/office/drawing/2014/main" id="{265A8FCA-04A0-4095-B0A6-384687CEEB2A}"/>
               </a:ext>
             </a:extLst>
           </p:cNvPr>
@@ -7708,7 +7708,7 @@
           <p:cNvPr id="13" name="">
             <a:extLst xmlns:a="http://schemas.openxmlformats.org/drawingml/2006/main">
               <a:ext uri="{FF2B5EF4-FFF2-40B4-BE49-F238E27FC236}">
-                <a16:creationId xmlns:a16="http://schemas.microsoft.com/office/drawing/2014/main" id="{A82BF1F3-C855-454F-A476-F8B15181AEAF}"/>
+                <a16:creationId xmlns:a16="http://schemas.microsoft.com/office/drawing/2014/main" id="{021104B5-0A86-4899-A8E3-37C486F76A6C}"/>
               </a:ext>
             </a:extLst>
           </p:cNvPr>
@@ -7741,7 +7741,7 @@
           <p:cNvPr id="14" name="">
             <a:extLst xmlns:a="http://schemas.openxmlformats.org/drawingml/2006/main">
               <a:ext uri="{FF2B5EF4-FFF2-40B4-BE49-F238E27FC236}">
-                <a16:creationId xmlns:a16="http://schemas.microsoft.com/office/drawing/2014/main" id="{5D53FC94-CCB8-4E72-B889-2A6C0DFEC21B}"/>
+                <a16:creationId xmlns:a16="http://schemas.microsoft.com/office/drawing/2014/main" id="{FB9E162A-EEA7-435A-A40F-CA0C06C4A5B0}"/>
               </a:ext>
             </a:extLst>
           </p:cNvPr>
@@ -7797,7 +7797,7 @@
           <p:cNvPr id="15" name="">
             <a:extLst xmlns:a="http://schemas.openxmlformats.org/drawingml/2006/main">
               <a:ext uri="{FF2B5EF4-FFF2-40B4-BE49-F238E27FC236}">
-                <a16:creationId xmlns:a16="http://schemas.microsoft.com/office/drawing/2014/main" id="{23383631-A84E-4E53-96C8-1C8BA3FF3B17}"/>
+                <a16:creationId xmlns:a16="http://schemas.microsoft.com/office/drawing/2014/main" id="{71ABED03-57E2-414C-B862-0FC5FCDA480A}"/>
               </a:ext>
             </a:extLst>
           </p:cNvPr>
@@ -7853,7 +7853,7 @@
           <p:cNvPr id="16" name="">
             <a:extLst xmlns:a="http://schemas.openxmlformats.org/drawingml/2006/main">
               <a:ext uri="{FF2B5EF4-FFF2-40B4-BE49-F238E27FC236}">
-                <a16:creationId xmlns:a16="http://schemas.microsoft.com/office/drawing/2014/main" id="{047792B2-13D2-455B-99E3-D4B31FF9CB73}"/>
+                <a16:creationId xmlns:a16="http://schemas.microsoft.com/office/drawing/2014/main" id="{59AF05A8-8F18-4BAC-B3CC-983875445BB4}"/>
               </a:ext>
             </a:extLst>
           </p:cNvPr>
@@ -7886,7 +7886,7 @@
           <p:cNvPr id="17" name="">
             <a:extLst xmlns:a="http://schemas.openxmlformats.org/drawingml/2006/main">
               <a:ext uri="{FF2B5EF4-FFF2-40B4-BE49-F238E27FC236}">
-                <a16:creationId xmlns:a16="http://schemas.microsoft.com/office/drawing/2014/main" id="{3A4E7A77-5DDC-4A32-9D6F-419025D1D575}"/>
+                <a16:creationId xmlns:a16="http://schemas.microsoft.com/office/drawing/2014/main" id="{5B9E8BFC-818F-4749-B988-0105DE163E7A}"/>
               </a:ext>
             </a:extLst>
           </p:cNvPr>
@@ -7919,7 +7919,7 @@
           <p:cNvPr id="18" name="">
             <a:extLst xmlns:a="http://schemas.openxmlformats.org/drawingml/2006/main">
               <a:ext uri="{FF2B5EF4-FFF2-40B4-BE49-F238E27FC236}">
-                <a16:creationId xmlns:a16="http://schemas.microsoft.com/office/drawing/2014/main" id="{4B126031-1424-42B8-8F84-DD7E62D5127C}"/>
+                <a16:creationId xmlns:a16="http://schemas.microsoft.com/office/drawing/2014/main" id="{FB9FD88F-CF04-47A9-8884-C28BA3594BE8}"/>
               </a:ext>
             </a:extLst>
           </p:cNvPr>
@@ -7975,7 +7975,7 @@
           <p:cNvPr id="19" name="">
             <a:extLst xmlns:a="http://schemas.openxmlformats.org/drawingml/2006/main">
               <a:ext uri="{FF2B5EF4-FFF2-40B4-BE49-F238E27FC236}">
-                <a16:creationId xmlns:a16="http://schemas.microsoft.com/office/drawing/2014/main" id="{3DFD0D52-349E-460D-BCD6-BCB88342C369}"/>
+                <a16:creationId xmlns:a16="http://schemas.microsoft.com/office/drawing/2014/main" id="{0976573E-BC17-4309-8664-4B2596A377BD}"/>
               </a:ext>
             </a:extLst>
           </p:cNvPr>
@@ -8031,7 +8031,7 @@
           <p:cNvPr id="20" name="">
             <a:extLst xmlns:a="http://schemas.openxmlformats.org/drawingml/2006/main">
               <a:ext uri="{FF2B5EF4-FFF2-40B4-BE49-F238E27FC236}">
-                <a16:creationId xmlns:a16="http://schemas.microsoft.com/office/drawing/2014/main" id="{EFCCF6CB-9B20-4951-B17C-BFAD5C8DD833}"/>
+                <a16:creationId xmlns:a16="http://schemas.microsoft.com/office/drawing/2014/main" id="{025E2CD4-A96F-4DBB-9B09-101C68B4946C}"/>
               </a:ext>
             </a:extLst>
           </p:cNvPr>
@@ -8085,7 +8085,7 @@
     </p:spTree>
     <p:extLst>
       <p:ext uri="{BB962C8B-B14F-4D97-AF65-F5344CB8AC3E}">
-        <p14:creationId xmlns:p14="http://schemas.microsoft.com/office/powerpoint/2010/main" val="417416289"/>
+        <p14:creationId xmlns:p14="http://schemas.microsoft.com/office/powerpoint/2010/main" val="579368679"/>
       </p:ext>
     </p:extLst>
   </p:cSld>
@@ -8116,7 +8116,7 @@
           <p:cNvPr id="1" name="">
             <a:extLst xmlns:a="http://schemas.openxmlformats.org/drawingml/2006/main">
               <a:ext uri="{FF2B5EF4-FFF2-40B4-BE49-F238E27FC236}">
-                <a16:creationId xmlns:a16="http://schemas.microsoft.com/office/drawing/2014/main" id="{7DA8F2CA-0C9F-4038-8F0A-71A167D218AB}"/>
+                <a16:creationId xmlns:a16="http://schemas.microsoft.com/office/drawing/2014/main" id="{E8AF927D-A445-4D5A-A49B-6C0D0BA81FA4}"/>
               </a:ext>
             </a:extLst>
           </p:cNvPr>
@@ -8149,7 +8149,7 @@
           <p:cNvPr id="2" name="">
             <a:extLst xmlns:a="http://schemas.openxmlformats.org/drawingml/2006/main">
               <a:ext uri="{FF2B5EF4-FFF2-40B4-BE49-F238E27FC236}">
-                <a16:creationId xmlns:a16="http://schemas.microsoft.com/office/drawing/2014/main" id="{62D29341-1113-489F-ACDE-2DBBC933A1D5}"/>
+                <a16:creationId xmlns:a16="http://schemas.microsoft.com/office/drawing/2014/main" id="{54E4CD58-7A63-4A93-A29E-EDDA85B15A2D}"/>
               </a:ext>
             </a:extLst>
           </p:cNvPr>
@@ -8182,7 +8182,7 @@
           <p:cNvPr id="3" name="">
             <a:extLst xmlns:a="http://schemas.openxmlformats.org/drawingml/2006/main">
               <a:ext uri="{FF2B5EF4-FFF2-40B4-BE49-F238E27FC236}">
-                <a16:creationId xmlns:a16="http://schemas.microsoft.com/office/drawing/2014/main" id="{6BC94178-9D75-4B74-A953-2BDC74EFFCC2}"/>
+                <a16:creationId xmlns:a16="http://schemas.microsoft.com/office/drawing/2014/main" id="{CEA23F6C-6C9F-4419-B74F-B87BC980BA87}"/>
               </a:ext>
             </a:extLst>
           </p:cNvPr>
@@ -8238,7 +8238,7 @@
           <p:cNvPr id="4" name="">
             <a:extLst xmlns:a="http://schemas.openxmlformats.org/drawingml/2006/main">
               <a:ext uri="{FF2B5EF4-FFF2-40B4-BE49-F238E27FC236}">
-                <a16:creationId xmlns:a16="http://schemas.microsoft.com/office/drawing/2014/main" id="{C18BDAC0-A327-4C4C-8DFD-70F3511D31FC}"/>
+                <a16:creationId xmlns:a16="http://schemas.microsoft.com/office/drawing/2014/main" id="{2E83AF08-A25E-4982-8BF7-DAF7F6085105}"/>
               </a:ext>
             </a:extLst>
           </p:cNvPr>
@@ -8294,7 +8294,7 @@
           <p:cNvPr id="5" name="">
             <a:extLst xmlns:a="http://schemas.openxmlformats.org/drawingml/2006/main">
               <a:ext uri="{FF2B5EF4-FFF2-40B4-BE49-F238E27FC236}">
-                <a16:creationId xmlns:a16="http://schemas.microsoft.com/office/drawing/2014/main" id="{F5E54AC8-0441-497F-A22E-23A80D7D9373}"/>
+                <a16:creationId xmlns:a16="http://schemas.microsoft.com/office/drawing/2014/main" id="{43D2D3DB-C018-4496-A178-33866DD35611}"/>
               </a:ext>
             </a:extLst>
           </p:cNvPr>
@@ -8350,7 +8350,7 @@
           <p:cNvPr id="6" name="">
             <a:extLst xmlns:a="http://schemas.openxmlformats.org/drawingml/2006/main">
               <a:ext uri="{FF2B5EF4-FFF2-40B4-BE49-F238E27FC236}">
-                <a16:creationId xmlns:a16="http://schemas.microsoft.com/office/drawing/2014/main" id="{B58FC360-4027-4CDA-83A3-AFBF1159F8B2}"/>
+                <a16:creationId xmlns:a16="http://schemas.microsoft.com/office/drawing/2014/main" id="{F8D4771C-8AA9-4186-9CC1-C7FEA1745E74}"/>
               </a:ext>
             </a:extLst>
           </p:cNvPr>
@@ -8406,7 +8406,7 @@
           <p:cNvPr id="7" name="">
             <a:extLst xmlns:a="http://schemas.openxmlformats.org/drawingml/2006/main">
               <a:ext uri="{FF2B5EF4-FFF2-40B4-BE49-F238E27FC236}">
-                <a16:creationId xmlns:a16="http://schemas.microsoft.com/office/drawing/2014/main" id="{2B34FBC7-B123-4908-985F-778F4DE646C5}"/>
+                <a16:creationId xmlns:a16="http://schemas.microsoft.com/office/drawing/2014/main" id="{95C38C67-1C8E-4F33-91F0-5A4825564ACB}"/>
               </a:ext>
             </a:extLst>
           </p:cNvPr>
@@ -8439,7 +8439,7 @@
           <p:cNvPr id="8" name="">
             <a:extLst xmlns:a="http://schemas.openxmlformats.org/drawingml/2006/main">
               <a:ext uri="{FF2B5EF4-FFF2-40B4-BE49-F238E27FC236}">
-                <a16:creationId xmlns:a16="http://schemas.microsoft.com/office/drawing/2014/main" id="{3FBB67F7-3B73-40E5-BADB-D11D4E18061F}"/>
+                <a16:creationId xmlns:a16="http://schemas.microsoft.com/office/drawing/2014/main" id="{91DBE544-410F-4AEE-BA0C-51E475FEE7C2}"/>
               </a:ext>
             </a:extLst>
           </p:cNvPr>
@@ -8472,7 +8472,7 @@
           <p:cNvPr id="9" name="">
             <a:extLst xmlns:a="http://schemas.openxmlformats.org/drawingml/2006/main">
               <a:ext uri="{FF2B5EF4-FFF2-40B4-BE49-F238E27FC236}">
-                <a16:creationId xmlns:a16="http://schemas.microsoft.com/office/drawing/2014/main" id="{B0676444-C4F3-4CE9-80F5-3ADB33957678}"/>
+                <a16:creationId xmlns:a16="http://schemas.microsoft.com/office/drawing/2014/main" id="{2D9DE939-0F24-4C20-A386-561F47760540}"/>
               </a:ext>
             </a:extLst>
           </p:cNvPr>
@@ -8528,7 +8528,7 @@
           <p:cNvPr id="10" name="">
             <a:extLst xmlns:a="http://schemas.openxmlformats.org/drawingml/2006/main">
               <a:ext uri="{FF2B5EF4-FFF2-40B4-BE49-F238E27FC236}">
-                <a16:creationId xmlns:a16="http://schemas.microsoft.com/office/drawing/2014/main" id="{93C365BC-13DA-46F3-AD6D-FDC5A80C5EC8}"/>
+                <a16:creationId xmlns:a16="http://schemas.microsoft.com/office/drawing/2014/main" id="{467FBB34-8388-44AA-9575-61541F3E253C}"/>
               </a:ext>
             </a:extLst>
           </p:cNvPr>
@@ -8607,7 +8607,7 @@
           <p:cNvPr id="11" name="">
             <a:extLst xmlns:a="http://schemas.openxmlformats.org/drawingml/2006/main">
               <a:ext uri="{FF2B5EF4-FFF2-40B4-BE49-F238E27FC236}">
-                <a16:creationId xmlns:a16="http://schemas.microsoft.com/office/drawing/2014/main" id="{B8E891B1-C42B-40F9-B798-0FFAED7D1AD6}"/>
+                <a16:creationId xmlns:a16="http://schemas.microsoft.com/office/drawing/2014/main" id="{94BB3F47-D73E-48F5-AFB1-F56CC4518BB4}"/>
               </a:ext>
             </a:extLst>
           </p:cNvPr>
@@ -8640,7 +8640,7 @@
           <p:cNvPr id="12" name="">
             <a:extLst xmlns:a="http://schemas.openxmlformats.org/drawingml/2006/main">
               <a:ext uri="{FF2B5EF4-FFF2-40B4-BE49-F238E27FC236}">
-                <a16:creationId xmlns:a16="http://schemas.microsoft.com/office/drawing/2014/main" id="{216A07E6-42D7-4247-A7D3-2442D49E5D04}"/>
+                <a16:creationId xmlns:a16="http://schemas.microsoft.com/office/drawing/2014/main" id="{6A8BFED5-8C07-490D-A982-EB77F1EBDACC}"/>
               </a:ext>
             </a:extLst>
           </p:cNvPr>
@@ -8696,7 +8696,7 @@
           <p:cNvPr id="13" name="">
             <a:extLst xmlns:a="http://schemas.openxmlformats.org/drawingml/2006/main">
               <a:ext uri="{FF2B5EF4-FFF2-40B4-BE49-F238E27FC236}">
-                <a16:creationId xmlns:a16="http://schemas.microsoft.com/office/drawing/2014/main" id="{24BE7678-BDD9-40DD-B90F-558D03D61911}"/>
+                <a16:creationId xmlns:a16="http://schemas.microsoft.com/office/drawing/2014/main" id="{30F3A0B2-3911-4D74-B796-6A6EFB8F208E}"/>
               </a:ext>
             </a:extLst>
           </p:cNvPr>
@@ -8775,7 +8775,7 @@
           <p:cNvPr id="14" name="">
             <a:extLst xmlns:a="http://schemas.openxmlformats.org/drawingml/2006/main">
               <a:ext uri="{FF2B5EF4-FFF2-40B4-BE49-F238E27FC236}">
-                <a16:creationId xmlns:a16="http://schemas.microsoft.com/office/drawing/2014/main" id="{91486EED-0D7E-43E5-8A3F-A288CF30117D}"/>
+                <a16:creationId xmlns:a16="http://schemas.microsoft.com/office/drawing/2014/main" id="{184000FC-ACF6-4097-BE7B-BEE817448F5F}"/>
               </a:ext>
             </a:extLst>
           </p:cNvPr>
@@ -8808,7 +8808,7 @@
           <p:cNvPr id="15" name="">
             <a:extLst xmlns:a="http://schemas.openxmlformats.org/drawingml/2006/main">
               <a:ext uri="{FF2B5EF4-FFF2-40B4-BE49-F238E27FC236}">
-                <a16:creationId xmlns:a16="http://schemas.microsoft.com/office/drawing/2014/main" id="{C1B10DAD-1BF2-4008-8556-11B6C977DE2C}"/>
+                <a16:creationId xmlns:a16="http://schemas.microsoft.com/office/drawing/2014/main" id="{9B402937-7BB6-415E-8377-44603D26A734}"/>
               </a:ext>
             </a:extLst>
           </p:cNvPr>
@@ -8864,7 +8864,7 @@
           <p:cNvPr id="16" name="">
             <a:extLst xmlns:a="http://schemas.openxmlformats.org/drawingml/2006/main">
               <a:ext uri="{FF2B5EF4-FFF2-40B4-BE49-F238E27FC236}">
-                <a16:creationId xmlns:a16="http://schemas.microsoft.com/office/drawing/2014/main" id="{0D3F446F-DB10-4D99-B37B-F26A0A4116DA}"/>
+                <a16:creationId xmlns:a16="http://schemas.microsoft.com/office/drawing/2014/main" id="{4DEB354C-465A-4CCF-A222-3F8E6A0F662E}"/>
               </a:ext>
             </a:extLst>
           </p:cNvPr>
@@ -8966,7 +8966,7 @@
           <p:cNvPr id="17" name="">
             <a:extLst xmlns:a="http://schemas.openxmlformats.org/drawingml/2006/main">
               <a:ext uri="{FF2B5EF4-FFF2-40B4-BE49-F238E27FC236}">
-                <a16:creationId xmlns:a16="http://schemas.microsoft.com/office/drawing/2014/main" id="{03948D14-DC0A-4134-9544-A6A664B5CED7}"/>
+                <a16:creationId xmlns:a16="http://schemas.microsoft.com/office/drawing/2014/main" id="{6148294D-FF54-4D49-9D89-22C3DC9334E6}"/>
               </a:ext>
             </a:extLst>
           </p:cNvPr>
@@ -8999,7 +8999,7 @@
           <p:cNvPr id="18" name="">
             <a:extLst xmlns:a="http://schemas.openxmlformats.org/drawingml/2006/main">
               <a:ext uri="{FF2B5EF4-FFF2-40B4-BE49-F238E27FC236}">
-                <a16:creationId xmlns:a16="http://schemas.microsoft.com/office/drawing/2014/main" id="{B2475B9B-504C-4DF7-BFA4-EE17F709B25F}"/>
+                <a16:creationId xmlns:a16="http://schemas.microsoft.com/office/drawing/2014/main" id="{8CADE6BC-32CF-41E5-A880-A00EFA20226D}"/>
               </a:ext>
             </a:extLst>
           </p:cNvPr>
@@ -9055,7 +9055,7 @@
           <p:cNvPr id="19" name="">
             <a:extLst xmlns:a="http://schemas.openxmlformats.org/drawingml/2006/main">
               <a:ext uri="{FF2B5EF4-FFF2-40B4-BE49-F238E27FC236}">
-                <a16:creationId xmlns:a16="http://schemas.microsoft.com/office/drawing/2014/main" id="{E7DC2329-8D7E-4659-BC69-7C984D8D13D1}"/>
+                <a16:creationId xmlns:a16="http://schemas.microsoft.com/office/drawing/2014/main" id="{ADA7B908-F72B-40DB-B0E7-A2F68A04E4F1}"/>
               </a:ext>
             </a:extLst>
           </p:cNvPr>
@@ -9157,7 +9157,7 @@
           <p:cNvPr id="20" name="">
             <a:extLst xmlns:a="http://schemas.openxmlformats.org/drawingml/2006/main">
               <a:ext uri="{FF2B5EF4-FFF2-40B4-BE49-F238E27FC236}">
-                <a16:creationId xmlns:a16="http://schemas.microsoft.com/office/drawing/2014/main" id="{CE55BCDA-99FC-4508-A4E5-DE778FD36D11}"/>
+                <a16:creationId xmlns:a16="http://schemas.microsoft.com/office/drawing/2014/main" id="{1A06A3D3-B783-4DBF-9BA5-F5B3EA50C5F3}"/>
               </a:ext>
             </a:extLst>
           </p:cNvPr>
@@ -9211,7 +9211,7 @@
     </p:spTree>
     <p:extLst>
       <p:ext uri="{BB962C8B-B14F-4D97-AF65-F5344CB8AC3E}">
-        <p14:creationId xmlns:p14="http://schemas.microsoft.com/office/powerpoint/2010/main" val="1232401401"/>
+        <p14:creationId xmlns:p14="http://schemas.microsoft.com/office/powerpoint/2010/main" val="1949752054"/>
       </p:ext>
     </p:extLst>
   </p:cSld>
@@ -9242,7 +9242,7 @@
           <p:cNvPr id="1" name="">
             <a:extLst xmlns:a="http://schemas.openxmlformats.org/drawingml/2006/main">
               <a:ext uri="{FF2B5EF4-FFF2-40B4-BE49-F238E27FC236}">
-                <a16:creationId xmlns:a16="http://schemas.microsoft.com/office/drawing/2014/main" id="{E1509DAD-738D-4E94-8CEE-CE686F9FC85D}"/>
+                <a16:creationId xmlns:a16="http://schemas.microsoft.com/office/drawing/2014/main" id="{2A02D10F-192E-4A4D-89F0-FC480B5816C0}"/>
               </a:ext>
             </a:extLst>
           </p:cNvPr>
@@ -9275,7 +9275,7 @@
           <p:cNvPr id="2" name="">
             <a:extLst xmlns:a="http://schemas.openxmlformats.org/drawingml/2006/main">
               <a:ext uri="{FF2B5EF4-FFF2-40B4-BE49-F238E27FC236}">
-                <a16:creationId xmlns:a16="http://schemas.microsoft.com/office/drawing/2014/main" id="{0AB7E9B8-6CA3-45AB-910F-D26B92D6534E}"/>
+                <a16:creationId xmlns:a16="http://schemas.microsoft.com/office/drawing/2014/main" id="{B031AC27-FA57-48F3-A9BB-5CB34918D03C}"/>
               </a:ext>
             </a:extLst>
           </p:cNvPr>
@@ -9308,7 +9308,7 @@
           <p:cNvPr id="3" name="">
             <a:extLst xmlns:a="http://schemas.openxmlformats.org/drawingml/2006/main">
               <a:ext uri="{FF2B5EF4-FFF2-40B4-BE49-F238E27FC236}">
-                <a16:creationId xmlns:a16="http://schemas.microsoft.com/office/drawing/2014/main" id="{86880B4A-AF44-4A76-82A3-B3EF35B5C2D9}"/>
+                <a16:creationId xmlns:a16="http://schemas.microsoft.com/office/drawing/2014/main" id="{F9C0EBFF-7D73-4B5B-9B8F-ABA31461FC7C}"/>
               </a:ext>
             </a:extLst>
           </p:cNvPr>
@@ -9364,7 +9364,7 @@
           <p:cNvPr id="4" name="">
             <a:extLst xmlns:a="http://schemas.openxmlformats.org/drawingml/2006/main">
               <a:ext uri="{FF2B5EF4-FFF2-40B4-BE49-F238E27FC236}">
-                <a16:creationId xmlns:a16="http://schemas.microsoft.com/office/drawing/2014/main" id="{BEB7F0BC-B3C2-4643-A9BD-FEA4A3FDAD8E}"/>
+                <a16:creationId xmlns:a16="http://schemas.microsoft.com/office/drawing/2014/main" id="{8CE70F2B-19A7-45E9-BC0E-A81BC93F1E8F}"/>
               </a:ext>
             </a:extLst>
           </p:cNvPr>
@@ -9420,7 +9420,7 @@
           <p:cNvPr id="5" name="">
             <a:extLst xmlns:a="http://schemas.openxmlformats.org/drawingml/2006/main">
               <a:ext uri="{FF2B5EF4-FFF2-40B4-BE49-F238E27FC236}">
-                <a16:creationId xmlns:a16="http://schemas.microsoft.com/office/drawing/2014/main" id="{B8539D85-2A60-412A-9A6F-8249C0D262CD}"/>
+                <a16:creationId xmlns:a16="http://schemas.microsoft.com/office/drawing/2014/main" id="{460460B6-88E7-4E6C-BAA0-C8010FB875B6}"/>
               </a:ext>
             </a:extLst>
           </p:cNvPr>
@@ -9476,7 +9476,7 @@
           <p:cNvPr id="6" name="">
             <a:extLst xmlns:a="http://schemas.openxmlformats.org/drawingml/2006/main">
               <a:ext uri="{FF2B5EF4-FFF2-40B4-BE49-F238E27FC236}">
-                <a16:creationId xmlns:a16="http://schemas.microsoft.com/office/drawing/2014/main" id="{9DB6FD24-1DAB-4E33-91DC-4B939BA0C8D9}"/>
+                <a16:creationId xmlns:a16="http://schemas.microsoft.com/office/drawing/2014/main" id="{8ACB1806-3530-4230-A471-2F242BA5CD46}"/>
               </a:ext>
             </a:extLst>
           </p:cNvPr>
@@ -9532,7 +9532,7 @@
           <p:cNvPr id="7" name="">
             <a:extLst xmlns:a="http://schemas.openxmlformats.org/drawingml/2006/main">
               <a:ext uri="{FF2B5EF4-FFF2-40B4-BE49-F238E27FC236}">
-                <a16:creationId xmlns:a16="http://schemas.microsoft.com/office/drawing/2014/main" id="{F33AA017-3F92-4137-8B56-F17F109C3B7A}"/>
+                <a16:creationId xmlns:a16="http://schemas.microsoft.com/office/drawing/2014/main" id="{831BA98B-6066-4DC3-8B1B-7A2010EFD7A5}"/>
               </a:ext>
             </a:extLst>
           </p:cNvPr>
@@ -9565,7 +9565,7 @@
           <p:cNvPr id="8" name="">
             <a:extLst xmlns:a="http://schemas.openxmlformats.org/drawingml/2006/main">
               <a:ext uri="{FF2B5EF4-FFF2-40B4-BE49-F238E27FC236}">
-                <a16:creationId xmlns:a16="http://schemas.microsoft.com/office/drawing/2014/main" id="{5DABDA97-7C3B-49EE-8734-2C4967036171}"/>
+                <a16:creationId xmlns:a16="http://schemas.microsoft.com/office/drawing/2014/main" id="{45AD560B-3DD6-4E37-892D-72330474F82A}"/>
               </a:ext>
             </a:extLst>
           </p:cNvPr>
@@ -9598,7 +9598,7 @@
           <p:cNvPr id="9" name="">
             <a:extLst xmlns:a="http://schemas.openxmlformats.org/drawingml/2006/main">
               <a:ext uri="{FF2B5EF4-FFF2-40B4-BE49-F238E27FC236}">
-                <a16:creationId xmlns:a16="http://schemas.microsoft.com/office/drawing/2014/main" id="{83693550-2780-469F-B5A9-ECBD2DEB56BD}"/>
+                <a16:creationId xmlns:a16="http://schemas.microsoft.com/office/drawing/2014/main" id="{DBA4C66C-F2F8-451D-8E63-3364523F5B9C}"/>
               </a:ext>
             </a:extLst>
           </p:cNvPr>
@@ -9654,7 +9654,7 @@
           <p:cNvPr id="10" name="">
             <a:extLst xmlns:a="http://schemas.openxmlformats.org/drawingml/2006/main">
               <a:ext uri="{FF2B5EF4-FFF2-40B4-BE49-F238E27FC236}">
-                <a16:creationId xmlns:a16="http://schemas.microsoft.com/office/drawing/2014/main" id="{AC6BA36B-2B8C-4127-9517-48FCD628B624}"/>
+                <a16:creationId xmlns:a16="http://schemas.microsoft.com/office/drawing/2014/main" id="{FD5FF8D2-BCD0-422E-909A-1DAB46EFDA73}"/>
               </a:ext>
             </a:extLst>
           </p:cNvPr>
@@ -9710,7 +9710,7 @@
           <p:cNvPr id="11" name="">
             <a:extLst xmlns:a="http://schemas.openxmlformats.org/drawingml/2006/main">
               <a:ext uri="{FF2B5EF4-FFF2-40B4-BE49-F238E27FC236}">
-                <a16:creationId xmlns:a16="http://schemas.microsoft.com/office/drawing/2014/main" id="{2D9AF865-3BE6-49FE-A62E-77DDE21D618C}"/>
+                <a16:creationId xmlns:a16="http://schemas.microsoft.com/office/drawing/2014/main" id="{7AB382DC-4961-4D64-AD0B-243BD3605E2F}"/>
               </a:ext>
             </a:extLst>
           </p:cNvPr>
@@ -9766,7 +9766,7 @@
           <p:cNvPr id="12" name="">
             <a:extLst xmlns:a="http://schemas.openxmlformats.org/drawingml/2006/main">
               <a:ext uri="{FF2B5EF4-FFF2-40B4-BE49-F238E27FC236}">
-                <a16:creationId xmlns:a16="http://schemas.microsoft.com/office/drawing/2014/main" id="{D7B37CC2-A6BB-44D3-9A05-9FAFC16A4A3F}"/>
+                <a16:creationId xmlns:a16="http://schemas.microsoft.com/office/drawing/2014/main" id="{38D0CC30-95F8-4AF0-8314-3AE8429448C5}"/>
               </a:ext>
             </a:extLst>
           </p:cNvPr>
@@ -9799,7 +9799,7 @@
           <p:cNvPr id="13" name="">
             <a:extLst xmlns:a="http://schemas.openxmlformats.org/drawingml/2006/main">
               <a:ext uri="{FF2B5EF4-FFF2-40B4-BE49-F238E27FC236}">
-                <a16:creationId xmlns:a16="http://schemas.microsoft.com/office/drawing/2014/main" id="{C72E5F6A-2057-4CE5-9356-BBF7DA80C761}"/>
+                <a16:creationId xmlns:a16="http://schemas.microsoft.com/office/drawing/2014/main" id="{05BE0AEB-294E-47EA-930A-B3B199C7F7D8}"/>
               </a:ext>
             </a:extLst>
           </p:cNvPr>
@@ -9855,7 +9855,7 @@
           <p:cNvPr id="14" name="">
             <a:extLst xmlns:a="http://schemas.openxmlformats.org/drawingml/2006/main">
               <a:ext uri="{FF2B5EF4-FFF2-40B4-BE49-F238E27FC236}">
-                <a16:creationId xmlns:a16="http://schemas.microsoft.com/office/drawing/2014/main" id="{E28775C1-B2E7-4390-8CE6-462D4208A71B}"/>
+                <a16:creationId xmlns:a16="http://schemas.microsoft.com/office/drawing/2014/main" id="{95216337-6EA8-4513-AE74-3A2CAC02459C}"/>
               </a:ext>
             </a:extLst>
           </p:cNvPr>
@@ -9911,7 +9911,7 @@
           <p:cNvPr id="15" name="">
             <a:extLst xmlns:a="http://schemas.openxmlformats.org/drawingml/2006/main">
               <a:ext uri="{FF2B5EF4-FFF2-40B4-BE49-F238E27FC236}">
-                <a16:creationId xmlns:a16="http://schemas.microsoft.com/office/drawing/2014/main" id="{FA1E24B9-2B13-408C-BA59-8EAF39F25BC3}"/>
+                <a16:creationId xmlns:a16="http://schemas.microsoft.com/office/drawing/2014/main" id="{765F9761-7661-40CC-946F-7AFC7E7E6F9B}"/>
               </a:ext>
             </a:extLst>
           </p:cNvPr>
@@ -9967,7 +9967,7 @@
           <p:cNvPr id="16" name="">
             <a:extLst xmlns:a="http://schemas.openxmlformats.org/drawingml/2006/main">
               <a:ext uri="{FF2B5EF4-FFF2-40B4-BE49-F238E27FC236}">
-                <a16:creationId xmlns:a16="http://schemas.microsoft.com/office/drawing/2014/main" id="{A1836364-5BFC-4A91-B8AB-1D7C01BF0E21}"/>
+                <a16:creationId xmlns:a16="http://schemas.microsoft.com/office/drawing/2014/main" id="{F69AB07C-99F0-4C08-B44F-B758E76B5A00}"/>
               </a:ext>
             </a:extLst>
           </p:cNvPr>
@@ -10000,7 +10000,7 @@
           <p:cNvPr id="17" name="">
             <a:extLst xmlns:a="http://schemas.openxmlformats.org/drawingml/2006/main">
               <a:ext uri="{FF2B5EF4-FFF2-40B4-BE49-F238E27FC236}">
-                <a16:creationId xmlns:a16="http://schemas.microsoft.com/office/drawing/2014/main" id="{E898D812-B433-4A35-BA54-3AD64001CA04}"/>
+                <a16:creationId xmlns:a16="http://schemas.microsoft.com/office/drawing/2014/main" id="{4CDDCCE3-2B49-4A61-A517-FCB1CFC87101}"/>
               </a:ext>
             </a:extLst>
           </p:cNvPr>
@@ -10056,7 +10056,7 @@
           <p:cNvPr id="18" name="">
             <a:extLst xmlns:a="http://schemas.openxmlformats.org/drawingml/2006/main">
               <a:ext uri="{FF2B5EF4-FFF2-40B4-BE49-F238E27FC236}">
-                <a16:creationId xmlns:a16="http://schemas.microsoft.com/office/drawing/2014/main" id="{4D7C8EFB-5CF3-41D5-840A-3E396FC06E6D}"/>
+                <a16:creationId xmlns:a16="http://schemas.microsoft.com/office/drawing/2014/main" id="{DF97CA64-76FF-4EA8-8D5D-D5633FAC51DE}"/>
               </a:ext>
             </a:extLst>
           </p:cNvPr>
@@ -10112,7 +10112,7 @@
           <p:cNvPr id="19" name="">
             <a:extLst xmlns:a="http://schemas.openxmlformats.org/drawingml/2006/main">
               <a:ext uri="{FF2B5EF4-FFF2-40B4-BE49-F238E27FC236}">
-                <a16:creationId xmlns:a16="http://schemas.microsoft.com/office/drawing/2014/main" id="{4FB848D7-4667-433A-BA48-F03E16D4319D}"/>
+                <a16:creationId xmlns:a16="http://schemas.microsoft.com/office/drawing/2014/main" id="{6DA33030-0FF5-4E34-A31F-26A27186D97A}"/>
               </a:ext>
             </a:extLst>
           </p:cNvPr>
@@ -10168,7 +10168,7 @@
           <p:cNvPr id="20" name="">
             <a:extLst xmlns:a="http://schemas.openxmlformats.org/drawingml/2006/main">
               <a:ext uri="{FF2B5EF4-FFF2-40B4-BE49-F238E27FC236}">
-                <a16:creationId xmlns:a16="http://schemas.microsoft.com/office/drawing/2014/main" id="{F34C5DCC-0A79-4B8F-9624-8135DA23F5D9}"/>
+                <a16:creationId xmlns:a16="http://schemas.microsoft.com/office/drawing/2014/main" id="{5EF5C43E-1C2A-4379-82A7-6C0A0B39D7BA}"/>
               </a:ext>
             </a:extLst>
           </p:cNvPr>
@@ -10201,7 +10201,7 @@
           <p:cNvPr id="21" name="">
             <a:extLst xmlns:a="http://schemas.openxmlformats.org/drawingml/2006/main">
               <a:ext uri="{FF2B5EF4-FFF2-40B4-BE49-F238E27FC236}">
-                <a16:creationId xmlns:a16="http://schemas.microsoft.com/office/drawing/2014/main" id="{D7E8B538-7487-4C3B-ACDC-F509CB2824C7}"/>
+                <a16:creationId xmlns:a16="http://schemas.microsoft.com/office/drawing/2014/main" id="{5CF9F6AB-EC9A-47FD-9B5D-3BD626278920}"/>
               </a:ext>
             </a:extLst>
           </p:cNvPr>
@@ -10257,7 +10257,7 @@
           <p:cNvPr id="22" name="">
             <a:extLst xmlns:a="http://schemas.openxmlformats.org/drawingml/2006/main">
               <a:ext uri="{FF2B5EF4-FFF2-40B4-BE49-F238E27FC236}">
-                <a16:creationId xmlns:a16="http://schemas.microsoft.com/office/drawing/2014/main" id="{0E0EC78C-96BE-44C1-9454-49A8DCE2D3C7}"/>
+                <a16:creationId xmlns:a16="http://schemas.microsoft.com/office/drawing/2014/main" id="{4FA2407E-D370-4BC7-85BD-6929E28AC908}"/>
               </a:ext>
             </a:extLst>
           </p:cNvPr>
@@ -10313,7 +10313,7 @@
           <p:cNvPr id="23" name="">
             <a:extLst xmlns:a="http://schemas.openxmlformats.org/drawingml/2006/main">
               <a:ext uri="{FF2B5EF4-FFF2-40B4-BE49-F238E27FC236}">
-                <a16:creationId xmlns:a16="http://schemas.microsoft.com/office/drawing/2014/main" id="{6B4322A7-4820-46F9-A15E-138341AA6A93}"/>
+                <a16:creationId xmlns:a16="http://schemas.microsoft.com/office/drawing/2014/main" id="{005B90FD-FBF0-4EAC-9D22-9B71287523A7}"/>
               </a:ext>
             </a:extLst>
           </p:cNvPr>
@@ -10369,7 +10369,7 @@
           <p:cNvPr id="24" name="">
             <a:extLst xmlns:a="http://schemas.openxmlformats.org/drawingml/2006/main">
               <a:ext uri="{FF2B5EF4-FFF2-40B4-BE49-F238E27FC236}">
-                <a16:creationId xmlns:a16="http://schemas.microsoft.com/office/drawing/2014/main" id="{A72799E9-A504-47AB-A09B-C7BF1FFD451E}"/>
+                <a16:creationId xmlns:a16="http://schemas.microsoft.com/office/drawing/2014/main" id="{20883AF1-AFE8-4F0A-B0DD-4EC60B38FE21}"/>
               </a:ext>
             </a:extLst>
           </p:cNvPr>
@@ -10402,7 +10402,7 @@
           <p:cNvPr id="25" name="">
             <a:extLst xmlns:a="http://schemas.openxmlformats.org/drawingml/2006/main">
               <a:ext uri="{FF2B5EF4-FFF2-40B4-BE49-F238E27FC236}">
-                <a16:creationId xmlns:a16="http://schemas.microsoft.com/office/drawing/2014/main" id="{E70FBF2A-EABF-4838-83CB-00181C22A451}"/>
+                <a16:creationId xmlns:a16="http://schemas.microsoft.com/office/drawing/2014/main" id="{E5172D30-2AF7-4E8D-8AEA-0D0E9F2B7DD6}"/>
               </a:ext>
             </a:extLst>
           </p:cNvPr>
@@ -10458,7 +10458,7 @@
           <p:cNvPr id="26" name="">
             <a:extLst xmlns:a="http://schemas.openxmlformats.org/drawingml/2006/main">
               <a:ext uri="{FF2B5EF4-FFF2-40B4-BE49-F238E27FC236}">
-                <a16:creationId xmlns:a16="http://schemas.microsoft.com/office/drawing/2014/main" id="{A5FF1A62-2F9D-4D5B-B239-F87815B9D19F}"/>
+                <a16:creationId xmlns:a16="http://schemas.microsoft.com/office/drawing/2014/main" id="{8D0B89F2-3A7A-4BF9-9396-BA96C4B3B9F9}"/>
               </a:ext>
             </a:extLst>
           </p:cNvPr>
@@ -10514,7 +10514,7 @@
           <p:cNvPr id="27" name="">
             <a:extLst xmlns:a="http://schemas.openxmlformats.org/drawingml/2006/main">
               <a:ext uri="{FF2B5EF4-FFF2-40B4-BE49-F238E27FC236}">
-                <a16:creationId xmlns:a16="http://schemas.microsoft.com/office/drawing/2014/main" id="{84CB9B5A-54AE-41AC-81DC-1E262F6619EA}"/>
+                <a16:creationId xmlns:a16="http://schemas.microsoft.com/office/drawing/2014/main" id="{7422808F-FE08-45C2-8111-AC3CA426A425}"/>
               </a:ext>
             </a:extLst>
           </p:cNvPr>
@@ -10568,7 +10568,7 @@
     </p:spTree>
     <p:extLst>
       <p:ext uri="{BB962C8B-B14F-4D97-AF65-F5344CB8AC3E}">
-        <p14:creationId xmlns:p14="http://schemas.microsoft.com/office/powerpoint/2010/main" val="420955280"/>
+        <p14:creationId xmlns:p14="http://schemas.microsoft.com/office/powerpoint/2010/main" val="631554021"/>
       </p:ext>
     </p:extLst>
   </p:cSld>
@@ -10599,7 +10599,7 @@
           <p:cNvPr id="1" name="">
             <a:extLst xmlns:a="http://schemas.openxmlformats.org/drawingml/2006/main">
               <a:ext uri="{FF2B5EF4-FFF2-40B4-BE49-F238E27FC236}">
-                <a16:creationId xmlns:a16="http://schemas.microsoft.com/office/drawing/2014/main" id="{47C2B13C-4EB4-416A-9675-ABE8118E0A28}"/>
+                <a16:creationId xmlns:a16="http://schemas.microsoft.com/office/drawing/2014/main" id="{F87BD577-DE9D-4090-AB87-FAEB1828F6E7}"/>
               </a:ext>
             </a:extLst>
           </p:cNvPr>
@@ -10632,7 +10632,7 @@
           <p:cNvPr id="2" name="">
             <a:extLst xmlns:a="http://schemas.openxmlformats.org/drawingml/2006/main">
               <a:ext uri="{FF2B5EF4-FFF2-40B4-BE49-F238E27FC236}">
-                <a16:creationId xmlns:a16="http://schemas.microsoft.com/office/drawing/2014/main" id="{C27B16D7-2BCA-4BD3-81ED-0C06632E00F3}"/>
+                <a16:creationId xmlns:a16="http://schemas.microsoft.com/office/drawing/2014/main" id="{3128802D-0E13-4C97-A7DB-93B70F56493F}"/>
               </a:ext>
             </a:extLst>
           </p:cNvPr>
@@ -10665,7 +10665,7 @@
           <p:cNvPr id="3" name="">
             <a:extLst xmlns:a="http://schemas.openxmlformats.org/drawingml/2006/main">
               <a:ext uri="{FF2B5EF4-FFF2-40B4-BE49-F238E27FC236}">
-                <a16:creationId xmlns:a16="http://schemas.microsoft.com/office/drawing/2014/main" id="{BA1D1772-B2B9-4092-A3EC-35912DA3D921}"/>
+                <a16:creationId xmlns:a16="http://schemas.microsoft.com/office/drawing/2014/main" id="{BA1CBC5C-4A88-415D-8204-0ADF5925EE7A}"/>
               </a:ext>
             </a:extLst>
           </p:cNvPr>
@@ -10721,7 +10721,7 @@
           <p:cNvPr id="4" name="">
             <a:extLst xmlns:a="http://schemas.openxmlformats.org/drawingml/2006/main">
               <a:ext uri="{FF2B5EF4-FFF2-40B4-BE49-F238E27FC236}">
-                <a16:creationId xmlns:a16="http://schemas.microsoft.com/office/drawing/2014/main" id="{29C39170-5456-458E-882B-6F0AA33A8F4A}"/>
+                <a16:creationId xmlns:a16="http://schemas.microsoft.com/office/drawing/2014/main" id="{47DA5341-F3FF-423E-8D7D-85D82F9563D2}"/>
               </a:ext>
             </a:extLst>
           </p:cNvPr>
@@ -10777,7 +10777,7 @@
           <p:cNvPr id="5" name="">
             <a:extLst xmlns:a="http://schemas.openxmlformats.org/drawingml/2006/main">
               <a:ext uri="{FF2B5EF4-FFF2-40B4-BE49-F238E27FC236}">
-                <a16:creationId xmlns:a16="http://schemas.microsoft.com/office/drawing/2014/main" id="{35D3F2DC-DF21-4A95-93B1-146AA87C33D3}"/>
+                <a16:creationId xmlns:a16="http://schemas.microsoft.com/office/drawing/2014/main" id="{03B5B765-8FE0-44A7-80D6-76D66578BC14}"/>
               </a:ext>
             </a:extLst>
           </p:cNvPr>
@@ -10833,7 +10833,7 @@
           <p:cNvPr id="6" name="">
             <a:extLst xmlns:a="http://schemas.openxmlformats.org/drawingml/2006/main">
               <a:ext uri="{FF2B5EF4-FFF2-40B4-BE49-F238E27FC236}">
-                <a16:creationId xmlns:a16="http://schemas.microsoft.com/office/drawing/2014/main" id="{B1C9A458-4DCC-4BD0-9629-0B024D70C6D2}"/>
+                <a16:creationId xmlns:a16="http://schemas.microsoft.com/office/drawing/2014/main" id="{641FA10F-CBA5-45BF-9AEF-AA4AA481E98C}"/>
               </a:ext>
             </a:extLst>
           </p:cNvPr>
@@ -10889,7 +10889,7 @@
           <p:cNvPr id="7" name="">
             <a:extLst xmlns:a="http://schemas.openxmlformats.org/drawingml/2006/main">
               <a:ext uri="{FF2B5EF4-FFF2-40B4-BE49-F238E27FC236}">
-                <a16:creationId xmlns:a16="http://schemas.microsoft.com/office/drawing/2014/main" id="{05567F6C-69C4-4C5B-B778-BD6712E66F6C}"/>
+                <a16:creationId xmlns:a16="http://schemas.microsoft.com/office/drawing/2014/main" id="{7C6E3E82-F257-433D-A947-C51B2CAB936F}"/>
               </a:ext>
             </a:extLst>
           </p:cNvPr>
@@ -10922,7 +10922,7 @@
           <p:cNvPr id="8" name="">
             <a:extLst xmlns:a="http://schemas.openxmlformats.org/drawingml/2006/main">
               <a:ext uri="{FF2B5EF4-FFF2-40B4-BE49-F238E27FC236}">
-                <a16:creationId xmlns:a16="http://schemas.microsoft.com/office/drawing/2014/main" id="{9765212B-4896-4A03-8B60-32F2AAAD488E}"/>
+                <a16:creationId xmlns:a16="http://schemas.microsoft.com/office/drawing/2014/main" id="{2649D498-A510-49EA-A3E6-B0A0BA93A8A1}"/>
               </a:ext>
             </a:extLst>
           </p:cNvPr>
@@ -10955,7 +10955,7 @@
           <p:cNvPr id="9" name="">
             <a:extLst xmlns:a="http://schemas.openxmlformats.org/drawingml/2006/main">
               <a:ext uri="{FF2B5EF4-FFF2-40B4-BE49-F238E27FC236}">
-                <a16:creationId xmlns:a16="http://schemas.microsoft.com/office/drawing/2014/main" id="{811DAB24-D02F-4910-A0D7-13B41477C169}"/>
+                <a16:creationId xmlns:a16="http://schemas.microsoft.com/office/drawing/2014/main" id="{EB828FE0-1E73-42AF-B38C-F7F9F93102A1}"/>
               </a:ext>
             </a:extLst>
           </p:cNvPr>
@@ -10988,7 +10988,7 @@
           <p:cNvPr id="10" name="">
             <a:extLst xmlns:a="http://schemas.openxmlformats.org/drawingml/2006/main">
               <a:ext uri="{FF2B5EF4-FFF2-40B4-BE49-F238E27FC236}">
-                <a16:creationId xmlns:a16="http://schemas.microsoft.com/office/drawing/2014/main" id="{F4B6A052-47E9-4BFA-93B4-602897BB3DA3}"/>
+                <a16:creationId xmlns:a16="http://schemas.microsoft.com/office/drawing/2014/main" id="{009ECBB8-8A3E-44F0-A1BD-F19FAA76B120}"/>
               </a:ext>
             </a:extLst>
           </p:cNvPr>
@@ -11044,7 +11044,7 @@
           <p:cNvPr id="11" name="">
             <a:extLst xmlns:a="http://schemas.openxmlformats.org/drawingml/2006/main">
               <a:ext uri="{FF2B5EF4-FFF2-40B4-BE49-F238E27FC236}">
-                <a16:creationId xmlns:a16="http://schemas.microsoft.com/office/drawing/2014/main" id="{AC5217C7-E50D-4274-8E20-9F1771F11E68}"/>
+                <a16:creationId xmlns:a16="http://schemas.microsoft.com/office/drawing/2014/main" id="{F251CEA2-30C7-4F86-80E5-BDFCDEF434D5}"/>
               </a:ext>
             </a:extLst>
           </p:cNvPr>
@@ -11123,7 +11123,7 @@
           <p:cNvPr id="12" name="">
             <a:extLst xmlns:a="http://schemas.openxmlformats.org/drawingml/2006/main">
               <a:ext uri="{FF2B5EF4-FFF2-40B4-BE49-F238E27FC236}">
-                <a16:creationId xmlns:a16="http://schemas.microsoft.com/office/drawing/2014/main" id="{7077BB13-0865-4138-9BD4-CDA348249482}"/>
+                <a16:creationId xmlns:a16="http://schemas.microsoft.com/office/drawing/2014/main" id="{BCE01C19-533E-4EEF-86C8-F641E0074754}"/>
               </a:ext>
             </a:extLst>
           </p:cNvPr>
@@ -11156,7 +11156,7 @@
           <p:cNvPr id="13" name="">
             <a:extLst xmlns:a="http://schemas.openxmlformats.org/drawingml/2006/main">
               <a:ext uri="{FF2B5EF4-FFF2-40B4-BE49-F238E27FC236}">
-                <a16:creationId xmlns:a16="http://schemas.microsoft.com/office/drawing/2014/main" id="{00168725-1D99-43A6-B959-17221EAEC79F}"/>
+                <a16:creationId xmlns:a16="http://schemas.microsoft.com/office/drawing/2014/main" id="{57691F69-0889-4249-8441-F0F84F53E792}"/>
               </a:ext>
             </a:extLst>
           </p:cNvPr>
@@ -11189,7 +11189,7 @@
           <p:cNvPr id="14" name="">
             <a:extLst xmlns:a="http://schemas.openxmlformats.org/drawingml/2006/main">
               <a:ext uri="{FF2B5EF4-FFF2-40B4-BE49-F238E27FC236}">
-                <a16:creationId xmlns:a16="http://schemas.microsoft.com/office/drawing/2014/main" id="{B9C43C70-80BF-40F7-AC96-979C4BFE9067}"/>
+                <a16:creationId xmlns:a16="http://schemas.microsoft.com/office/drawing/2014/main" id="{F800D0E0-4206-48C7-AB50-397BA389CF38}"/>
               </a:ext>
             </a:extLst>
           </p:cNvPr>
@@ -11245,7 +11245,7 @@
           <p:cNvPr id="15" name="">
             <a:extLst xmlns:a="http://schemas.openxmlformats.org/drawingml/2006/main">
               <a:ext uri="{FF2B5EF4-FFF2-40B4-BE49-F238E27FC236}">
-                <a16:creationId xmlns:a16="http://schemas.microsoft.com/office/drawing/2014/main" id="{C6F61FAC-9CE5-412E-A938-06F6CFD8CB65}"/>
+                <a16:creationId xmlns:a16="http://schemas.microsoft.com/office/drawing/2014/main" id="{0F4F9484-93B4-4D8D-99EA-FAEFA35703ED}"/>
               </a:ext>
             </a:extLst>
           </p:cNvPr>
@@ -11324,7 +11324,7 @@
           <p:cNvPr id="16" name="">
             <a:extLst xmlns:a="http://schemas.openxmlformats.org/drawingml/2006/main">
               <a:ext uri="{FF2B5EF4-FFF2-40B4-BE49-F238E27FC236}">
-                <a16:creationId xmlns:a16="http://schemas.microsoft.com/office/drawing/2014/main" id="{11E45CE6-E65A-462B-8921-F9E5F438B0D4}"/>
+                <a16:creationId xmlns:a16="http://schemas.microsoft.com/office/drawing/2014/main" id="{EAD6F6F5-B546-40D8-BDDF-1D0D1227CFC6}"/>
               </a:ext>
             </a:extLst>
           </p:cNvPr>
@@ -11357,7 +11357,7 @@
           <p:cNvPr id="17" name="">
             <a:extLst xmlns:a="http://schemas.openxmlformats.org/drawingml/2006/main">
               <a:ext uri="{FF2B5EF4-FFF2-40B4-BE49-F238E27FC236}">
-                <a16:creationId xmlns:a16="http://schemas.microsoft.com/office/drawing/2014/main" id="{54FBB5AE-6D2D-4CC0-B71E-AF18CB5E86ED}"/>
+                <a16:creationId xmlns:a16="http://schemas.microsoft.com/office/drawing/2014/main" id="{D73560AC-9AC9-41B5-B47D-7A9AA27F1D85}"/>
               </a:ext>
             </a:extLst>
           </p:cNvPr>
@@ -11390,7 +11390,7 @@
           <p:cNvPr id="18" name="">
             <a:extLst xmlns:a="http://schemas.openxmlformats.org/drawingml/2006/main">
               <a:ext uri="{FF2B5EF4-FFF2-40B4-BE49-F238E27FC236}">
-                <a16:creationId xmlns:a16="http://schemas.microsoft.com/office/drawing/2014/main" id="{4C97C1F2-09A7-4F0A-92ED-EFC458E81735}"/>
+                <a16:creationId xmlns:a16="http://schemas.microsoft.com/office/drawing/2014/main" id="{259D9D16-25BB-4AF3-AC71-8D33056D8CAE}"/>
               </a:ext>
             </a:extLst>
           </p:cNvPr>
@@ -11446,7 +11446,7 @@
           <p:cNvPr id="19" name="">
             <a:extLst xmlns:a="http://schemas.openxmlformats.org/drawingml/2006/main">
               <a:ext uri="{FF2B5EF4-FFF2-40B4-BE49-F238E27FC236}">
-                <a16:creationId xmlns:a16="http://schemas.microsoft.com/office/drawing/2014/main" id="{8F37A931-C65A-43EA-9228-462E6F3236F9}"/>
+                <a16:creationId xmlns:a16="http://schemas.microsoft.com/office/drawing/2014/main" id="{D7906195-963E-4473-84FA-001EEF487D8F}"/>
               </a:ext>
             </a:extLst>
           </p:cNvPr>
@@ -11525,7 +11525,7 @@
           <p:cNvPr id="20" name="">
             <a:extLst xmlns:a="http://schemas.openxmlformats.org/drawingml/2006/main">
               <a:ext uri="{FF2B5EF4-FFF2-40B4-BE49-F238E27FC236}">
-                <a16:creationId xmlns:a16="http://schemas.microsoft.com/office/drawing/2014/main" id="{96F48424-121E-48BA-8748-7F898B45A17E}"/>
+                <a16:creationId xmlns:a16="http://schemas.microsoft.com/office/drawing/2014/main" id="{E6867E4F-D76B-4DDD-A0FE-CFD43448399F}"/>
               </a:ext>
             </a:extLst>
           </p:cNvPr>
@@ -11579,7 +11579,7 @@
     </p:spTree>
     <p:extLst>
       <p:ext uri="{BB962C8B-B14F-4D97-AF65-F5344CB8AC3E}">
-        <p14:creationId xmlns:p14="http://schemas.microsoft.com/office/powerpoint/2010/main" val="1533498389"/>
+        <p14:creationId xmlns:p14="http://schemas.microsoft.com/office/powerpoint/2010/main" val="1094702624"/>
       </p:ext>
     </p:extLst>
   </p:cSld>
@@ -11610,7 +11610,7 @@
           <p:cNvPr id="1" name="">
             <a:extLst xmlns:a="http://schemas.openxmlformats.org/drawingml/2006/main">
               <a:ext uri="{FF2B5EF4-FFF2-40B4-BE49-F238E27FC236}">
-                <a16:creationId xmlns:a16="http://schemas.microsoft.com/office/drawing/2014/main" id="{B406A1B6-1BA0-4B52-BE1C-DFE69B8C753E}"/>
+                <a16:creationId xmlns:a16="http://schemas.microsoft.com/office/drawing/2014/main" id="{653591EF-C0CA-404C-A594-EF3D1BFC46F8}"/>
               </a:ext>
             </a:extLst>
           </p:cNvPr>
@@ -11643,7 +11643,7 @@
           <p:cNvPr id="2" name="">
             <a:extLst xmlns:a="http://schemas.openxmlformats.org/drawingml/2006/main">
               <a:ext uri="{FF2B5EF4-FFF2-40B4-BE49-F238E27FC236}">
-                <a16:creationId xmlns:a16="http://schemas.microsoft.com/office/drawing/2014/main" id="{59868382-2BCF-4E0A-A96E-22A2EE4C90C0}"/>
+                <a16:creationId xmlns:a16="http://schemas.microsoft.com/office/drawing/2014/main" id="{504D3ACA-40E8-4EC6-BC3A-B438F0ED4DE2}"/>
               </a:ext>
             </a:extLst>
           </p:cNvPr>
@@ -11676,7 +11676,7 @@
           <p:cNvPr id="3" name="">
             <a:extLst xmlns:a="http://schemas.openxmlformats.org/drawingml/2006/main">
               <a:ext uri="{FF2B5EF4-FFF2-40B4-BE49-F238E27FC236}">
-                <a16:creationId xmlns:a16="http://schemas.microsoft.com/office/drawing/2014/main" id="{03FA90E7-EF3B-470A-B2C5-E43F9F3056B6}"/>
+                <a16:creationId xmlns:a16="http://schemas.microsoft.com/office/drawing/2014/main" id="{14EAD630-C8AF-43A0-80B6-4492421330FE}"/>
               </a:ext>
             </a:extLst>
           </p:cNvPr>
@@ -11732,7 +11732,7 @@
           <p:cNvPr id="4" name="">
             <a:extLst xmlns:a="http://schemas.openxmlformats.org/drawingml/2006/main">
               <a:ext uri="{FF2B5EF4-FFF2-40B4-BE49-F238E27FC236}">
-                <a16:creationId xmlns:a16="http://schemas.microsoft.com/office/drawing/2014/main" id="{5BC444F4-52D6-4929-AE47-0EB323F03EDE}"/>
+                <a16:creationId xmlns:a16="http://schemas.microsoft.com/office/drawing/2014/main" id="{884314A6-D650-4E26-99F1-7B4B95C1DC3A}"/>
               </a:ext>
             </a:extLst>
           </p:cNvPr>
@@ -11788,7 +11788,7 @@
           <p:cNvPr id="5" name="">
             <a:extLst xmlns:a="http://schemas.openxmlformats.org/drawingml/2006/main">
               <a:ext uri="{FF2B5EF4-FFF2-40B4-BE49-F238E27FC236}">
-                <a16:creationId xmlns:a16="http://schemas.microsoft.com/office/drawing/2014/main" id="{1E783934-33EF-4399-8AFD-2D76D105810E}"/>
+                <a16:creationId xmlns:a16="http://schemas.microsoft.com/office/drawing/2014/main" id="{D862986F-3C77-44C6-82D5-98F58A911831}"/>
               </a:ext>
             </a:extLst>
           </p:cNvPr>
@@ -11844,7 +11844,7 @@
           <p:cNvPr id="6" name="">
             <a:extLst xmlns:a="http://schemas.openxmlformats.org/drawingml/2006/main">
               <a:ext uri="{FF2B5EF4-FFF2-40B4-BE49-F238E27FC236}">
-                <a16:creationId xmlns:a16="http://schemas.microsoft.com/office/drawing/2014/main" id="{D61CD95A-B91B-4670-9301-8BB70A333FE8}"/>
+                <a16:creationId xmlns:a16="http://schemas.microsoft.com/office/drawing/2014/main" id="{3B77C226-8385-4EF3-84C3-8DBA9C01AED2}"/>
               </a:ext>
             </a:extLst>
           </p:cNvPr>
@@ -11900,7 +11900,7 @@
           <p:cNvPr id="7" name="">
             <a:extLst xmlns:a="http://schemas.openxmlformats.org/drawingml/2006/main">
               <a:ext uri="{FF2B5EF4-FFF2-40B4-BE49-F238E27FC236}">
-                <a16:creationId xmlns:a16="http://schemas.microsoft.com/office/drawing/2014/main" id="{4BD043BF-FABE-4AE7-B3A8-76EB91477BE2}"/>
+                <a16:creationId xmlns:a16="http://schemas.microsoft.com/office/drawing/2014/main" id="{E3F334FC-1537-4546-BFD4-771215B47FCE}"/>
               </a:ext>
             </a:extLst>
           </p:cNvPr>
@@ -11933,7 +11933,7 @@
           <p:cNvPr id="8" name="">
             <a:extLst xmlns:a="http://schemas.openxmlformats.org/drawingml/2006/main">
               <a:ext uri="{FF2B5EF4-FFF2-40B4-BE49-F238E27FC236}">
-                <a16:creationId xmlns:a16="http://schemas.microsoft.com/office/drawing/2014/main" id="{796FDA08-5C27-4DD1-AF0B-C19B5C9644FD}"/>
+                <a16:creationId xmlns:a16="http://schemas.microsoft.com/office/drawing/2014/main" id="{4F21332C-D31D-441F-97BD-C02D2F420EF6}"/>
               </a:ext>
             </a:extLst>
           </p:cNvPr>
@@ -11966,7 +11966,7 @@
           <p:cNvPr id="9" name="">
             <a:extLst xmlns:a="http://schemas.openxmlformats.org/drawingml/2006/main">
               <a:ext uri="{FF2B5EF4-FFF2-40B4-BE49-F238E27FC236}">
-                <a16:creationId xmlns:a16="http://schemas.microsoft.com/office/drawing/2014/main" id="{9D3BC1D5-BF4A-452D-BB94-F81A48705D6E}"/>
+                <a16:creationId xmlns:a16="http://schemas.microsoft.com/office/drawing/2014/main" id="{3E1E3293-043A-44F7-A7DD-4613E527D53E}"/>
               </a:ext>
             </a:extLst>
           </p:cNvPr>
@@ -11999,7 +11999,7 @@
           <p:cNvPr id="10" name="">
             <a:extLst xmlns:a="http://schemas.openxmlformats.org/drawingml/2006/main">
               <a:ext uri="{FF2B5EF4-FFF2-40B4-BE49-F238E27FC236}">
-                <a16:creationId xmlns:a16="http://schemas.microsoft.com/office/drawing/2014/main" id="{DE3D3D29-D2F5-43B8-8147-29733B351B09}"/>
+                <a16:creationId xmlns:a16="http://schemas.microsoft.com/office/drawing/2014/main" id="{8F735F71-5A58-4259-8BED-60F137FC1FD6}"/>
               </a:ext>
             </a:extLst>
           </p:cNvPr>
@@ -12055,7 +12055,7 @@
           <p:cNvPr id="11" name="">
             <a:extLst xmlns:a="http://schemas.openxmlformats.org/drawingml/2006/main">
               <a:ext uri="{FF2B5EF4-FFF2-40B4-BE49-F238E27FC236}">
-                <a16:creationId xmlns:a16="http://schemas.microsoft.com/office/drawing/2014/main" id="{D12B6065-DE09-488F-A008-5EE6466F7CCE}"/>
+                <a16:creationId xmlns:a16="http://schemas.microsoft.com/office/drawing/2014/main" id="{EDDA7C30-B342-496E-9E7E-477A8A88B756}"/>
               </a:ext>
             </a:extLst>
           </p:cNvPr>
@@ -12226,7 +12226,7 @@
           <p:cNvPr id="12" name="">
             <a:extLst xmlns:a="http://schemas.openxmlformats.org/drawingml/2006/main">
               <a:ext uri="{FF2B5EF4-FFF2-40B4-BE49-F238E27FC236}">
-                <a16:creationId xmlns:a16="http://schemas.microsoft.com/office/drawing/2014/main" id="{D8A4CAA5-24BE-4B69-9A6C-BBC0CA938735}"/>
+                <a16:creationId xmlns:a16="http://schemas.microsoft.com/office/drawing/2014/main" id="{1EE457E8-D730-406F-88B6-128AD8A7A720}"/>
               </a:ext>
             </a:extLst>
           </p:cNvPr>
@@ -12259,7 +12259,7 @@
           <p:cNvPr id="13" name="">
             <a:extLst xmlns:a="http://schemas.openxmlformats.org/drawingml/2006/main">
               <a:ext uri="{FF2B5EF4-FFF2-40B4-BE49-F238E27FC236}">
-                <a16:creationId xmlns:a16="http://schemas.microsoft.com/office/drawing/2014/main" id="{E6CFC906-DFB0-43D7-881A-7AA1C1F63F7E}"/>
+                <a16:creationId xmlns:a16="http://schemas.microsoft.com/office/drawing/2014/main" id="{E9D34361-B2A3-40EC-A3E4-859A054E09F7}"/>
               </a:ext>
             </a:extLst>
           </p:cNvPr>
@@ -12292,7 +12292,7 @@
           <p:cNvPr id="14" name="">
             <a:extLst xmlns:a="http://schemas.openxmlformats.org/drawingml/2006/main">
               <a:ext uri="{FF2B5EF4-FFF2-40B4-BE49-F238E27FC236}">
-                <a16:creationId xmlns:a16="http://schemas.microsoft.com/office/drawing/2014/main" id="{AA9A4F0E-C63E-4295-973A-B6260D0EBD00}"/>
+                <a16:creationId xmlns:a16="http://schemas.microsoft.com/office/drawing/2014/main" id="{56F1AD78-0A44-4788-BF93-CCFD34B84B9C}"/>
               </a:ext>
             </a:extLst>
           </p:cNvPr>
@@ -12348,7 +12348,7 @@
           <p:cNvPr id="15" name="">
             <a:extLst xmlns:a="http://schemas.openxmlformats.org/drawingml/2006/main">
               <a:ext uri="{FF2B5EF4-FFF2-40B4-BE49-F238E27FC236}">
-                <a16:creationId xmlns:a16="http://schemas.microsoft.com/office/drawing/2014/main" id="{04AEFCBF-4220-4479-8F67-94CDCD766C26}"/>
+                <a16:creationId xmlns:a16="http://schemas.microsoft.com/office/drawing/2014/main" id="{4BB93E67-4126-4158-8429-6FADE4FF5E5D}"/>
               </a:ext>
             </a:extLst>
           </p:cNvPr>
@@ -12450,7 +12450,7 @@
           <p:cNvPr id="16" name="">
             <a:extLst xmlns:a="http://schemas.openxmlformats.org/drawingml/2006/main">
               <a:ext uri="{FF2B5EF4-FFF2-40B4-BE49-F238E27FC236}">
-                <a16:creationId xmlns:a16="http://schemas.microsoft.com/office/drawing/2014/main" id="{F525D118-6111-4759-97E7-76C11E550C30}"/>
+                <a16:creationId xmlns:a16="http://schemas.microsoft.com/office/drawing/2014/main" id="{1BE96652-5D6D-4EFF-8137-B74D253430A9}"/>
               </a:ext>
             </a:extLst>
           </p:cNvPr>
@@ -12483,7 +12483,7 @@
           <p:cNvPr id="17" name="">
             <a:extLst xmlns:a="http://schemas.openxmlformats.org/drawingml/2006/main">
               <a:ext uri="{FF2B5EF4-FFF2-40B4-BE49-F238E27FC236}">
-                <a16:creationId xmlns:a16="http://schemas.microsoft.com/office/drawing/2014/main" id="{80761FB2-C7B9-4847-887A-142CD6E9DB5C}"/>
+                <a16:creationId xmlns:a16="http://schemas.microsoft.com/office/drawing/2014/main" id="{C664C2EE-ABE1-4940-B213-2FFD32D36C8E}"/>
               </a:ext>
             </a:extLst>
           </p:cNvPr>
@@ -12516,7 +12516,7 @@
           <p:cNvPr id="18" name="">
             <a:extLst xmlns:a="http://schemas.openxmlformats.org/drawingml/2006/main">
               <a:ext uri="{FF2B5EF4-FFF2-40B4-BE49-F238E27FC236}">
-                <a16:creationId xmlns:a16="http://schemas.microsoft.com/office/drawing/2014/main" id="{0B9B7683-7712-41CA-89E6-5BD2ECAA5C52}"/>
+                <a16:creationId xmlns:a16="http://schemas.microsoft.com/office/drawing/2014/main" id="{D91310F0-613C-4593-AFE3-7E17981E407F}"/>
               </a:ext>
             </a:extLst>
           </p:cNvPr>
@@ -12572,7 +12572,7 @@
           <p:cNvPr id="19" name="">
             <a:extLst xmlns:a="http://schemas.openxmlformats.org/drawingml/2006/main">
               <a:ext uri="{FF2B5EF4-FFF2-40B4-BE49-F238E27FC236}">
-                <a16:creationId xmlns:a16="http://schemas.microsoft.com/office/drawing/2014/main" id="{55888B44-7A9B-4591-B512-695882684373}"/>
+                <a16:creationId xmlns:a16="http://schemas.microsoft.com/office/drawing/2014/main" id="{373BD857-F8FB-4C14-9191-8C2A20D47AA8}"/>
               </a:ext>
             </a:extLst>
           </p:cNvPr>
@@ -12651,7 +12651,7 @@
           <p:cNvPr id="20" name="">
             <a:extLst xmlns:a="http://schemas.openxmlformats.org/drawingml/2006/main">
               <a:ext uri="{FF2B5EF4-FFF2-40B4-BE49-F238E27FC236}">
-                <a16:creationId xmlns:a16="http://schemas.microsoft.com/office/drawing/2014/main" id="{5DD2D22C-4B15-4625-B570-3D6481CF70C7}"/>
+                <a16:creationId xmlns:a16="http://schemas.microsoft.com/office/drawing/2014/main" id="{6AB886F6-D36A-41E6-BE82-361CA27C4C07}"/>
               </a:ext>
             </a:extLst>
           </p:cNvPr>
@@ -12684,7 +12684,7 @@
           <p:cNvPr id="21" name="">
             <a:extLst xmlns:a="http://schemas.openxmlformats.org/drawingml/2006/main">
               <a:ext uri="{FF2B5EF4-FFF2-40B4-BE49-F238E27FC236}">
-                <a16:creationId xmlns:a16="http://schemas.microsoft.com/office/drawing/2014/main" id="{75275E27-2D7F-4F42-A457-D6FEFF6142F5}"/>
+                <a16:creationId xmlns:a16="http://schemas.microsoft.com/office/drawing/2014/main" id="{8F106849-E557-4A01-9C69-AA04D84C32D9}"/>
               </a:ext>
             </a:extLst>
           </p:cNvPr>
@@ -12740,7 +12740,7 @@
           <p:cNvPr id="22" name="">
             <a:extLst xmlns:a="http://schemas.openxmlformats.org/drawingml/2006/main">
               <a:ext uri="{FF2B5EF4-FFF2-40B4-BE49-F238E27FC236}">
-                <a16:creationId xmlns:a16="http://schemas.microsoft.com/office/drawing/2014/main" id="{0A2142A4-81F7-4816-B947-D9DF5E934530}"/>
+                <a16:creationId xmlns:a16="http://schemas.microsoft.com/office/drawing/2014/main" id="{3BC53F10-8979-46E6-9FB8-4F32FD849A23}"/>
               </a:ext>
             </a:extLst>
           </p:cNvPr>
@@ -12796,7 +12796,7 @@
           <p:cNvPr id="23" name="">
             <a:extLst xmlns:a="http://schemas.openxmlformats.org/drawingml/2006/main">
               <a:ext uri="{FF2B5EF4-FFF2-40B4-BE49-F238E27FC236}">
-                <a16:creationId xmlns:a16="http://schemas.microsoft.com/office/drawing/2014/main" id="{D76956E6-37EA-43FD-95A7-7FFD10A3F138}"/>
+                <a16:creationId xmlns:a16="http://schemas.microsoft.com/office/drawing/2014/main" id="{2CEF1701-1932-44BB-BBC7-DD9F302A5B48}"/>
               </a:ext>
             </a:extLst>
           </p:cNvPr>
@@ -12829,7 +12829,7 @@
           <p:cNvPr id="24" name="">
             <a:extLst xmlns:a="http://schemas.openxmlformats.org/drawingml/2006/main">
               <a:ext uri="{FF2B5EF4-FFF2-40B4-BE49-F238E27FC236}">
-                <a16:creationId xmlns:a16="http://schemas.microsoft.com/office/drawing/2014/main" id="{DAB2CC8E-BE2D-4650-8EC8-705DF82C2B21}"/>
+                <a16:creationId xmlns:a16="http://schemas.microsoft.com/office/drawing/2014/main" id="{8AF35481-084D-498B-905C-011565FA9133}"/>
               </a:ext>
             </a:extLst>
           </p:cNvPr>
@@ -12885,7 +12885,7 @@
           <p:cNvPr id="25" name="">
             <a:extLst xmlns:a="http://schemas.openxmlformats.org/drawingml/2006/main">
               <a:ext uri="{FF2B5EF4-FFF2-40B4-BE49-F238E27FC236}">
-                <a16:creationId xmlns:a16="http://schemas.microsoft.com/office/drawing/2014/main" id="{D3C37EF7-3197-4E02-9FA7-67959AC81A32}"/>
+                <a16:creationId xmlns:a16="http://schemas.microsoft.com/office/drawing/2014/main" id="{351F8526-8473-4230-9576-6A91D7CCFA2B}"/>
               </a:ext>
             </a:extLst>
           </p:cNvPr>
@@ -12941,7 +12941,7 @@
           <p:cNvPr id="26" name="">
             <a:extLst xmlns:a="http://schemas.openxmlformats.org/drawingml/2006/main">
               <a:ext uri="{FF2B5EF4-FFF2-40B4-BE49-F238E27FC236}">
-                <a16:creationId xmlns:a16="http://schemas.microsoft.com/office/drawing/2014/main" id="{3B149EB0-31FB-4497-A849-DFA12FC6D900}"/>
+                <a16:creationId xmlns:a16="http://schemas.microsoft.com/office/drawing/2014/main" id="{52DBA4ED-F860-425A-90BA-885563CF424E}"/>
               </a:ext>
             </a:extLst>
           </p:cNvPr>
@@ -12974,7 +12974,7 @@
           <p:cNvPr id="27" name="">
             <a:extLst xmlns:a="http://schemas.openxmlformats.org/drawingml/2006/main">
               <a:ext uri="{FF2B5EF4-FFF2-40B4-BE49-F238E27FC236}">
-                <a16:creationId xmlns:a16="http://schemas.microsoft.com/office/drawing/2014/main" id="{AF96AD35-E84E-4746-B3D5-E2FEEC84FA7C}"/>
+                <a16:creationId xmlns:a16="http://schemas.microsoft.com/office/drawing/2014/main" id="{EFADC059-CF88-49C2-9D4A-0EEC2014D70C}"/>
               </a:ext>
             </a:extLst>
           </p:cNvPr>
@@ -13030,7 +13030,7 @@
           <p:cNvPr id="28" name="">
             <a:extLst xmlns:a="http://schemas.openxmlformats.org/drawingml/2006/main">
               <a:ext uri="{FF2B5EF4-FFF2-40B4-BE49-F238E27FC236}">
-                <a16:creationId xmlns:a16="http://schemas.microsoft.com/office/drawing/2014/main" id="{9F186452-4AA7-4154-9E23-D3408841E098}"/>
+                <a16:creationId xmlns:a16="http://schemas.microsoft.com/office/drawing/2014/main" id="{C7DBD82E-1417-4F85-9C2D-3B83C9B7C1D0}"/>
               </a:ext>
             </a:extLst>
           </p:cNvPr>
@@ -13084,7 +13084,7 @@
     </p:spTree>
     <p:extLst>
       <p:ext uri="{BB962C8B-B14F-4D97-AF65-F5344CB8AC3E}">
-        <p14:creationId xmlns:p14="http://schemas.microsoft.com/office/powerpoint/2010/main" val="577864127"/>
+        <p14:creationId xmlns:p14="http://schemas.microsoft.com/office/powerpoint/2010/main" val="1070138550"/>
       </p:ext>
     </p:extLst>
   </p:cSld>
@@ -13115,7 +13115,7 @@
           <p:cNvPr id="1" name="">
             <a:extLst xmlns:a="http://schemas.openxmlformats.org/drawingml/2006/main">
               <a:ext uri="{FF2B5EF4-FFF2-40B4-BE49-F238E27FC236}">
-                <a16:creationId xmlns:a16="http://schemas.microsoft.com/office/drawing/2014/main" id="{2D1DAF2A-1567-4543-97E2-6EE6C9EB4EBD}"/>
+                <a16:creationId xmlns:a16="http://schemas.microsoft.com/office/drawing/2014/main" id="{5BC2588B-EB95-4362-B4EB-9789B2028C8C}"/>
               </a:ext>
             </a:extLst>
           </p:cNvPr>
@@ -13148,7 +13148,7 @@
           <p:cNvPr id="2" name="">
             <a:extLst xmlns:a="http://schemas.openxmlformats.org/drawingml/2006/main">
               <a:ext uri="{FF2B5EF4-FFF2-40B4-BE49-F238E27FC236}">
-                <a16:creationId xmlns:a16="http://schemas.microsoft.com/office/drawing/2014/main" id="{0115225A-5212-43CD-9516-D4381D561A5C}"/>
+                <a16:creationId xmlns:a16="http://schemas.microsoft.com/office/drawing/2014/main" id="{F92BAE75-046B-4BAB-9CF5-B71F0DE430E7}"/>
               </a:ext>
             </a:extLst>
           </p:cNvPr>
@@ -13181,7 +13181,7 @@
           <p:cNvPr id="3" name="">
             <a:extLst xmlns:a="http://schemas.openxmlformats.org/drawingml/2006/main">
               <a:ext uri="{FF2B5EF4-FFF2-40B4-BE49-F238E27FC236}">
-                <a16:creationId xmlns:a16="http://schemas.microsoft.com/office/drawing/2014/main" id="{677E8ADB-9612-45B4-8779-8F7BBC0CADBC}"/>
+                <a16:creationId xmlns:a16="http://schemas.microsoft.com/office/drawing/2014/main" id="{BAE99156-A102-4420-A0A9-E32C9D935265}"/>
               </a:ext>
             </a:extLst>
           </p:cNvPr>
@@ -13237,7 +13237,7 @@
           <p:cNvPr id="4" name="">
             <a:extLst xmlns:a="http://schemas.openxmlformats.org/drawingml/2006/main">
               <a:ext uri="{FF2B5EF4-FFF2-40B4-BE49-F238E27FC236}">
-                <a16:creationId xmlns:a16="http://schemas.microsoft.com/office/drawing/2014/main" id="{9CD0BFD4-AB8A-46BE-8916-9A0C629945E1}"/>
+                <a16:creationId xmlns:a16="http://schemas.microsoft.com/office/drawing/2014/main" id="{03DDE888-DA1A-4C80-BCAD-736ABA075B96}"/>
               </a:ext>
             </a:extLst>
           </p:cNvPr>
@@ -13293,7 +13293,7 @@
           <p:cNvPr id="5" name="">
             <a:extLst xmlns:a="http://schemas.openxmlformats.org/drawingml/2006/main">
               <a:ext uri="{FF2B5EF4-FFF2-40B4-BE49-F238E27FC236}">
-                <a16:creationId xmlns:a16="http://schemas.microsoft.com/office/drawing/2014/main" id="{92FF3807-8D74-4567-A48A-54BB04B4AF4B}"/>
+                <a16:creationId xmlns:a16="http://schemas.microsoft.com/office/drawing/2014/main" id="{DC1658AF-1093-42A3-BB6A-BD3502462B95}"/>
               </a:ext>
             </a:extLst>
           </p:cNvPr>
@@ -13349,7 +13349,7 @@
           <p:cNvPr id="6" name="">
             <a:extLst xmlns:a="http://schemas.openxmlformats.org/drawingml/2006/main">
               <a:ext uri="{FF2B5EF4-FFF2-40B4-BE49-F238E27FC236}">
-                <a16:creationId xmlns:a16="http://schemas.microsoft.com/office/drawing/2014/main" id="{114D5046-CCBE-40AB-A8B1-8A140B4ADE6E}"/>
+                <a16:creationId xmlns:a16="http://schemas.microsoft.com/office/drawing/2014/main" id="{828D78B2-A2DB-476A-9CB1-81092A7CC917}"/>
               </a:ext>
             </a:extLst>
           </p:cNvPr>
@@ -13405,7 +13405,7 @@
           <p:cNvPr id="7" name="">
             <a:extLst xmlns:a="http://schemas.openxmlformats.org/drawingml/2006/main">
               <a:ext uri="{FF2B5EF4-FFF2-40B4-BE49-F238E27FC236}">
-                <a16:creationId xmlns:a16="http://schemas.microsoft.com/office/drawing/2014/main" id="{39825EE3-57A5-41D7-962A-2724F382945C}"/>
+                <a16:creationId xmlns:a16="http://schemas.microsoft.com/office/drawing/2014/main" id="{FDD8B463-3DDD-4F9B-8303-C7CF49E0A3C1}"/>
               </a:ext>
             </a:extLst>
           </p:cNvPr>
@@ -13438,7 +13438,7 @@
           <p:cNvPr id="8" name="">
             <a:extLst xmlns:a="http://schemas.openxmlformats.org/drawingml/2006/main">
               <a:ext uri="{FF2B5EF4-FFF2-40B4-BE49-F238E27FC236}">
-                <a16:creationId xmlns:a16="http://schemas.microsoft.com/office/drawing/2014/main" id="{B2271E3B-BEEB-4FD2-B2C7-DF9FEC4B4038}"/>
+                <a16:creationId xmlns:a16="http://schemas.microsoft.com/office/drawing/2014/main" id="{B91C6A74-DBB0-47B2-AE51-78C869DA65DF}"/>
               </a:ext>
             </a:extLst>
           </p:cNvPr>
@@ -13471,7 +13471,7 @@
           <p:cNvPr id="9" name="">
             <a:extLst xmlns:a="http://schemas.openxmlformats.org/drawingml/2006/main">
               <a:ext uri="{FF2B5EF4-FFF2-40B4-BE49-F238E27FC236}">
-                <a16:creationId xmlns:a16="http://schemas.microsoft.com/office/drawing/2014/main" id="{1C441DC9-A94A-4DD7-87E2-5A528204EF21}"/>
+                <a16:creationId xmlns:a16="http://schemas.microsoft.com/office/drawing/2014/main" id="{A8F65082-B640-4342-946D-023DAAA2FEB9}"/>
               </a:ext>
             </a:extLst>
           </p:cNvPr>
@@ -13504,7 +13504,7 @@
           <p:cNvPr id="10" name="">
             <a:extLst xmlns:a="http://schemas.openxmlformats.org/drawingml/2006/main">
               <a:ext uri="{FF2B5EF4-FFF2-40B4-BE49-F238E27FC236}">
-                <a16:creationId xmlns:a16="http://schemas.microsoft.com/office/drawing/2014/main" id="{822D6405-1ED1-46BC-ABC2-F627F60A8097}"/>
+                <a16:creationId xmlns:a16="http://schemas.microsoft.com/office/drawing/2014/main" id="{A272B40F-D66B-4437-AAB5-BB624F530218}"/>
               </a:ext>
             </a:extLst>
           </p:cNvPr>
@@ -13560,7 +13560,7 @@
           <p:cNvPr id="11" name="">
             <a:extLst xmlns:a="http://schemas.openxmlformats.org/drawingml/2006/main">
               <a:ext uri="{FF2B5EF4-FFF2-40B4-BE49-F238E27FC236}">
-                <a16:creationId xmlns:a16="http://schemas.microsoft.com/office/drawing/2014/main" id="{928CC804-7625-4768-82E0-5051AE87F690}"/>
+                <a16:creationId xmlns:a16="http://schemas.microsoft.com/office/drawing/2014/main" id="{EC6DF207-F923-4F6D-8D95-94EAC295EEBA}"/>
               </a:ext>
             </a:extLst>
           </p:cNvPr>
@@ -13616,7 +13616,7 @@
           <p:cNvPr id="12" name="">
             <a:extLst xmlns:a="http://schemas.openxmlformats.org/drawingml/2006/main">
               <a:ext uri="{FF2B5EF4-FFF2-40B4-BE49-F238E27FC236}">
-                <a16:creationId xmlns:a16="http://schemas.microsoft.com/office/drawing/2014/main" id="{2C709D87-24E0-4EFA-950D-69E854EBF172}"/>
+                <a16:creationId xmlns:a16="http://schemas.microsoft.com/office/drawing/2014/main" id="{BA11076A-E89F-497E-986E-CAE7ECCA4799}"/>
               </a:ext>
             </a:extLst>
           </p:cNvPr>
@@ -13649,7 +13649,7 @@
           <p:cNvPr id="13" name="">
             <a:extLst xmlns:a="http://schemas.openxmlformats.org/drawingml/2006/main">
               <a:ext uri="{FF2B5EF4-FFF2-40B4-BE49-F238E27FC236}">
-                <a16:creationId xmlns:a16="http://schemas.microsoft.com/office/drawing/2014/main" id="{4759A79D-6711-4D12-B336-B011D262539F}"/>
+                <a16:creationId xmlns:a16="http://schemas.microsoft.com/office/drawing/2014/main" id="{8D5EC285-E82C-4A05-9AD4-7181487B9E32}"/>
               </a:ext>
             </a:extLst>
           </p:cNvPr>
@@ -13682,7 +13682,7 @@
           <p:cNvPr id="14" name="">
             <a:extLst xmlns:a="http://schemas.openxmlformats.org/drawingml/2006/main">
               <a:ext uri="{FF2B5EF4-FFF2-40B4-BE49-F238E27FC236}">
-                <a16:creationId xmlns:a16="http://schemas.microsoft.com/office/drawing/2014/main" id="{030194A8-054C-40CC-9EFF-D77C06289993}"/>
+                <a16:creationId xmlns:a16="http://schemas.microsoft.com/office/drawing/2014/main" id="{385FAAC7-3BB2-4286-B3CC-CC7BF60BCE14}"/>
               </a:ext>
             </a:extLst>
           </p:cNvPr>
@@ -13738,7 +13738,7 @@
           <p:cNvPr id="15" name="">
             <a:extLst xmlns:a="http://schemas.openxmlformats.org/drawingml/2006/main">
               <a:ext uri="{FF2B5EF4-FFF2-40B4-BE49-F238E27FC236}">
-                <a16:creationId xmlns:a16="http://schemas.microsoft.com/office/drawing/2014/main" id="{EA34257F-7E05-44B4-9FF7-6BD5F43681ED}"/>
+                <a16:creationId xmlns:a16="http://schemas.microsoft.com/office/drawing/2014/main" id="{0BB38AC4-3AC0-4122-B350-197B77585B05}"/>
               </a:ext>
             </a:extLst>
           </p:cNvPr>
@@ -13817,7 +13817,7 @@
           <p:cNvPr id="16" name="">
             <a:extLst xmlns:a="http://schemas.openxmlformats.org/drawingml/2006/main">
               <a:ext uri="{FF2B5EF4-FFF2-40B4-BE49-F238E27FC236}">
-                <a16:creationId xmlns:a16="http://schemas.microsoft.com/office/drawing/2014/main" id="{00AB2092-0ACB-49C8-B9C0-5FE88BEFAFD3}"/>
+                <a16:creationId xmlns:a16="http://schemas.microsoft.com/office/drawing/2014/main" id="{2CE79539-AE66-415C-A675-74AF89B90EA3}"/>
               </a:ext>
             </a:extLst>
           </p:cNvPr>
@@ -13850,7 +13850,7 @@
           <p:cNvPr id="17" name="">
             <a:extLst xmlns:a="http://schemas.openxmlformats.org/drawingml/2006/main">
               <a:ext uri="{FF2B5EF4-FFF2-40B4-BE49-F238E27FC236}">
-                <a16:creationId xmlns:a16="http://schemas.microsoft.com/office/drawing/2014/main" id="{B67E80AE-86BB-474A-B436-BB985F61619E}"/>
+                <a16:creationId xmlns:a16="http://schemas.microsoft.com/office/drawing/2014/main" id="{2605337A-50FF-43E4-B296-5AEF2572577B}"/>
               </a:ext>
             </a:extLst>
           </p:cNvPr>
@@ -13883,7 +13883,7 @@
           <p:cNvPr id="18" name="">
             <a:extLst xmlns:a="http://schemas.openxmlformats.org/drawingml/2006/main">
               <a:ext uri="{FF2B5EF4-FFF2-40B4-BE49-F238E27FC236}">
-                <a16:creationId xmlns:a16="http://schemas.microsoft.com/office/drawing/2014/main" id="{10DC660F-C0F3-4499-9FB1-BB9DA6BACA9C}"/>
+                <a16:creationId xmlns:a16="http://schemas.microsoft.com/office/drawing/2014/main" id="{4C138EC5-C120-4959-957B-DC9C8EBB62E7}"/>
               </a:ext>
             </a:extLst>
           </p:cNvPr>
@@ -13939,7 +13939,7 @@
           <p:cNvPr id="19" name="">
             <a:extLst xmlns:a="http://schemas.openxmlformats.org/drawingml/2006/main">
               <a:ext uri="{FF2B5EF4-FFF2-40B4-BE49-F238E27FC236}">
-                <a16:creationId xmlns:a16="http://schemas.microsoft.com/office/drawing/2014/main" id="{3C2DC7D4-9411-4E73-B33A-58996E180E93}"/>
+                <a16:creationId xmlns:a16="http://schemas.microsoft.com/office/drawing/2014/main" id="{E5CC26C8-F74E-4618-B658-5293833A853F}"/>
               </a:ext>
             </a:extLst>
           </p:cNvPr>
@@ -13995,7 +13995,7 @@
           <p:cNvPr id="20" name="">
             <a:extLst xmlns:a="http://schemas.openxmlformats.org/drawingml/2006/main">
               <a:ext uri="{FF2B5EF4-FFF2-40B4-BE49-F238E27FC236}">
-                <a16:creationId xmlns:a16="http://schemas.microsoft.com/office/drawing/2014/main" id="{EB039FEB-557A-41F4-9D64-6E212D9EB9B4}"/>
+                <a16:creationId xmlns:a16="http://schemas.microsoft.com/office/drawing/2014/main" id="{60310E39-79A3-478D-B60B-18779E8227EE}"/>
               </a:ext>
             </a:extLst>
           </p:cNvPr>
@@ -14049,7 +14049,7 @@
     </p:spTree>
     <p:extLst>
       <p:ext uri="{BB962C8B-B14F-4D97-AF65-F5344CB8AC3E}">
-        <p14:creationId xmlns:p14="http://schemas.microsoft.com/office/powerpoint/2010/main" val="1649194805"/>
+        <p14:creationId xmlns:p14="http://schemas.microsoft.com/office/powerpoint/2010/main" val="1163604342"/>
       </p:ext>
     </p:extLst>
   </p:cSld>
@@ -14080,7 +14080,7 @@
           <p:cNvPr id="1" name="">
             <a:extLst xmlns:a="http://schemas.openxmlformats.org/drawingml/2006/main">
               <a:ext uri="{FF2B5EF4-FFF2-40B4-BE49-F238E27FC236}">
-                <a16:creationId xmlns:a16="http://schemas.microsoft.com/office/drawing/2014/main" id="{5429A647-A363-4351-A651-8B4B176BE3B8}"/>
+                <a16:creationId xmlns:a16="http://schemas.microsoft.com/office/drawing/2014/main" id="{17CEC656-B096-4C7B-ACB0-62E92D9FCD6D}"/>
               </a:ext>
             </a:extLst>
           </p:cNvPr>
@@ -14113,7 +14113,7 @@
           <p:cNvPr id="2" name="">
             <a:extLst xmlns:a="http://schemas.openxmlformats.org/drawingml/2006/main">
               <a:ext uri="{FF2B5EF4-FFF2-40B4-BE49-F238E27FC236}">
-                <a16:creationId xmlns:a16="http://schemas.microsoft.com/office/drawing/2014/main" id="{9DB16E67-8CC2-47B3-99E8-80946A02A777}"/>
+                <a16:creationId xmlns:a16="http://schemas.microsoft.com/office/drawing/2014/main" id="{C4587ABB-A8B2-47EE-992F-9FDB466A9684}"/>
               </a:ext>
             </a:extLst>
           </p:cNvPr>
@@ -14146,7 +14146,7 @@
           <p:cNvPr id="3" name="">
             <a:extLst xmlns:a="http://schemas.openxmlformats.org/drawingml/2006/main">
               <a:ext uri="{FF2B5EF4-FFF2-40B4-BE49-F238E27FC236}">
-                <a16:creationId xmlns:a16="http://schemas.microsoft.com/office/drawing/2014/main" id="{56AE48AC-7144-4EAB-B337-34B023396436}"/>
+                <a16:creationId xmlns:a16="http://schemas.microsoft.com/office/drawing/2014/main" id="{3AB9647A-AEC8-4552-B8D2-6C98905E7944}"/>
               </a:ext>
             </a:extLst>
           </p:cNvPr>
@@ -14202,7 +14202,7 @@
           <p:cNvPr id="4" name="">
             <a:extLst xmlns:a="http://schemas.openxmlformats.org/drawingml/2006/main">
               <a:ext uri="{FF2B5EF4-FFF2-40B4-BE49-F238E27FC236}">
-                <a16:creationId xmlns:a16="http://schemas.microsoft.com/office/drawing/2014/main" id="{28422A9A-D5FB-4DAD-A911-9CE680B8889B}"/>
+                <a16:creationId xmlns:a16="http://schemas.microsoft.com/office/drawing/2014/main" id="{73D4D069-5359-4752-8EC1-A175F56703DA}"/>
               </a:ext>
             </a:extLst>
           </p:cNvPr>
@@ -14258,7 +14258,7 @@
           <p:cNvPr id="5" name="">
             <a:extLst xmlns:a="http://schemas.openxmlformats.org/drawingml/2006/main">
               <a:ext uri="{FF2B5EF4-FFF2-40B4-BE49-F238E27FC236}">
-                <a16:creationId xmlns:a16="http://schemas.microsoft.com/office/drawing/2014/main" id="{169241F5-FB82-4E9C-989F-895C01225522}"/>
+                <a16:creationId xmlns:a16="http://schemas.microsoft.com/office/drawing/2014/main" id="{AEC498F8-F475-4A7E-B22D-F51D0B0FA054}"/>
               </a:ext>
             </a:extLst>
           </p:cNvPr>
@@ -14314,7 +14314,7 @@
           <p:cNvPr id="6" name="">
             <a:extLst xmlns:a="http://schemas.openxmlformats.org/drawingml/2006/main">
               <a:ext uri="{FF2B5EF4-FFF2-40B4-BE49-F238E27FC236}">
-                <a16:creationId xmlns:a16="http://schemas.microsoft.com/office/drawing/2014/main" id="{DE490522-197F-4CF9-AC28-9C72FBBD3286}"/>
+                <a16:creationId xmlns:a16="http://schemas.microsoft.com/office/drawing/2014/main" id="{8101BA4A-3511-4EFA-ABAE-9EB12439CB05}"/>
               </a:ext>
             </a:extLst>
           </p:cNvPr>
@@ -14370,7 +14370,7 @@
           <p:cNvPr id="7" name="">
             <a:extLst xmlns:a="http://schemas.openxmlformats.org/drawingml/2006/main">
               <a:ext uri="{FF2B5EF4-FFF2-40B4-BE49-F238E27FC236}">
-                <a16:creationId xmlns:a16="http://schemas.microsoft.com/office/drawing/2014/main" id="{C1338819-27A8-425F-9A60-1E7AA40876B5}"/>
+                <a16:creationId xmlns:a16="http://schemas.microsoft.com/office/drawing/2014/main" id="{824C20AB-34C6-4600-822D-64D3B630275F}"/>
               </a:ext>
             </a:extLst>
           </p:cNvPr>
@@ -14403,7 +14403,7 @@
           <p:cNvPr id="8" name="">
             <a:extLst xmlns:a="http://schemas.openxmlformats.org/drawingml/2006/main">
               <a:ext uri="{FF2B5EF4-FFF2-40B4-BE49-F238E27FC236}">
-                <a16:creationId xmlns:a16="http://schemas.microsoft.com/office/drawing/2014/main" id="{73C580CA-7929-4F63-8979-23ED3425FA4C}"/>
+                <a16:creationId xmlns:a16="http://schemas.microsoft.com/office/drawing/2014/main" id="{E0EFAA2B-927D-435D-A56C-74B7C0A80A7C}"/>
               </a:ext>
             </a:extLst>
           </p:cNvPr>
@@ -14440,7 +14440,7 @@
           <p:nvPr/>
         </p:nvPicPr>
         <p:blipFill>
-          <a:blip xmlns:r="http://schemas.openxmlformats.org/officeDocument/2006/relationships" xmlns:a="http://schemas.openxmlformats.org/drawingml/2006/main" r:embed="Rea2e40fc4e444ba3"/>
+          <a:blip xmlns:r="http://schemas.openxmlformats.org/officeDocument/2006/relationships" xmlns:a="http://schemas.openxmlformats.org/drawingml/2006/main" r:embed="Rc5a3d47432484829"/>
           <a:stretch xmlns:a="http://schemas.openxmlformats.org/drawingml/2006/main"/>
         </p:blipFill>
         <p:spPr>
@@ -14458,7 +14458,7 @@
           <p:cNvPr id="10" name="">
             <a:extLst xmlns:a="http://schemas.openxmlformats.org/drawingml/2006/main">
               <a:ext uri="{FF2B5EF4-FFF2-40B4-BE49-F238E27FC236}">
-                <a16:creationId xmlns:a16="http://schemas.microsoft.com/office/drawing/2014/main" id="{CF2231AB-D078-4186-A40A-4C2D8750802F}"/>
+                <a16:creationId xmlns:a16="http://schemas.microsoft.com/office/drawing/2014/main" id="{22454E13-41F8-4794-A691-51FE77D03BA1}"/>
               </a:ext>
             </a:extLst>
           </p:cNvPr>
@@ -14491,7 +14491,7 @@
           <p:cNvPr id="11" name="">
             <a:extLst xmlns:a="http://schemas.openxmlformats.org/drawingml/2006/main">
               <a:ext uri="{FF2B5EF4-FFF2-40B4-BE49-F238E27FC236}">
-                <a16:creationId xmlns:a16="http://schemas.microsoft.com/office/drawing/2014/main" id="{694BFBF0-8D62-4BB3-BC29-F0E9C44D810C}"/>
+                <a16:creationId xmlns:a16="http://schemas.microsoft.com/office/drawing/2014/main" id="{3311B710-D438-4796-B987-7F673FBFAD5E}"/>
               </a:ext>
             </a:extLst>
           </p:cNvPr>
@@ -14547,7 +14547,7 @@
           <p:cNvPr id="12" name="">
             <a:extLst xmlns:a="http://schemas.openxmlformats.org/drawingml/2006/main">
               <a:ext uri="{FF2B5EF4-FFF2-40B4-BE49-F238E27FC236}">
-                <a16:creationId xmlns:a16="http://schemas.microsoft.com/office/drawing/2014/main" id="{B73AF764-760C-48E2-9940-6BB4F6411F8C}"/>
+                <a16:creationId xmlns:a16="http://schemas.microsoft.com/office/drawing/2014/main" id="{F0E0F02E-E82C-451B-AF34-10321B3CC8DD}"/>
               </a:ext>
             </a:extLst>
           </p:cNvPr>
@@ -14603,7 +14603,7 @@
           <p:cNvPr id="13" name="">
             <a:extLst xmlns:a="http://schemas.openxmlformats.org/drawingml/2006/main">
               <a:ext uri="{FF2B5EF4-FFF2-40B4-BE49-F238E27FC236}">
-                <a16:creationId xmlns:a16="http://schemas.microsoft.com/office/drawing/2014/main" id="{2FCF52DC-AF92-45D8-9EAB-51D931E482C0}"/>
+                <a16:creationId xmlns:a16="http://schemas.microsoft.com/office/drawing/2014/main" id="{4DE47971-CB4C-4159-B864-294E6287693C}"/>
               </a:ext>
             </a:extLst>
           </p:cNvPr>
@@ -14636,7 +14636,7 @@
           <p:cNvPr id="14" name="">
             <a:extLst xmlns:a="http://schemas.openxmlformats.org/drawingml/2006/main">
               <a:ext uri="{FF2B5EF4-FFF2-40B4-BE49-F238E27FC236}">
-                <a16:creationId xmlns:a16="http://schemas.microsoft.com/office/drawing/2014/main" id="{99833040-5BFB-4C80-B68E-66E323594C14}"/>
+                <a16:creationId xmlns:a16="http://schemas.microsoft.com/office/drawing/2014/main" id="{E1F8B1C3-20D0-46CE-97DF-DB1FA92EDEF4}"/>
               </a:ext>
             </a:extLst>
           </p:cNvPr>
@@ -14692,7 +14692,7 @@
           <p:cNvPr id="15" name="">
             <a:extLst xmlns:a="http://schemas.openxmlformats.org/drawingml/2006/main">
               <a:ext uri="{FF2B5EF4-FFF2-40B4-BE49-F238E27FC236}">
-                <a16:creationId xmlns:a16="http://schemas.microsoft.com/office/drawing/2014/main" id="{068B54AC-A0FC-4FAF-81B6-4146840205D8}"/>
+                <a16:creationId xmlns:a16="http://schemas.microsoft.com/office/drawing/2014/main" id="{8ADBD548-2E65-461D-8E8B-BD4312C8A625}"/>
               </a:ext>
             </a:extLst>
           </p:cNvPr>
@@ -14748,7 +14748,7 @@
           <p:cNvPr id="16" name="">
             <a:extLst xmlns:a="http://schemas.openxmlformats.org/drawingml/2006/main">
               <a:ext uri="{FF2B5EF4-FFF2-40B4-BE49-F238E27FC236}">
-                <a16:creationId xmlns:a16="http://schemas.microsoft.com/office/drawing/2014/main" id="{A9F87B29-AA78-4F36-AD52-F25B03788E8A}"/>
+                <a16:creationId xmlns:a16="http://schemas.microsoft.com/office/drawing/2014/main" id="{22B1009F-11B8-4B72-B45A-E57C67D2EFC8}"/>
               </a:ext>
             </a:extLst>
           </p:cNvPr>
@@ -14781,7 +14781,7 @@
           <p:cNvPr id="17" name="">
             <a:extLst xmlns:a="http://schemas.openxmlformats.org/drawingml/2006/main">
               <a:ext uri="{FF2B5EF4-FFF2-40B4-BE49-F238E27FC236}">
-                <a16:creationId xmlns:a16="http://schemas.microsoft.com/office/drawing/2014/main" id="{CF948CD0-681F-4BB4-85A3-38B3BA0A9391}"/>
+                <a16:creationId xmlns:a16="http://schemas.microsoft.com/office/drawing/2014/main" id="{58BE103A-69D6-4D39-A3AC-B8083F0CF664}"/>
               </a:ext>
             </a:extLst>
           </p:cNvPr>
@@ -14837,7 +14837,7 @@
           <p:cNvPr id="18" name="">
             <a:extLst xmlns:a="http://schemas.openxmlformats.org/drawingml/2006/main">
               <a:ext uri="{FF2B5EF4-FFF2-40B4-BE49-F238E27FC236}">
-                <a16:creationId xmlns:a16="http://schemas.microsoft.com/office/drawing/2014/main" id="{2366106C-BDA4-4DA6-9D51-C433D5344B84}"/>
+                <a16:creationId xmlns:a16="http://schemas.microsoft.com/office/drawing/2014/main" id="{55A2E6B5-EF92-4DE8-97E1-D37F2C38BD8E}"/>
               </a:ext>
             </a:extLst>
           </p:cNvPr>
@@ -14893,7 +14893,7 @@
           <p:cNvPr id="19" name="">
             <a:extLst xmlns:a="http://schemas.openxmlformats.org/drawingml/2006/main">
               <a:ext uri="{FF2B5EF4-FFF2-40B4-BE49-F238E27FC236}">
-                <a16:creationId xmlns:a16="http://schemas.microsoft.com/office/drawing/2014/main" id="{F53428EA-8FC5-4FF0-ADAE-9D868656A044}"/>
+                <a16:creationId xmlns:a16="http://schemas.microsoft.com/office/drawing/2014/main" id="{D712CA25-88D3-4563-B2B2-FE521709C15F}"/>
               </a:ext>
             </a:extLst>
           </p:cNvPr>
@@ -14926,7 +14926,7 @@
           <p:cNvPr id="20" name="">
             <a:extLst xmlns:a="http://schemas.openxmlformats.org/drawingml/2006/main">
               <a:ext uri="{FF2B5EF4-FFF2-40B4-BE49-F238E27FC236}">
-                <a16:creationId xmlns:a16="http://schemas.microsoft.com/office/drawing/2014/main" id="{8E7EA782-CA3A-48BA-AE9F-0B8F9FCC2F8B}"/>
+                <a16:creationId xmlns:a16="http://schemas.microsoft.com/office/drawing/2014/main" id="{EF855CDA-8A34-452B-A01D-3E5353CFCB69}"/>
               </a:ext>
             </a:extLst>
           </p:cNvPr>
@@ -14982,7 +14982,7 @@
           <p:cNvPr id="21" name="">
             <a:extLst xmlns:a="http://schemas.openxmlformats.org/drawingml/2006/main">
               <a:ext uri="{FF2B5EF4-FFF2-40B4-BE49-F238E27FC236}">
-                <a16:creationId xmlns:a16="http://schemas.microsoft.com/office/drawing/2014/main" id="{B502DCF3-85C3-462B-A18D-828DB3E41ED9}"/>
+                <a16:creationId xmlns:a16="http://schemas.microsoft.com/office/drawing/2014/main" id="{C1F2468D-A090-462B-8680-DAF1183CB2C0}"/>
               </a:ext>
             </a:extLst>
           </p:cNvPr>
@@ -15038,7 +15038,7 @@
           <p:cNvPr id="22" name="">
             <a:extLst xmlns:a="http://schemas.openxmlformats.org/drawingml/2006/main">
               <a:ext uri="{FF2B5EF4-FFF2-40B4-BE49-F238E27FC236}">
-                <a16:creationId xmlns:a16="http://schemas.microsoft.com/office/drawing/2014/main" id="{1289554A-91BC-41E6-8B16-7BE0614F37DA}"/>
+                <a16:creationId xmlns:a16="http://schemas.microsoft.com/office/drawing/2014/main" id="{F42BB007-F60C-4CA9-81CD-A0CA79AB3292}"/>
               </a:ext>
             </a:extLst>
           </p:cNvPr>
@@ -15071,7 +15071,7 @@
           <p:cNvPr id="23" name="">
             <a:extLst xmlns:a="http://schemas.openxmlformats.org/drawingml/2006/main">
               <a:ext uri="{FF2B5EF4-FFF2-40B4-BE49-F238E27FC236}">
-                <a16:creationId xmlns:a16="http://schemas.microsoft.com/office/drawing/2014/main" id="{CABCC060-8458-47E1-A730-1AC22A54A84D}"/>
+                <a16:creationId xmlns:a16="http://schemas.microsoft.com/office/drawing/2014/main" id="{44178B46-089A-40E0-9AFD-EEC6E4CABEA5}"/>
               </a:ext>
             </a:extLst>
           </p:cNvPr>
@@ -15104,7 +15104,7 @@
           <p:cNvPr id="24" name="">
             <a:extLst xmlns:a="http://schemas.openxmlformats.org/drawingml/2006/main">
               <a:ext uri="{FF2B5EF4-FFF2-40B4-BE49-F238E27FC236}">
-                <a16:creationId xmlns:a16="http://schemas.microsoft.com/office/drawing/2014/main" id="{A8B159F5-8965-4A39-B7F6-A53B790BAB24}"/>
+                <a16:creationId xmlns:a16="http://schemas.microsoft.com/office/drawing/2014/main" id="{273E1270-1323-4C16-AC6C-C06B83A66786}"/>
               </a:ext>
             </a:extLst>
           </p:cNvPr>
@@ -15160,7 +15160,7 @@
           <p:cNvPr id="25" name="">
             <a:extLst xmlns:a="http://schemas.openxmlformats.org/drawingml/2006/main">
               <a:ext uri="{FF2B5EF4-FFF2-40B4-BE49-F238E27FC236}">
-                <a16:creationId xmlns:a16="http://schemas.microsoft.com/office/drawing/2014/main" id="{6EE38B77-692B-4246-B48E-3FF7CC524ECB}"/>
+                <a16:creationId xmlns:a16="http://schemas.microsoft.com/office/drawing/2014/main" id="{07E36987-3048-4FC1-B4E6-42868FC076B5}"/>
               </a:ext>
             </a:extLst>
           </p:cNvPr>
@@ -15214,7 +15214,7 @@
     </p:spTree>
     <p:extLst>
       <p:ext uri="{BB962C8B-B14F-4D97-AF65-F5344CB8AC3E}">
-        <p14:creationId xmlns:p14="http://schemas.microsoft.com/office/powerpoint/2010/main" val="1539101238"/>
+        <p14:creationId xmlns:p14="http://schemas.microsoft.com/office/powerpoint/2010/main" val="1216686947"/>
       </p:ext>
     </p:extLst>
   </p:cSld>
@@ -15245,7 +15245,7 @@
           <p:cNvPr id="1" name="">
             <a:extLst xmlns:a="http://schemas.openxmlformats.org/drawingml/2006/main">
               <a:ext uri="{FF2B5EF4-FFF2-40B4-BE49-F238E27FC236}">
-                <a16:creationId xmlns:a16="http://schemas.microsoft.com/office/drawing/2014/main" id="{DA551CA3-00F2-436C-807F-A176E061D4F9}"/>
+                <a16:creationId xmlns:a16="http://schemas.microsoft.com/office/drawing/2014/main" id="{C331A500-DF6A-4717-9518-9EA9BF415216}"/>
               </a:ext>
             </a:extLst>
           </p:cNvPr>
@@ -15278,7 +15278,7 @@
           <p:cNvPr id="2" name="">
             <a:extLst xmlns:a="http://schemas.openxmlformats.org/drawingml/2006/main">
               <a:ext uri="{FF2B5EF4-FFF2-40B4-BE49-F238E27FC236}">
-                <a16:creationId xmlns:a16="http://schemas.microsoft.com/office/drawing/2014/main" id="{42EE1C74-73DA-4629-8AD8-883D81E332C7}"/>
+                <a16:creationId xmlns:a16="http://schemas.microsoft.com/office/drawing/2014/main" id="{885B8BF4-1E9B-4B12-8537-1F5A4FC24801}"/>
               </a:ext>
             </a:extLst>
           </p:cNvPr>
@@ -15311,7 +15311,7 @@
           <p:cNvPr id="3" name="">
             <a:extLst xmlns:a="http://schemas.openxmlformats.org/drawingml/2006/main">
               <a:ext uri="{FF2B5EF4-FFF2-40B4-BE49-F238E27FC236}">
-                <a16:creationId xmlns:a16="http://schemas.microsoft.com/office/drawing/2014/main" id="{E1A4F225-72EA-43A4-8BA3-094427996D17}"/>
+                <a16:creationId xmlns:a16="http://schemas.microsoft.com/office/drawing/2014/main" id="{3441F3C4-E57C-4079-A455-94A2A720C0DE}"/>
               </a:ext>
             </a:extLst>
           </p:cNvPr>
@@ -15367,7 +15367,7 @@
           <p:cNvPr id="4" name="">
             <a:extLst xmlns:a="http://schemas.openxmlformats.org/drawingml/2006/main">
               <a:ext uri="{FF2B5EF4-FFF2-40B4-BE49-F238E27FC236}">
-                <a16:creationId xmlns:a16="http://schemas.microsoft.com/office/drawing/2014/main" id="{C675FEC9-2869-4FA7-8ECC-D4714A6C3937}"/>
+                <a16:creationId xmlns:a16="http://schemas.microsoft.com/office/drawing/2014/main" id="{393E5437-42C1-4C56-A439-29B849CFA183}"/>
               </a:ext>
             </a:extLst>
           </p:cNvPr>
@@ -15423,7 +15423,7 @@
           <p:cNvPr id="5" name="">
             <a:extLst xmlns:a="http://schemas.openxmlformats.org/drawingml/2006/main">
               <a:ext uri="{FF2B5EF4-FFF2-40B4-BE49-F238E27FC236}">
-                <a16:creationId xmlns:a16="http://schemas.microsoft.com/office/drawing/2014/main" id="{53C95B64-AC70-4F77-82FE-5376E71C20FB}"/>
+                <a16:creationId xmlns:a16="http://schemas.microsoft.com/office/drawing/2014/main" id="{F2A6A900-45BB-4263-B6A8-E1BB997F615B}"/>
               </a:ext>
             </a:extLst>
           </p:cNvPr>
@@ -15479,7 +15479,7 @@
           <p:cNvPr id="6" name="">
             <a:extLst xmlns:a="http://schemas.openxmlformats.org/drawingml/2006/main">
               <a:ext uri="{FF2B5EF4-FFF2-40B4-BE49-F238E27FC236}">
-                <a16:creationId xmlns:a16="http://schemas.microsoft.com/office/drawing/2014/main" id="{87C3E296-B4C5-4E55-BA1D-6610031B5993}"/>
+                <a16:creationId xmlns:a16="http://schemas.microsoft.com/office/drawing/2014/main" id="{F6C010E4-132D-4AC8-B823-0B6DE6A16B25}"/>
               </a:ext>
             </a:extLst>
           </p:cNvPr>
@@ -15535,7 +15535,7 @@
           <p:cNvPr id="7" name="">
             <a:extLst xmlns:a="http://schemas.openxmlformats.org/drawingml/2006/main">
               <a:ext uri="{FF2B5EF4-FFF2-40B4-BE49-F238E27FC236}">
-                <a16:creationId xmlns:a16="http://schemas.microsoft.com/office/drawing/2014/main" id="{AB26DDC5-10A3-4A7C-8ECC-1EDDC10ECA7D}"/>
+                <a16:creationId xmlns:a16="http://schemas.microsoft.com/office/drawing/2014/main" id="{6ED549EA-6819-4C65-871B-200DE39600FD}"/>
               </a:ext>
             </a:extLst>
           </p:cNvPr>
@@ -15568,7 +15568,7 @@
           <p:cNvPr id="8" name="">
             <a:extLst xmlns:a="http://schemas.openxmlformats.org/drawingml/2006/main">
               <a:ext uri="{FF2B5EF4-FFF2-40B4-BE49-F238E27FC236}">
-                <a16:creationId xmlns:a16="http://schemas.microsoft.com/office/drawing/2014/main" id="{4922F504-F952-451A-84CB-50523C3EA16F}"/>
+                <a16:creationId xmlns:a16="http://schemas.microsoft.com/office/drawing/2014/main" id="{C7A94278-8C3D-416E-961A-5F825424F6DB}"/>
               </a:ext>
             </a:extLst>
           </p:cNvPr>
@@ -15605,7 +15605,7 @@
           <p:nvPr/>
         </p:nvPicPr>
         <p:blipFill>
-          <a:blip xmlns:r="http://schemas.openxmlformats.org/officeDocument/2006/relationships" xmlns:a="http://schemas.openxmlformats.org/drawingml/2006/main" r:embed="Rf53a77e81fab4e1a"/>
+          <a:blip xmlns:r="http://schemas.openxmlformats.org/officeDocument/2006/relationships" xmlns:a="http://schemas.openxmlformats.org/drawingml/2006/main" r:embed="R017feab107ea49e5"/>
           <a:stretch xmlns:a="http://schemas.openxmlformats.org/drawingml/2006/main"/>
         </p:blipFill>
         <p:spPr>
@@ -15623,7 +15623,7 @@
           <p:cNvPr id="10" name="">
             <a:extLst xmlns:a="http://schemas.openxmlformats.org/drawingml/2006/main">
               <a:ext uri="{FF2B5EF4-FFF2-40B4-BE49-F238E27FC236}">
-                <a16:creationId xmlns:a16="http://schemas.microsoft.com/office/drawing/2014/main" id="{32E920E3-F3E4-4E73-A622-0CC1CD7E958F}"/>
+                <a16:creationId xmlns:a16="http://schemas.microsoft.com/office/drawing/2014/main" id="{AC2D89D2-8DA6-4867-A787-ED29DA7483A5}"/>
               </a:ext>
             </a:extLst>
           </p:cNvPr>
@@ -15656,7 +15656,7 @@
           <p:cNvPr id="11" name="">
             <a:extLst xmlns:a="http://schemas.openxmlformats.org/drawingml/2006/main">
               <a:ext uri="{FF2B5EF4-FFF2-40B4-BE49-F238E27FC236}">
-                <a16:creationId xmlns:a16="http://schemas.microsoft.com/office/drawing/2014/main" id="{1FF9BF71-5F58-4F34-BB33-C9892DB80E46}"/>
+                <a16:creationId xmlns:a16="http://schemas.microsoft.com/office/drawing/2014/main" id="{49E79B92-9D8B-4318-A958-033A32EE1815}"/>
               </a:ext>
             </a:extLst>
           </p:cNvPr>
@@ -15712,7 +15712,7 @@
           <p:cNvPr id="12" name="">
             <a:extLst xmlns:a="http://schemas.openxmlformats.org/drawingml/2006/main">
               <a:ext uri="{FF2B5EF4-FFF2-40B4-BE49-F238E27FC236}">
-                <a16:creationId xmlns:a16="http://schemas.microsoft.com/office/drawing/2014/main" id="{769F575A-1474-46DA-B035-65F3A3AC049B}"/>
+                <a16:creationId xmlns:a16="http://schemas.microsoft.com/office/drawing/2014/main" id="{DE5DA238-7339-44DC-84E4-BD2D023FCA50}"/>
               </a:ext>
             </a:extLst>
           </p:cNvPr>
@@ -15768,7 +15768,7 @@
           <p:cNvPr id="13" name="">
             <a:extLst xmlns:a="http://schemas.openxmlformats.org/drawingml/2006/main">
               <a:ext uri="{FF2B5EF4-FFF2-40B4-BE49-F238E27FC236}">
-                <a16:creationId xmlns:a16="http://schemas.microsoft.com/office/drawing/2014/main" id="{B5F3E265-F044-4EC0-943A-B1257F5460DE}"/>
+                <a16:creationId xmlns:a16="http://schemas.microsoft.com/office/drawing/2014/main" id="{D31F4792-B4A5-4173-8F88-20CFBCBF14D3}"/>
               </a:ext>
             </a:extLst>
           </p:cNvPr>
@@ -15801,7 +15801,7 @@
           <p:cNvPr id="14" name="">
             <a:extLst xmlns:a="http://schemas.openxmlformats.org/drawingml/2006/main">
               <a:ext uri="{FF2B5EF4-FFF2-40B4-BE49-F238E27FC236}">
-                <a16:creationId xmlns:a16="http://schemas.microsoft.com/office/drawing/2014/main" id="{B145ECBB-F5F2-4F26-88DB-905A18518419}"/>
+                <a16:creationId xmlns:a16="http://schemas.microsoft.com/office/drawing/2014/main" id="{30415046-29A1-4C10-9880-EA6D69AF74A1}"/>
               </a:ext>
             </a:extLst>
           </p:cNvPr>
@@ -15857,7 +15857,7 @@
           <p:cNvPr id="15" name="">
             <a:extLst xmlns:a="http://schemas.openxmlformats.org/drawingml/2006/main">
               <a:ext uri="{FF2B5EF4-FFF2-40B4-BE49-F238E27FC236}">
-                <a16:creationId xmlns:a16="http://schemas.microsoft.com/office/drawing/2014/main" id="{6CA78037-FAC3-48EB-8162-01468E9F21C2}"/>
+                <a16:creationId xmlns:a16="http://schemas.microsoft.com/office/drawing/2014/main" id="{4D92D81A-A112-4AEA-8D56-C04DD9CEF099}"/>
               </a:ext>
             </a:extLst>
           </p:cNvPr>
@@ -15913,7 +15913,7 @@
           <p:cNvPr id="16" name="">
             <a:extLst xmlns:a="http://schemas.openxmlformats.org/drawingml/2006/main">
               <a:ext uri="{FF2B5EF4-FFF2-40B4-BE49-F238E27FC236}">
-                <a16:creationId xmlns:a16="http://schemas.microsoft.com/office/drawing/2014/main" id="{B9AF4679-E083-4686-BB1B-C4C67A99683E}"/>
+                <a16:creationId xmlns:a16="http://schemas.microsoft.com/office/drawing/2014/main" id="{B5F786ED-A818-4283-9492-06E9755640C4}"/>
               </a:ext>
             </a:extLst>
           </p:cNvPr>
@@ -15946,7 +15946,7 @@
           <p:cNvPr id="17" name="">
             <a:extLst xmlns:a="http://schemas.openxmlformats.org/drawingml/2006/main">
               <a:ext uri="{FF2B5EF4-FFF2-40B4-BE49-F238E27FC236}">
-                <a16:creationId xmlns:a16="http://schemas.microsoft.com/office/drawing/2014/main" id="{CFD5569A-42E6-4310-B301-4DFBBF338CA5}"/>
+                <a16:creationId xmlns:a16="http://schemas.microsoft.com/office/drawing/2014/main" id="{6DA94C10-E649-451D-9710-DA08EACE29E4}"/>
               </a:ext>
             </a:extLst>
           </p:cNvPr>
@@ -16002,7 +16002,7 @@
           <p:cNvPr id="18" name="">
             <a:extLst xmlns:a="http://schemas.openxmlformats.org/drawingml/2006/main">
               <a:ext uri="{FF2B5EF4-FFF2-40B4-BE49-F238E27FC236}">
-                <a16:creationId xmlns:a16="http://schemas.microsoft.com/office/drawing/2014/main" id="{7A90A311-358D-48C4-BB90-94DAB27ECFA6}"/>
+                <a16:creationId xmlns:a16="http://schemas.microsoft.com/office/drawing/2014/main" id="{6744EC17-0D31-4CAE-95EF-15A1DD45CA62}"/>
               </a:ext>
             </a:extLst>
           </p:cNvPr>
@@ -16058,7 +16058,7 @@
           <p:cNvPr id="19" name="">
             <a:extLst xmlns:a="http://schemas.openxmlformats.org/drawingml/2006/main">
               <a:ext uri="{FF2B5EF4-FFF2-40B4-BE49-F238E27FC236}">
-                <a16:creationId xmlns:a16="http://schemas.microsoft.com/office/drawing/2014/main" id="{1D63F43E-25C6-461F-AA82-11DF861F4EB2}"/>
+                <a16:creationId xmlns:a16="http://schemas.microsoft.com/office/drawing/2014/main" id="{1C14C94B-093F-412B-B73F-5816ED47CC63}"/>
               </a:ext>
             </a:extLst>
           </p:cNvPr>
@@ -16091,7 +16091,7 @@
           <p:cNvPr id="20" name="">
             <a:extLst xmlns:a="http://schemas.openxmlformats.org/drawingml/2006/main">
               <a:ext uri="{FF2B5EF4-FFF2-40B4-BE49-F238E27FC236}">
-                <a16:creationId xmlns:a16="http://schemas.microsoft.com/office/drawing/2014/main" id="{AB993E72-A241-41D3-B59D-6977D09B2E07}"/>
+                <a16:creationId xmlns:a16="http://schemas.microsoft.com/office/drawing/2014/main" id="{8E5969DC-9D4F-47A0-BF5F-42CFCF6B6679}"/>
               </a:ext>
             </a:extLst>
           </p:cNvPr>
@@ -16147,7 +16147,7 @@
           <p:cNvPr id="21" name="">
             <a:extLst xmlns:a="http://schemas.openxmlformats.org/drawingml/2006/main">
               <a:ext uri="{FF2B5EF4-FFF2-40B4-BE49-F238E27FC236}">
-                <a16:creationId xmlns:a16="http://schemas.microsoft.com/office/drawing/2014/main" id="{118205F2-BD8A-4298-BB9C-4380DDD82E31}"/>
+                <a16:creationId xmlns:a16="http://schemas.microsoft.com/office/drawing/2014/main" id="{5453AE7A-9293-4D78-8CDE-BE35F9C9E3B5}"/>
               </a:ext>
             </a:extLst>
           </p:cNvPr>
@@ -16203,7 +16203,7 @@
           <p:cNvPr id="22" name="">
             <a:extLst xmlns:a="http://schemas.openxmlformats.org/drawingml/2006/main">
               <a:ext uri="{FF2B5EF4-FFF2-40B4-BE49-F238E27FC236}">
-                <a16:creationId xmlns:a16="http://schemas.microsoft.com/office/drawing/2014/main" id="{F7B74E57-7B3F-41F6-9A7E-9665CD8DCEB9}"/>
+                <a16:creationId xmlns:a16="http://schemas.microsoft.com/office/drawing/2014/main" id="{C134E0D1-41CC-4E8B-A211-A3719E92F51E}"/>
               </a:ext>
             </a:extLst>
           </p:cNvPr>
@@ -16236,7 +16236,7 @@
           <p:cNvPr id="23" name="">
             <a:extLst xmlns:a="http://schemas.openxmlformats.org/drawingml/2006/main">
               <a:ext uri="{FF2B5EF4-FFF2-40B4-BE49-F238E27FC236}">
-                <a16:creationId xmlns:a16="http://schemas.microsoft.com/office/drawing/2014/main" id="{0C6B8E50-4C81-4E92-82A2-AA020284A4CE}"/>
+                <a16:creationId xmlns:a16="http://schemas.microsoft.com/office/drawing/2014/main" id="{2D36D2C5-13FE-40A5-9572-B0E53266134C}"/>
               </a:ext>
             </a:extLst>
           </p:cNvPr>
@@ -16269,7 +16269,7 @@
           <p:cNvPr id="24" name="">
             <a:extLst xmlns:a="http://schemas.openxmlformats.org/drawingml/2006/main">
               <a:ext uri="{FF2B5EF4-FFF2-40B4-BE49-F238E27FC236}">
-                <a16:creationId xmlns:a16="http://schemas.microsoft.com/office/drawing/2014/main" id="{CE570EFC-A205-4EC5-8DF3-6DD14F6940FF}"/>
+                <a16:creationId xmlns:a16="http://schemas.microsoft.com/office/drawing/2014/main" id="{2724A941-DDAF-44B4-AABA-6614C8E0E897}"/>
               </a:ext>
             </a:extLst>
           </p:cNvPr>
@@ -16325,7 +16325,7 @@
           <p:cNvPr id="25" name="">
             <a:extLst xmlns:a="http://schemas.openxmlformats.org/drawingml/2006/main">
               <a:ext uri="{FF2B5EF4-FFF2-40B4-BE49-F238E27FC236}">
-                <a16:creationId xmlns:a16="http://schemas.microsoft.com/office/drawing/2014/main" id="{0222F7F7-3D3C-47AD-918D-A0C3E85E4586}"/>
+                <a16:creationId xmlns:a16="http://schemas.microsoft.com/office/drawing/2014/main" id="{E0454BE4-6387-4241-9FE8-EC298B3C505D}"/>
               </a:ext>
             </a:extLst>
           </p:cNvPr>
@@ -16379,7 +16379,7 @@
     </p:spTree>
     <p:extLst>
       <p:ext uri="{BB962C8B-B14F-4D97-AF65-F5344CB8AC3E}">
-        <p14:creationId xmlns:p14="http://schemas.microsoft.com/office/powerpoint/2010/main" val="1406247635"/>
+        <p14:creationId xmlns:p14="http://schemas.microsoft.com/office/powerpoint/2010/main" val="859331965"/>
       </p:ext>
     </p:extLst>
   </p:cSld>

</xml_diff>